<commit_message>
docs: presentation covers all four tabs
Co-Authored-By: Claude Opus 5.5 <noreply@anthropic.com>
</commit_message>
<xml_diff>
--- a/docs/forth-on-cor24.pptx
+++ b/docs/forth-on-cor24.pptx
@@ -128,13 +128,13 @@
   <p:extLst>
     <p:ext uri="{521415D9-36F7-43E2-AB2F-B90AF26B5E84}">
       <p14:sectionLst xmlns:p14="http://schemas.microsoft.com/office/powerpoint/2010/main">
-        <p14:section name="Intro" id="{ed61afbc-3d93-bfb9-09d6-c9669175780e}">
+        <p14:section name="Intro" id="{a39012f4-56b8-3259-85e7-51be84849491}">
           <p14:sldIdLst>
             <p14:sldId id="256"/>
             <p14:sldId id="257"/>
           </p14:sldIdLst>
         </p14:section>
-        <p14:section name="The target" id="{61592790-3fbf-84e0-2557-5dfe5331b727}">
+        <p14:section name="The target" id="{5ddff025-cd3c-07ba-88f2-8e4ef95314d9}">
           <p14:sldIdLst>
             <p14:sldId id="258"/>
             <p14:sldId id="259"/>
@@ -143,7 +143,7 @@
             <p14:sldId id="262"/>
           </p14:sldIdLst>
         </p14:section>
-        <p14:section name="Implementations" id="{6c6d2e8e-17d0-1e1a-ea84-fa4645ead82d}">
+        <p14:section name="Implementations" id="{daccbc34-c375-50d5-d73e-86c4fd1de0bc}">
           <p14:sldIdLst>
             <p14:sldId id="263"/>
             <p14:sldId id="264"/>
@@ -156,14 +156,14 @@
             <p14:sldId id="271"/>
           </p14:sldIdLst>
         </p14:section>
-        <p14:section name="Demos" id="{6855864c-6bf8-3743-064b-448a2039f8af}">
+        <p14:section name="Demos" id="{1d37f474-3b8a-4177-7c89-3688c8f68361}">
           <p14:sldIdLst>
             <p14:sldId id="272"/>
             <p14:sldId id="273"/>
             <p14:sldId id="274"/>
           </p14:sldIdLst>
         </p14:section>
-        <p14:section name="Working with words" id="{f08c2a17-7167-5ad2-f276-ad53b34724fb}">
+        <p14:section name="Working with words" id="{11650ce8-1349-ad9c-3b82-47ccefd78af7}">
           <p14:sldIdLst>
             <p14:sldId id="275"/>
             <p14:sldId id="276"/>
@@ -574,7 +574,7 @@
           <a:p>
             <a:r>
               <a:rPr lang="en-US" dirty="0"/>
-              <a:t>Deck covers the COR24 target and its ISA limits, the three Forth implementations in sw-cor24-forth, how they compare with other Forths, the demo set in the web UI, and the everyday workflow of defining, listing, running and redefining words.</a:t>
+              <a:t>Deck covers the COR24 target and its ISA limits, the four Forth implementations in sw-cor24-forth, how they compare with other Forths, the demo set in the web UI, and the everyday workflow of defining, listing, running and redefining words.</a:t>
             </a:r>
             <a:endParaRPr lang="en-US" dirty="0"/>
           </a:p>
@@ -3278,7 +3278,7 @@
                   <a:schemeClr val="accent1"/>
                 </a:solidFill>
               </a:rPr>
-              <a:t>Forth kernels for a 24-bit soft CPU: all assembly, Forth-in-Forth, Forth on a Forth-shaped substrate, and a fourth, compiled by Forth, in progress</a:t>
+              <a:t>Four Forth kernels for a 24-bit soft CPU, from all assembly to a dictionary compiled by Forth itself</a:t>
             </a:r>
             <a:endParaRPr lang="en-US" sz="1800" dirty="0"/>
           </a:p>
@@ -3538,7 +3538,7 @@
       </p:sp>
       <p:sp>
         <p:nvSpPr>
-          <p:cNvPr id="3" name="bullets 103"/>
+          <p:cNvPr id="3" name="bullets 115"/>
           <p:cNvSpPr txBox="1"/>
           <p:nvPr/>
         </p:nvSpPr>
@@ -3704,7 +3704,7 @@
       </p:sp>
       <p:sp>
         <p:nvSpPr>
-          <p:cNvPr id="5" name="code background 104"/>
+          <p:cNvPr id="5" name="code background 116"/>
           <p:cNvSpPr/>
           <p:nvPr/>
         </p:nvSpPr>
@@ -3731,7 +3731,7 @@
       </p:sp>
       <p:sp>
         <p:nvSpPr>
-          <p:cNvPr id="6" name="code 105"/>
+          <p:cNvPr id="6" name="code 117"/>
           <p:cNvSpPr txBox="1"/>
           <p:nvPr/>
         </p:nvSpPr>
@@ -4222,7 +4222,7 @@
       </p:sp>
       <p:sp>
         <p:nvSpPr>
-          <p:cNvPr id="4" name="flow box 106"/>
+          <p:cNvPr id="4" name="flow box 118"/>
           <p:cNvSpPr/>
           <p:nvPr/>
         </p:nvSpPr>
@@ -4249,7 +4249,7 @@
       </p:sp>
       <p:sp>
         <p:nvSpPr>
-          <p:cNvPr id="5" name="flow text 107"/>
+          <p:cNvPr id="5" name="flow text 119"/>
           <p:cNvSpPr txBox="1"/>
           <p:nvPr/>
         </p:nvSpPr>
@@ -4285,7 +4285,7 @@
       </p:sp>
       <p:sp>
         <p:nvSpPr>
-          <p:cNvPr id="6" name="arrow 108"/>
+          <p:cNvPr id="6" name="arrow 120"/>
           <p:cNvSpPr/>
           <p:nvPr/>
         </p:nvSpPr>
@@ -4310,7 +4310,7 @@
       </p:sp>
       <p:sp>
         <p:nvSpPr>
-          <p:cNvPr id="7" name="arrow 109"/>
+          <p:cNvPr id="7" name="arrow 121"/>
           <p:cNvSpPr/>
           <p:nvPr/>
         </p:nvSpPr>
@@ -4335,7 +4335,7 @@
       </p:sp>
       <p:sp>
         <p:nvSpPr>
-          <p:cNvPr id="8" name="flow box 110"/>
+          <p:cNvPr id="8" name="flow box 122"/>
           <p:cNvSpPr/>
           <p:nvPr/>
         </p:nvSpPr>
@@ -4362,7 +4362,7 @@
       </p:sp>
       <p:sp>
         <p:nvSpPr>
-          <p:cNvPr id="9" name="flow text 111"/>
+          <p:cNvPr id="9" name="flow text 123"/>
           <p:cNvSpPr txBox="1"/>
           <p:nvPr/>
         </p:nvSpPr>
@@ -4426,7 +4426,7 @@
       </p:sp>
       <p:sp>
         <p:nvSpPr>
-          <p:cNvPr id="10" name="flow box 112"/>
+          <p:cNvPr id="10" name="flow box 124"/>
           <p:cNvSpPr/>
           <p:nvPr/>
         </p:nvSpPr>
@@ -4453,7 +4453,7 @@
       </p:sp>
       <p:sp>
         <p:nvSpPr>
-          <p:cNvPr id="11" name="flow text 113"/>
+          <p:cNvPr id="11" name="flow text 125"/>
           <p:cNvSpPr txBox="1"/>
           <p:nvPr/>
         </p:nvSpPr>
@@ -4503,7 +4503,7 @@
       </p:sp>
       <p:sp>
         <p:nvSpPr>
-          <p:cNvPr id="12" name="code background 114"/>
+          <p:cNvPr id="12" name="code background 126"/>
           <p:cNvSpPr/>
           <p:nvPr/>
         </p:nvSpPr>
@@ -4530,7 +4530,7 @@
       </p:sp>
       <p:sp>
         <p:nvSpPr>
-          <p:cNvPr id="13" name="code 115"/>
+          <p:cNvPr id="13" name="code 127"/>
           <p:cNvSpPr txBox="1"/>
           <p:nvPr/>
         </p:nvSpPr>
@@ -4637,7 +4637,7 @@
       </p:sp>
       <p:sp>
         <p:nvSpPr>
-          <p:cNvPr id="14" name="bullets 116"/>
+          <p:cNvPr id="14" name="bullets 128"/>
           <p:cNvSpPr txBox="1"/>
           <p:nvPr/>
         </p:nvSpPr>
@@ -4741,7 +4741,7 @@
                   <a:schemeClr val="tx1"/>
                 </a:solidFill>
               </a:rPr>
-              <a:t>Same source commit as tab 1, so the three web tabs and the SWTOS pane run the same Forth; only the host differs.</a:t>
+              <a:t>Same source commit as tab 1, so the web debugger tab and the SWTOS pane run the same Forth; only the host differs.</a:t>
             </a:r>
             <a:endParaRPr lang="en-US" sz="1100" dirty="0"/>
           </a:p>
@@ -4857,7 +4857,7 @@
       </p:sp>
       <p:sp>
         <p:nvSpPr>
-          <p:cNvPr id="3" name="flow box 117"/>
+          <p:cNvPr id="3" name="flow box 129"/>
           <p:cNvSpPr/>
           <p:nvPr/>
         </p:nvSpPr>
@@ -4884,7 +4884,7 @@
       </p:sp>
       <p:sp>
         <p:nvSpPr>
-          <p:cNvPr id="4" name="flow text 118"/>
+          <p:cNvPr id="4" name="flow text 130"/>
           <p:cNvSpPr txBox="1"/>
           <p:nvPr/>
         </p:nvSpPr>
@@ -4920,7 +4920,7 @@
       </p:sp>
       <p:sp>
         <p:nvSpPr>
-          <p:cNvPr id="5" name="tier words 119"/>
+          <p:cNvPr id="5" name="tier words 131"/>
           <p:cNvSpPr txBox="1"/>
           <p:nvPr/>
         </p:nvSpPr>
@@ -4956,7 +4956,7 @@
       </p:sp>
       <p:sp>
         <p:nvSpPr>
-          <p:cNvPr id="6" name="arrow 120"/>
+          <p:cNvPr id="6" name="arrow 132"/>
           <p:cNvSpPr/>
           <p:nvPr/>
         </p:nvSpPr>
@@ -4981,7 +4981,7 @@
       </p:sp>
       <p:sp>
         <p:nvSpPr>
-          <p:cNvPr id="7" name="flow box 121"/>
+          <p:cNvPr id="7" name="flow box 133"/>
           <p:cNvSpPr/>
           <p:nvPr/>
         </p:nvSpPr>
@@ -5008,7 +5008,7 @@
       </p:sp>
       <p:sp>
         <p:nvSpPr>
-          <p:cNvPr id="8" name="flow text 122"/>
+          <p:cNvPr id="8" name="flow text 134"/>
           <p:cNvSpPr txBox="1"/>
           <p:nvPr/>
         </p:nvSpPr>
@@ -5044,7 +5044,7 @@
       </p:sp>
       <p:sp>
         <p:nvSpPr>
-          <p:cNvPr id="9" name="tier words 123"/>
+          <p:cNvPr id="9" name="tier words 135"/>
           <p:cNvSpPr txBox="1"/>
           <p:nvPr/>
         </p:nvSpPr>
@@ -5080,7 +5080,7 @@
       </p:sp>
       <p:sp>
         <p:nvSpPr>
-          <p:cNvPr id="10" name="arrow 124"/>
+          <p:cNvPr id="10" name="arrow 136"/>
           <p:cNvSpPr/>
           <p:nvPr/>
         </p:nvSpPr>
@@ -5105,7 +5105,7 @@
       </p:sp>
       <p:sp>
         <p:nvSpPr>
-          <p:cNvPr id="11" name="flow box 125"/>
+          <p:cNvPr id="11" name="flow box 137"/>
           <p:cNvSpPr/>
           <p:nvPr/>
         </p:nvSpPr>
@@ -5132,7 +5132,7 @@
       </p:sp>
       <p:sp>
         <p:nvSpPr>
-          <p:cNvPr id="12" name="flow text 126"/>
+          <p:cNvPr id="12" name="flow text 138"/>
           <p:cNvSpPr txBox="1"/>
           <p:nvPr/>
         </p:nvSpPr>
@@ -5168,7 +5168,7 @@
       </p:sp>
       <p:sp>
         <p:nvSpPr>
-          <p:cNvPr id="13" name="tier words 127"/>
+          <p:cNvPr id="13" name="tier words 139"/>
           <p:cNvSpPr txBox="1"/>
           <p:nvPr/>
         </p:nvSpPr>
@@ -5204,7 +5204,7 @@
       </p:sp>
       <p:sp>
         <p:nvSpPr>
-          <p:cNvPr id="14" name="arrow 128"/>
+          <p:cNvPr id="14" name="arrow 140"/>
           <p:cNvSpPr/>
           <p:nvPr/>
         </p:nvSpPr>
@@ -5229,7 +5229,7 @@
       </p:sp>
       <p:sp>
         <p:nvSpPr>
-          <p:cNvPr id="15" name="flow box 129"/>
+          <p:cNvPr id="15" name="flow box 141"/>
           <p:cNvSpPr/>
           <p:nvPr/>
         </p:nvSpPr>
@@ -5256,7 +5256,7 @@
       </p:sp>
       <p:sp>
         <p:nvSpPr>
-          <p:cNvPr id="16" name="flow text 130"/>
+          <p:cNvPr id="16" name="flow text 142"/>
           <p:cNvSpPr txBox="1"/>
           <p:nvPr/>
         </p:nvSpPr>
@@ -5292,7 +5292,7 @@
       </p:sp>
       <p:sp>
         <p:nvSpPr>
-          <p:cNvPr id="17" name="tier words 131"/>
+          <p:cNvPr id="17" name="tier words 143"/>
           <p:cNvSpPr txBox="1"/>
           <p:nvPr/>
         </p:nvSpPr>
@@ -5400,7 +5400,7 @@
       </p:sp>
       <p:sp>
         <p:nvSpPr>
-          <p:cNvPr id="20" name="code background 132"/>
+          <p:cNvPr id="20" name="code background 144"/>
           <p:cNvSpPr/>
           <p:nvPr/>
         </p:nvSpPr>
@@ -5427,7 +5427,7 @@
       </p:sp>
       <p:sp>
         <p:nvSpPr>
-          <p:cNvPr id="21" name="code 133"/>
+          <p:cNvPr id="21" name="code 145"/>
           <p:cNvSpPr txBox="1"/>
           <p:nvPr/>
         </p:nvSpPr>
@@ -5517,7 +5517,7 @@
       </p:sp>
       <p:sp>
         <p:nvSpPr>
-          <p:cNvPr id="22" name="bullets 134"/>
+          <p:cNvPr id="22" name="bullets 146"/>
           <p:cNvSpPr txBox="1"/>
           <p:nvPr/>
         </p:nvSpPr>
@@ -5719,7 +5719,7 @@
       </p:sp>
       <p:graphicFrame>
         <p:nvGraphicFramePr>
-          <p:cNvPr id="14" name="table 135"/>
+          <p:cNvPr id="14" name="table 147"/>
           <p:cNvGraphicFramePr>
             <a:graphicFrameLocks noGrp="1"/>
           </p:cNvGraphicFramePr>
@@ -6811,7 +6811,7 @@
       </p:graphicFrame>
       <p:sp>
         <p:nvSpPr>
-          <p:cNvPr id="4" name="code background 136"/>
+          <p:cNvPr id="4" name="code background 148"/>
           <p:cNvSpPr/>
           <p:nvPr/>
         </p:nvSpPr>
@@ -6838,7 +6838,7 @@
       </p:sp>
       <p:sp>
         <p:nvSpPr>
-          <p:cNvPr id="5" name="code 137"/>
+          <p:cNvPr id="5" name="code 149"/>
           <p:cNvSpPr txBox="1"/>
           <p:nvPr/>
         </p:nvSpPr>
@@ -6979,7 +6979,7 @@
       </p:sp>
       <p:sp>
         <p:nvSpPr>
-          <p:cNvPr id="6" name="bullets 138"/>
+          <p:cNvPr id="6" name="bullets 150"/>
           <p:cNvSpPr txBox="1"/>
           <p:nvPr/>
         </p:nvSpPr>
@@ -7047,7 +7047,7 @@
                   <a:schemeClr val="tx1"/>
                 </a:solidFill>
               </a:rPr>
-              <a:t>Honest number: kernel.s is still 2,659 lines. The asm bootstrap must compile runtime.fth before Forth : exists, so the asm WORD / FIND / NUMBER bodies stay alive. Deleting them needs a precompiled image: that is phase 4.</a:t>
+              <a:t>kernel.s stays at 2,659 lines here: the asm bootstrap must compile runtime.fth before the Forth : exists, so the asm WORD, FIND and NUMBER stay. Tab 4 removes them by compiling the core ahead of time.</a:t>
             </a:r>
             <a:endParaRPr lang="en-US" sz="1050" dirty="0"/>
           </a:p>
@@ -7173,7 +7173,7 @@
                   <a:schemeClr val="tx1"/>
                 </a:solidFill>
               </a:rPr>
-              <a:t>forth-from-forth: the kernel as a build artifact (WIP)</a:t>
+              <a:t>forth-from-forth (tab 4): compiled by Forth</a:t>
             </a:r>
             <a:endParaRPr lang="en-US" sz="2600" dirty="0"/>
           </a:p>
@@ -7181,7 +7181,7 @@
       </p:sp>
       <p:sp>
         <p:nvSpPr>
-          <p:cNvPr id="3" name="flow box 139"/>
+          <p:cNvPr id="3" name="flow box 151"/>
           <p:cNvSpPr/>
           <p:nvPr/>
         </p:nvSpPr>
@@ -7208,7 +7208,7 @@
       </p:sp>
       <p:sp>
         <p:nvSpPr>
-          <p:cNvPr id="4" name="flow text 140"/>
+          <p:cNvPr id="4" name="flow text 152"/>
           <p:cNvSpPr txBox="1"/>
           <p:nvPr/>
         </p:nvSpPr>
@@ -7231,34 +7231,34 @@
               <a:buNone/>
             </a:pPr>
             <a:r>
-              <a:rPr lang="en-US" sz="950" dirty="0">
+              <a:rPr lang="en-US" sz="1000" dirty="0">
                 <a:solidFill>
                   <a:schemeClr val="bg1"/>
                 </a:solidFill>
               </a:rPr>
               <a:t>xcomp.fth + prims.fth</a:t>
             </a:r>
-            <a:endParaRPr lang="en-US" sz="950" dirty="0"/>
+            <a:endParaRPr lang="en-US" sz="1000" dirty="0"/>
           </a:p>
           <a:p>
             <a:pPr algn="ctr" indent="0" marL="0">
               <a:buNone/>
             </a:pPr>
             <a:r>
-              <a:rPr lang="en-US" sz="950" dirty="0">
+              <a:rPr lang="en-US" sz="1000" dirty="0">
                 <a:solidFill>
                   <a:schemeClr val="bg1"/>
                 </a:solidFill>
               </a:rPr>
               <a:t>(the compiler, in Forth)</a:t>
             </a:r>
-            <a:endParaRPr lang="en-US" sz="950" dirty="0"/>
+            <a:endParaRPr lang="en-US" sz="1000" dirty="0"/>
           </a:p>
         </p:txBody>
       </p:sp>
       <p:sp>
         <p:nvSpPr>
-          <p:cNvPr id="5" name="arrow 141"/>
+          <p:cNvPr id="5" name="arrow 153"/>
           <p:cNvSpPr/>
           <p:nvPr/>
         </p:nvSpPr>
@@ -7283,7 +7283,7 @@
       </p:sp>
       <p:sp>
         <p:nvSpPr>
-          <p:cNvPr id="6" name="flow box 142"/>
+          <p:cNvPr id="6" name="flow box 154"/>
           <p:cNvSpPr/>
           <p:nvPr/>
         </p:nvSpPr>
@@ -7310,7 +7310,7 @@
       </p:sp>
       <p:sp>
         <p:nvSpPr>
-          <p:cNvPr id="7" name="flow text 143"/>
+          <p:cNvPr id="7" name="flow text 155"/>
           <p:cNvSpPr txBox="1"/>
           <p:nvPr/>
         </p:nvSpPr>
@@ -7333,34 +7333,34 @@
               <a:buNone/>
             </a:pPr>
             <a:r>
-              <a:rPr lang="en-US" sz="950" dirty="0">
+              <a:rPr lang="en-US" sz="1000" dirty="0">
                 <a:solidFill>
                   <a:schemeClr val="bg1"/>
                 </a:solidFill>
               </a:rPr>
               <a:t>core/*.fth</a:t>
             </a:r>
-            <a:endParaRPr lang="en-US" sz="950" dirty="0"/>
+            <a:endParaRPr lang="en-US" sz="1000" dirty="0"/>
           </a:p>
           <a:p>
             <a:pPr algn="ctr" indent="0" marL="0">
               <a:buNone/>
             </a:pPr>
             <a:r>
-              <a:rPr lang="en-US" sz="950" dirty="0">
+              <a:rPr lang="en-US" sz="1000" dirty="0">
                 <a:solidFill>
                   <a:schemeClr val="bg1"/>
                 </a:solidFill>
               </a:rPr>
               <a:t>read as source</a:t>
             </a:r>
-            <a:endParaRPr lang="en-US" sz="950" dirty="0"/>
+            <a:endParaRPr lang="en-US" sz="1000" dirty="0"/>
           </a:p>
         </p:txBody>
       </p:sp>
       <p:sp>
         <p:nvSpPr>
-          <p:cNvPr id="8" name="arrow 144"/>
+          <p:cNvPr id="8" name="arrow 156"/>
           <p:cNvSpPr/>
           <p:nvPr/>
         </p:nvSpPr>
@@ -7385,7 +7385,7 @@
       </p:sp>
       <p:sp>
         <p:nvSpPr>
-          <p:cNvPr id="9" name="flow box 145"/>
+          <p:cNvPr id="9" name="flow box 157"/>
           <p:cNvSpPr/>
           <p:nvPr/>
         </p:nvSpPr>
@@ -7412,7 +7412,7 @@
       </p:sp>
       <p:sp>
         <p:nvSpPr>
-          <p:cNvPr id="10" name="flow text 146"/>
+          <p:cNvPr id="10" name="flow text 158"/>
           <p:cNvSpPr txBox="1"/>
           <p:nvPr/>
         </p:nvSpPr>
@@ -7435,34 +7435,34 @@
               <a:buNone/>
             </a:pPr>
             <a:r>
-              <a:rPr lang="en-US" sz="950" dirty="0">
+              <a:rPr lang="en-US" sz="1000" dirty="0">
                 <a:solidFill>
                   <a:schemeClr val="bg1"/>
                 </a:solidFill>
               </a:rPr>
-              <a:t>runs on the phase-3 REPL,</a:t>
-            </a:r>
-            <a:endParaRPr lang="en-US" sz="950" dirty="0"/>
+              <a:t>runs on tab 3's kernel,</a:t>
+            </a:r>
+            <a:endParaRPr lang="en-US" sz="1000" dirty="0"/>
           </a:p>
           <a:p>
             <a:pPr algn="ctr" indent="0" marL="0">
               <a:buNone/>
             </a:pPr>
             <a:r>
-              <a:rPr lang="en-US" sz="950" dirty="0">
+              <a:rPr lang="en-US" sz="1000" dirty="0">
                 <a:solidFill>
                   <a:schemeClr val="bg1"/>
                 </a:solidFill>
               </a:rPr>
               <a:t>asm text out the UART</a:t>
             </a:r>
-            <a:endParaRPr lang="en-US" sz="950" dirty="0"/>
+            <a:endParaRPr lang="en-US" sz="1000" dirty="0"/>
           </a:p>
         </p:txBody>
       </p:sp>
       <p:sp>
         <p:nvSpPr>
-          <p:cNvPr id="11" name="arrow 147"/>
+          <p:cNvPr id="11" name="arrow 159"/>
           <p:cNvSpPr/>
           <p:nvPr/>
         </p:nvSpPr>
@@ -7487,7 +7487,7 @@
       </p:sp>
       <p:sp>
         <p:nvSpPr>
-          <p:cNvPr id="12" name="flow box 148"/>
+          <p:cNvPr id="12" name="flow box 160"/>
           <p:cNvSpPr/>
           <p:nvPr/>
         </p:nvSpPr>
@@ -7514,7 +7514,7 @@
       </p:sp>
       <p:sp>
         <p:nvSpPr>
-          <p:cNvPr id="13" name="flow text 149"/>
+          <p:cNvPr id="13" name="flow text 161"/>
           <p:cNvSpPr txBox="1"/>
           <p:nvPr/>
         </p:nvSpPr>
@@ -7537,45 +7537,81 @@
               <a:buNone/>
             </a:pPr>
             <a:r>
-              <a:rPr lang="en-US" sz="950" dirty="0">
+              <a:rPr lang="en-US" sz="1000" dirty="0">
                 <a:solidFill>
                   <a:schemeClr val="bg1"/>
                 </a:solidFill>
               </a:rPr>
-              <a:t>kernel.s → cor24-asm → image boot,</a:t>
-            </a:r>
-            <a:endParaRPr lang="en-US" sz="950" dirty="0"/>
+              <a:t>kernel.s = primitives + dictionary;</a:t>
+            </a:r>
+            <a:endParaRPr lang="en-US" sz="1000" dirty="0"/>
           </a:p>
           <a:p>
             <a:pPr algn="ctr" indent="0" marL="0">
               <a:buNone/>
             </a:pPr>
             <a:r>
-              <a:rPr lang="en-US" sz="950" dirty="0">
+              <a:rPr lang="en-US" sz="1000" dirty="0">
                 <a:solidFill>
                   <a:schemeClr val="bg1"/>
                 </a:solidFill>
               </a:rPr>
-              <a:t>no UART bootstrap</a:t>
-            </a:r>
-            <a:endParaRPr lang="en-US" sz="950" dirty="0"/>
+              <a:t>boots straight into QUIT</a:t>
+            </a:r>
+            <a:endParaRPr lang="en-US" sz="1000" dirty="0"/>
           </a:p>
         </p:txBody>
       </p:sp>
       <p:sp>
         <p:nvSpPr>
-          <p:cNvPr id="14" name="code background 150"/>
+          <p:cNvPr id="14" name="emit caption"/>
+          <p:cNvSpPr txBox="1"/>
+          <p:nvPr/>
+        </p:nvSpPr>
+        <p:spPr>
+          <a:xfrm>
+            <a:off x="457200" y="1691640"/>
+            <a:ext cx="4023360" cy="274320"/>
+          </a:xfrm>
+          <a:prstGeom prst="rect">
+            <a:avLst/>
+          </a:prstGeom>
+          <a:noFill/>
+          <a:ln/>
+        </p:spPr>
+        <p:txBody>
+          <a:bodyPr wrap="square" lIns="0" tIns="0" rIns="0" bIns="0" rtlCol="0" anchor="ctr"/>
+          <a:lstStyle/>
+          <a:p>
+            <a:pPr indent="0" marL="0">
+              <a:buNone/>
+            </a:pPr>
+            <a:r>
+              <a:rPr lang="en-US" sz="1100" b="1" dirty="0">
+                <a:solidFill>
+                  <a:schemeClr val="tx1"/>
+                </a:solidFill>
+              </a:rPr>
+              <a:t>What the compiler emits for : R@ RP@ 3 + @ ;</a:t>
+            </a:r>
+            <a:endParaRPr lang="en-US" sz="1100" dirty="0"/>
+          </a:p>
+        </p:txBody>
+      </p:sp>
+      <p:sp>
+        <p:nvSpPr>
+          <p:cNvPr id="15" name="code background 162"/>
           <p:cNvSpPr/>
           <p:nvPr/>
         </p:nvSpPr>
         <p:spPr>
           <a:xfrm>
-            <a:off x="457200" y="1691640"/>
-            <a:ext cx="4023360" cy="1371600"/>
+            <a:off x="457200" y="1993392"/>
+            <a:ext cx="4023360" cy="1828800"/>
           </a:xfrm>
           <a:prstGeom prst="roundRect">
             <a:avLst>
-              <a:gd name="adj" fmla="val 5333"/>
+              <a:gd name="adj" fmla="val 4000"/>
             </a:avLst>
           </a:prstGeom>
           <a:solidFill>
@@ -7591,14 +7627,14 @@
       </p:sp>
       <p:sp>
         <p:nvSpPr>
-          <p:cNvPr id="15" name="code 151"/>
+          <p:cNvPr id="16" name="code 163"/>
           <p:cNvSpPr txBox="1"/>
           <p:nvPr/>
         </p:nvSpPr>
         <p:spPr>
           <a:xfrm>
-            <a:off x="585216" y="1764792"/>
-            <a:ext cx="3767328" cy="1225296"/>
+            <a:off x="585216" y="2066544"/>
+            <a:ext cx="3767328" cy="1682496"/>
           </a:xfrm>
           <a:prstGeom prst="rect">
             <a:avLst/>
@@ -7614,7 +7650,7 @@
               <a:buNone/>
             </a:pPr>
             <a:r>
-              <a:rPr lang="en-US" sz="900" dirty="0">
+              <a:rPr lang="en-US" sz="950" dirty="0">
                 <a:solidFill>
                   <a:schemeClr val="bg1"/>
                 </a:solidFill>
@@ -7622,16 +7658,16 @@
                 <a:ea typeface="Courier New" pitchFamily="34" charset="-122"/>
                 <a:cs typeface="Courier New" pitchFamily="34" charset="-120"/>
               </a:rPr>
-              <a:t>XC-COMPILE-TEST : FOO SP@ @ ;</a:t>
-            </a:r>
-            <a:endParaRPr lang="en-US" sz="900" dirty="0"/>
+              <a:t>fff_e5_R_64:          ; header</a:t>
+            </a:r>
+            <a:endParaRPr lang="en-US" sz="950" dirty="0"/>
           </a:p>
           <a:p>
             <a:pPr indent="0" marL="0">
               <a:buNone/>
             </a:pPr>
             <a:r>
-              <a:rPr lang="en-US" sz="900" dirty="0">
+              <a:rPr lang="en-US" sz="950" dirty="0">
                 <a:solidFill>
                   <a:schemeClr val="bg1"/>
                 </a:solidFill>
@@ -7639,16 +7675,16 @@
                 <a:ea typeface="Courier New" pitchFamily="34" charset="-122"/>
                 <a:cs typeface="Courier New" pitchFamily="34" charset="-120"/>
               </a:rPr>
-              <a:t>fff_e_1:</a:t>
-            </a:r>
-            <a:endParaRPr lang="en-US" sz="900" dirty="0"/>
+              <a:t>.word fff_e4_SWAP     ; link</a:t>
+            </a:r>
+            <a:endParaRPr lang="en-US" sz="950" dirty="0"/>
           </a:p>
           <a:p>
             <a:pPr indent="0" marL="0">
               <a:buNone/>
             </a:pPr>
             <a:r>
-              <a:rPr lang="en-US" sz="900" dirty="0">
+              <a:rPr lang="en-US" sz="950" dirty="0">
                 <a:solidFill>
                   <a:schemeClr val="bg1"/>
                 </a:solidFill>
@@ -7656,16 +7692,16 @@
                 <a:ea typeface="Courier New" pitchFamily="34" charset="-122"/>
                 <a:cs typeface="Courier New" pitchFamily="34" charset="-120"/>
               </a:rPr>
-              <a:t>.word 0</a:t>
-            </a:r>
-            <a:endParaRPr lang="en-US" sz="900" dirty="0"/>
+              <a:t>.byte 2               ; length</a:t>
+            </a:r>
+            <a:endParaRPr lang="en-US" sz="950" dirty="0"/>
           </a:p>
           <a:p>
             <a:pPr indent="0" marL="0">
               <a:buNone/>
             </a:pPr>
             <a:r>
-              <a:rPr lang="en-US" sz="900" dirty="0">
+              <a:rPr lang="en-US" sz="950" dirty="0">
                 <a:solidFill>
                   <a:schemeClr val="bg1"/>
                 </a:solidFill>
@@ -7673,16 +7709,16 @@
                 <a:ea typeface="Courier New" pitchFamily="34" charset="-122"/>
                 <a:cs typeface="Courier New" pitchFamily="34" charset="-120"/>
               </a:rPr>
-              <a:t>.byte 3</a:t>
-            </a:r>
-            <a:endParaRPr lang="en-US" sz="900" dirty="0"/>
+              <a:t>.byte 82, 64          ; "R@"</a:t>
+            </a:r>
+            <a:endParaRPr lang="en-US" sz="950" dirty="0"/>
           </a:p>
           <a:p>
             <a:pPr indent="0" marL="0">
               <a:buNone/>
             </a:pPr>
             <a:r>
-              <a:rPr lang="en-US" sz="900" dirty="0">
+              <a:rPr lang="en-US" sz="950" dirty="0">
                 <a:solidFill>
                   <a:schemeClr val="bg1"/>
                 </a:solidFill>
@@ -7690,16 +7726,16 @@
                 <a:ea typeface="Courier New" pitchFamily="34" charset="-122"/>
                 <a:cs typeface="Courier New" pitchFamily="34" charset="-120"/>
               </a:rPr>
-              <a:t>.byte 70   ; F O O ...</a:t>
-            </a:r>
-            <a:endParaRPr lang="en-US" sz="900" dirty="0"/>
+              <a:t>fff_c5_R_64:          ; CFA: far DOCOL</a:t>
+            </a:r>
+            <a:endParaRPr lang="en-US" sz="950" dirty="0"/>
           </a:p>
           <a:p>
             <a:pPr indent="0" marL="0">
               <a:buNone/>
             </a:pPr>
             <a:r>
-              <a:rPr lang="en-US" sz="900" dirty="0">
+              <a:rPr lang="en-US" sz="950" dirty="0">
                 <a:solidFill>
                   <a:schemeClr val="bg1"/>
                 </a:solidFill>
@@ -7707,16 +7743,16 @@
                 <a:ea typeface="Courier New" pitchFamily="34" charset="-122"/>
                 <a:cs typeface="Courier New" pitchFamily="34" charset="-120"/>
               </a:rPr>
-              <a:t>fff_c_1:</a:t>
-            </a:r>
-            <a:endParaRPr lang="en-US" sz="900" dirty="0"/>
+              <a:t>.byte 125, 41 / .word do_docol_far / .byte 38</a:t>
+            </a:r>
+            <a:endParaRPr lang="en-US" sz="950" dirty="0"/>
           </a:p>
           <a:p>
             <a:pPr indent="0" marL="0">
               <a:buNone/>
             </a:pPr>
             <a:r>
-              <a:rPr lang="en-US" sz="900" dirty="0">
+              <a:rPr lang="en-US" sz="950" dirty="0">
                 <a:solidFill>
                   <a:schemeClr val="bg1"/>
                 </a:solidFill>
@@ -7724,16 +7760,16 @@
                 <a:ea typeface="Courier New" pitchFamily="34" charset="-122"/>
                 <a:cs typeface="Courier New" pitchFamily="34" charset="-120"/>
               </a:rPr>
-              <a:t>.word do_docol_far   ; far CFA prelude</a:t>
-            </a:r>
-            <a:endParaRPr lang="en-US" sz="900" dirty="0"/>
+              <a:t>.word do_rp_fetch     ; body</a:t>
+            </a:r>
+            <a:endParaRPr lang="en-US" sz="950" dirty="0"/>
           </a:p>
           <a:p>
             <a:pPr indent="0" marL="0">
               <a:buNone/>
             </a:pPr>
             <a:r>
-              <a:rPr lang="en-US" sz="900" dirty="0">
+              <a:rPr lang="en-US" sz="950" dirty="0">
                 <a:solidFill>
                   <a:schemeClr val="bg1"/>
                 </a:solidFill>
@@ -7741,22 +7777,22 @@
                 <a:ea typeface="Courier New" pitchFamily="34" charset="-122"/>
                 <a:cs typeface="Courier New" pitchFamily="34" charset="-120"/>
               </a:rPr>
-              <a:t>.word do_sp_fetch  .word do_fetch  .word do_exit</a:t>
-            </a:r>
-            <a:endParaRPr lang="en-US" sz="900" dirty="0"/>
+              <a:t>.word do_lit, 3, do_plus, do_fetch, do_exit</a:t>
+            </a:r>
+            <a:endParaRPr lang="en-US" sz="950" dirty="0"/>
           </a:p>
         </p:txBody>
       </p:sp>
       <p:sp>
         <p:nvSpPr>
-          <p:cNvPr id="16" name="fff status caption"/>
+          <p:cNvPr id="17" name="fff why"/>
           <p:cNvSpPr txBox="1"/>
           <p:nvPr/>
         </p:nvSpPr>
         <p:spPr>
           <a:xfrm>
-            <a:off x="4754880" y="1691640"/>
-            <a:ext cx="3931920" cy="274320"/>
+            <a:off x="457200" y="3931920"/>
+            <a:ext cx="4023360" cy="457200"/>
           </a:xfrm>
           <a:prstGeom prst="rect">
             <a:avLst/>
@@ -7772,12 +7808,48 @@
               <a:buNone/>
             </a:pPr>
             <a:r>
+              <a:rPr lang="en-US" sz="1050" i="1" dirty="0">
+                <a:solidFill>
+                  <a:schemeClr val="accent2"/>
+                </a:solidFill>
+              </a:rPr>
+              <a:t>Retargeting to another CPU becomes a new assembly emitter, not a new kernel.</a:t>
+            </a:r>
+            <a:endParaRPr lang="en-US" sz="1050" dirty="0"/>
+          </a:p>
+        </p:txBody>
+      </p:sp>
+      <p:sp>
+        <p:nvSpPr>
+          <p:cNvPr id="18" name="fff status caption"/>
+          <p:cNvSpPr txBox="1"/>
+          <p:nvPr/>
+        </p:nvSpPr>
+        <p:spPr>
+          <a:xfrm>
+            <a:off x="4754880" y="1691640"/>
+            <a:ext cx="3931920" cy="274320"/>
+          </a:xfrm>
+          <a:prstGeom prst="rect">
+            <a:avLst/>
+          </a:prstGeom>
+          <a:noFill/>
+          <a:ln/>
+        </p:spPr>
+        <p:txBody>
+          <a:bodyPr wrap="square" lIns="0" tIns="0" rIns="0" bIns="0" rtlCol="0" anchor="ctr"/>
+          <a:lstStyle/>
+          <a:p>
+            <a:pPr indent="0" marL="0">
+              <a:buNone/>
+            </a:pPr>
+            <a:r>
               <a:rPr lang="en-US" sz="1250" b="1" dirty="0">
                 <a:solidFill>
                   <a:schemeClr val="tx1"/>
                 </a:solidFill>
               </a:rPr>
-              <a:t>Status on 2026-10-23</a:t>
+              <a:t>Shipped 2026-10-23 / 24</a:t>
             </a:r>
             <a:endParaRPr lang="en-US" sz="1250" dirty="0"/>
           </a:p>
@@ -7785,7 +7857,7 @@
       </p:sp>
       <p:sp>
         <p:nvSpPr>
-          <p:cNvPr id="17" name="bullets 152"/>
+          <p:cNvPr id="19" name="bullets 164"/>
           <p:cNvSpPr txBox="1"/>
           <p:nvPr/>
         </p:nvSpPr>
@@ -7817,7 +7889,7 @@
                   <a:schemeClr val="tx1"/>
                 </a:solidFill>
               </a:rPr>
-              <a:t>Works: the compiler emits the whole runtime.fth tier (DUP through :, ;) and a self-test image runs that dictionary.</a:t>
+              <a:t>All five core tiers compile from source: 83 definitions, each identical in SEE form to what tab 3 compiles at boot, and they run when linked.</a:t>
             </a:r>
             <a:endParaRPr lang="en-US" sz="1000" dirty="0"/>
           </a:p>
@@ -7835,7 +7907,7 @@
                   <a:schemeClr val="tx1"/>
                 </a:solidFill>
               </a:rPr>
-              <a:t>Was stuck since April: compiling a definition from source died right after the begin marker. Found today: the phase-3 Forth NUMBER read its sign byte from the wrong cell, so every -1 in the compiler became a ? and a missing stack item. With that fixed, : FOO SP@ @ ; compiles from source (left).</a:t>
+              <a:t>Boot: first output after 0.71 M instructions against 149.56 M for tab 3, which streams and compiles its core first.</a:t>
             </a:r>
             <a:endParaRPr lang="en-US" sz="1000" dirty="0"/>
           </a:p>
@@ -7853,7 +7925,7 @@
                   <a:schemeClr val="tx1"/>
                 </a:solidFill>
               </a:rPr>
-              <a:t>Not yet: the other four tiers, the primitive declarations, an _start that boots from the image, deleting the asm bootstrap. kernel.s is still a copy of forth-on-forthish.</a:t>
+              <a:t>A reachability pass removes the asm bootstrap (INTERPRET, QUIT, NUMBER, WORD, FIND, : ; [']): 9,450 → 8,168 bytes.</a:t>
             </a:r>
             <a:endParaRPr lang="en-US" sz="1000" dirty="0"/>
           </a:p>
@@ -7871,45 +7943,27 @@
                   <a:schemeClr val="tx1"/>
                 </a:solidFill>
               </a:rPr>
-              <a:t>Tracked as saga phase-4-tab-4: eight steps ending in a fourth web tab, a blog brief and this deck updated.</a:t>
+              <a:t>Unblocked by a one-cell bug: tab 3's Forth NUMBER read the minus sign from the wrong cell, so every -1 in the compiler vanished.</a:t>
             </a:r>
             <a:endParaRPr lang="en-US" sz="1000" dirty="0"/>
           </a:p>
-        </p:txBody>
-      </p:sp>
-      <p:sp>
-        <p:nvSpPr>
-          <p:cNvPr id="18" name="fff why"/>
-          <p:cNvSpPr txBox="1"/>
-          <p:nvPr/>
-        </p:nvSpPr>
-        <p:spPr>
-          <a:xfrm>
-            <a:off x="457200" y="3200400"/>
-            <a:ext cx="4023360" cy="1463040"/>
-          </a:xfrm>
-          <a:prstGeom prst="rect">
-            <a:avLst/>
-          </a:prstGeom>
-          <a:noFill/>
-          <a:ln/>
-        </p:spPr>
-        <p:txBody>
-          <a:bodyPr wrap="square" lIns="0" tIns="0" rIns="0" bIns="0" rtlCol="0" anchor="ctr"/>
-          <a:lstStyle/>
-          <a:p>
-            <a:pPr indent="0" marL="0">
-              <a:buNone/>
-            </a:pPr>
-            <a:r>
-              <a:rPr lang="en-US" sz="1050" i="1" dirty="0">
-                <a:solidFill>
-                  <a:schemeClr val="accent2"/>
-                </a:solidFill>
-              </a:rPr>
-              <a:t>Why bother: no hand-written assembly left; retargeting to another CPU means a new asm-emit module, not a new kernel. The April blog posts (Rabbit-hole parts 2 to 5) planned this: FIND's hash goes away, forward references become linker-style fixups.</a:t>
-            </a:r>
-            <a:endParaRPr lang="en-US" sz="1050" dirty="0"/>
+          <a:p>
+            <a:pPr marL="342900" indent="-342900">
+              <a:spcAft>
+                <a:spcPts val="500"/>
+              </a:spcAft>
+              <a:buSzPct val="100000"/>
+              <a:buChar char="•"/>
+            </a:pPr>
+            <a:r>
+              <a:rPr lang="en-US" sz="1000" dirty="0">
+                <a:solidFill>
+                  <a:schemeClr val="tx1"/>
+                </a:solidFill>
+              </a:rPr>
+              <a:t>Next: the primitives themselves from core/prims.fth.</a:t>
+            </a:r>
+            <a:endParaRPr lang="en-US" sz="1000" dirty="0"/>
           </a:p>
         </p:txBody>
       </p:sp>
@@ -8015,7 +8069,7 @@
                   <a:schemeClr val="tx1"/>
                 </a:solidFill>
               </a:rPr>
-              <a:t>Boot: one kernel binary, then a stream of text</a:t>
+              <a:t>Boot: a stream of core text, or none at all</a:t>
             </a:r>
             <a:endParaRPr lang="en-US" sz="2600" dirty="0"/>
           </a:p>
@@ -8023,7 +8077,7 @@
       </p:sp>
       <p:sp>
         <p:nvSpPr>
-          <p:cNvPr id="3" name="flow box 153"/>
+          <p:cNvPr id="3" name="flow box 165"/>
           <p:cNvSpPr/>
           <p:nvPr/>
         </p:nvSpPr>
@@ -8050,7 +8104,7 @@
       </p:sp>
       <p:sp>
         <p:nvSpPr>
-          <p:cNvPr id="4" name="flow text 154"/>
+          <p:cNvPr id="4" name="flow text 166"/>
           <p:cNvSpPr txBox="1"/>
           <p:nvPr/>
         </p:nvSpPr>
@@ -8100,7 +8154,7 @@
       </p:sp>
       <p:sp>
         <p:nvSpPr>
-          <p:cNvPr id="5" name="arrow 155"/>
+          <p:cNvPr id="5" name="arrow 167"/>
           <p:cNvSpPr/>
           <p:nvPr/>
         </p:nvSpPr>
@@ -8125,7 +8179,7 @@
       </p:sp>
       <p:sp>
         <p:nvSpPr>
-          <p:cNvPr id="6" name="flow box 156"/>
+          <p:cNvPr id="6" name="flow box 168"/>
           <p:cNvSpPr/>
           <p:nvPr/>
         </p:nvSpPr>
@@ -8152,7 +8206,7 @@
       </p:sp>
       <p:sp>
         <p:nvSpPr>
-          <p:cNvPr id="7" name="flow text 157"/>
+          <p:cNvPr id="7" name="flow text 169"/>
           <p:cNvSpPr txBox="1"/>
           <p:nvPr/>
         </p:nvSpPr>
@@ -8202,7 +8256,7 @@
       </p:sp>
       <p:sp>
         <p:nvSpPr>
-          <p:cNvPr id="8" name="arrow 158"/>
+          <p:cNvPr id="8" name="arrow 170"/>
           <p:cNvSpPr/>
           <p:nvPr/>
         </p:nvSpPr>
@@ -8227,7 +8281,7 @@
       </p:sp>
       <p:sp>
         <p:nvSpPr>
-          <p:cNvPr id="9" name="flow box 159"/>
+          <p:cNvPr id="9" name="flow box 171"/>
           <p:cNvSpPr/>
           <p:nvPr/>
         </p:nvSpPr>
@@ -8254,7 +8308,7 @@
       </p:sp>
       <p:sp>
         <p:nvSpPr>
-          <p:cNvPr id="10" name="flow text 160"/>
+          <p:cNvPr id="10" name="flow text 172"/>
           <p:cNvSpPr txBox="1"/>
           <p:nvPr/>
         </p:nvSpPr>
@@ -8304,7 +8358,7 @@
       </p:sp>
       <p:sp>
         <p:nvSpPr>
-          <p:cNvPr id="11" name="arrow 161"/>
+          <p:cNvPr id="11" name="arrow 173"/>
           <p:cNvSpPr/>
           <p:nvPr/>
         </p:nvSpPr>
@@ -8329,7 +8383,7 @@
       </p:sp>
       <p:sp>
         <p:nvSpPr>
-          <p:cNvPr id="12" name="flow box 162"/>
+          <p:cNvPr id="12" name="flow box 174"/>
           <p:cNvSpPr/>
           <p:nvPr/>
         </p:nvSpPr>
@@ -8356,7 +8410,7 @@
       </p:sp>
       <p:sp>
         <p:nvSpPr>
-          <p:cNvPr id="13" name="flow text 163"/>
+          <p:cNvPr id="13" name="flow text 175"/>
           <p:cNvSpPr txBox="1"/>
           <p:nvPr/>
         </p:nvSpPr>
@@ -8392,7 +8446,7 @@
       </p:sp>
       <p:sp>
         <p:nvSpPr>
-          <p:cNvPr id="14" name="arrow 164"/>
+          <p:cNvPr id="14" name="arrow 176"/>
           <p:cNvSpPr/>
           <p:nvPr/>
         </p:nvSpPr>
@@ -8417,7 +8471,7 @@
       </p:sp>
       <p:sp>
         <p:nvSpPr>
-          <p:cNvPr id="15" name="flow box 165"/>
+          <p:cNvPr id="15" name="flow box 177"/>
           <p:cNvSpPr/>
           <p:nvPr/>
         </p:nvSpPr>
@@ -8444,7 +8498,7 @@
       </p:sp>
       <p:sp>
         <p:nvSpPr>
-          <p:cNvPr id="16" name="flow text 166"/>
+          <p:cNvPr id="16" name="flow text 178"/>
           <p:cNvSpPr txBox="1"/>
           <p:nvPr/>
         </p:nvSpPr>
@@ -8522,7 +8576,7 @@
                   <a:schemeClr val="tx1"/>
                 </a:solidFill>
               </a:rPr>
-              <a:t>Tab 1 sends no core files and is interactive at once. Tab 2 streams four tiers, tab 3 five. The same bytes work on the CLI:</a:t>
+              <a:t>Tab 1 has no core files; tab 2 streams four tiers, tab 3 five; tab 4 none, its core is compiled in. CLI:</a:t>
             </a:r>
             <a:endParaRPr lang="en-US" sz="1150" dirty="0"/>
           </a:p>
@@ -8530,7 +8584,7 @@
       </p:sp>
       <p:sp>
         <p:nvSpPr>
-          <p:cNvPr id="18" name="code background 167"/>
+          <p:cNvPr id="18" name="code background 179"/>
           <p:cNvSpPr/>
           <p:nvPr/>
         </p:nvSpPr>
@@ -8557,7 +8611,7 @@
       </p:sp>
       <p:sp>
         <p:nvSpPr>
-          <p:cNvPr id="19" name="code 168"/>
+          <p:cNvPr id="19" name="code 180"/>
           <p:cNvSpPr txBox="1"/>
           <p:nvPr/>
         </p:nvSpPr>
@@ -8630,7 +8684,7 @@
       </p:sp>
       <p:sp>
         <p:nvSpPr>
-          <p:cNvPr id="20" name="bullets 169"/>
+          <p:cNvPr id="20" name="bullets 181"/>
           <p:cNvSpPr txBox="1"/>
           <p:nvPr/>
         </p:nvSpPr>
@@ -8680,7 +8734,7 @@
                   <a:schemeClr val="tx1"/>
                 </a:solidFill>
               </a:rPr>
-              <a:t>Those poll-loop labels are the one thing a new kernel must register; a headless test boots all three kernels through the pump to catch a missing one.</a:t>
+              <a:t>Those poll-loop labels are the one thing a new kernel must register; a headless test boots all four kernels through the pump, with a watchdog, to catch a missing one.</a:t>
             </a:r>
             <a:endParaRPr lang="en-US" sz="1050" dirty="0"/>
           </a:p>
@@ -8688,7 +8742,7 @@
       </p:sp>
       <p:graphicFrame>
         <p:nvGraphicFramePr>
-          <p:cNvPr id="16" name="table 170"/>
+          <p:cNvPr id="16" name="table 182"/>
           <p:cNvGraphicFramePr>
             <a:graphicFrameLocks noGrp="1"/>
           </p:cNvGraphicFramePr>
@@ -8709,9 +8763,9 @@
             <a:tbl>
               <a:tblPr/>
               <a:tblGrid>
-                <a:gridCol w="1371600"/>
-                <a:gridCol w="1005840"/>
-                <a:gridCol w="1554480"/>
+                <a:gridCol w="1417320"/>
+                <a:gridCol w="1051560"/>
+                <a:gridCol w="1463040"/>
               </a:tblGrid>
               <a:tr h="274320">
                 <a:tc>
@@ -8731,7 +8785,7 @@
                           <a:ea typeface="Calibri" pitchFamily="34" charset="-122"/>
                           <a:cs typeface="Calibri" pitchFamily="34" charset="-120"/>
                         </a:rPr>
-                        <a:t>Fibonacci demo</a:t>
+                        <a:t>Kernel</a:t>
                       </a:r>
                       <a:endParaRPr lang="en-US" sz="1000" dirty="0">
                         <a:latin typeface="Calibri" charset="0"/>
@@ -8799,7 +8853,7 @@
                           <a:ea typeface="Calibri" pitchFamily="34" charset="-122"/>
                           <a:cs typeface="Calibri" pitchFamily="34" charset="-120"/>
                         </a:rPr>
-                        <a:t>Instructions</a:t>
+                        <a:t>First output at</a:t>
                       </a:r>
                       <a:endParaRPr lang="en-US" sz="1000" dirty="0">
                         <a:latin typeface="Calibri" charset="0"/>
@@ -8867,7 +8921,7 @@
                           <a:ea typeface="Calibri" pitchFamily="34" charset="-122"/>
                           <a:cs typeface="Calibri" pitchFamily="34" charset="-120"/>
                         </a:rPr>
-                        <a:t>Why</a:t>
+                        <a:t>Core arrives</a:t>
                       </a:r>
                       <a:endParaRPr lang="en-US" sz="1000" dirty="0">
                         <a:latin typeface="Calibri" charset="0"/>
@@ -9002,7 +9056,7 @@
                           <a:ea typeface="Calibri" pitchFamily="34" charset="-122"/>
                           <a:cs typeface="Calibri" pitchFamily="34" charset="-120"/>
                         </a:rPr>
-                        <a:t>~40 M</a:t>
+                        <a:t>80 k</a:t>
                       </a:r>
                       <a:endParaRPr lang="en-US" sz="1000" dirty="0">
                         <a:latin typeface="Calibri" charset="0"/>
@@ -9067,7 +9121,204 @@
                           <a:ea typeface="Calibri" pitchFamily="34" charset="-122"/>
                           <a:cs typeface="Calibri" pitchFamily="34" charset="-120"/>
                         </a:rPr>
-                        <a:t>everything native</a:t>
+                        <a:t>all assembly</a:t>
+                      </a:r>
+                      <a:endParaRPr lang="en-US" sz="1000" dirty="0">
+                        <a:latin typeface="Calibri" charset="0"/>
+                        <a:ea typeface="Calibri" charset="0"/>
+                        <a:cs typeface="Calibri" charset="0"/>
+                      </a:endParaRPr>
+                    </a:p>
+                  </a:txBody>
+                  <a:tcPr marL="45720" marR="45720" marT="45720" marB="45720" anchor="ctr">
+                    <a:lnL w="6350" cap="flat" cmpd="sng" algn="ctr">
+                      <a:solidFill>
+                        <a:srgbClr val="D5DCE1"/>
+                      </a:solidFill>
+                      <a:prstDash val="solid"/>
+                      <a:round/>
+                      <a:headEnd type="none" w="med" len="med"/>
+                      <a:tailEnd type="none" w="med" len="med"/>
+                    </a:lnL>
+                    <a:lnR w="6350" cap="flat" cmpd="sng" algn="ctr">
+                      <a:solidFill>
+                        <a:srgbClr val="D5DCE1"/>
+                      </a:solidFill>
+                      <a:prstDash val="solid"/>
+                      <a:round/>
+                      <a:headEnd type="none" w="med" len="med"/>
+                      <a:tailEnd type="none" w="med" len="med"/>
+                    </a:lnR>
+                    <a:lnT w="6350" cap="flat" cmpd="sng" algn="ctr">
+                      <a:solidFill>
+                        <a:srgbClr val="D5DCE1"/>
+                      </a:solidFill>
+                      <a:prstDash val="solid"/>
+                      <a:round/>
+                      <a:headEnd type="none" w="med" len="med"/>
+                      <a:tailEnd type="none" w="med" len="med"/>
+                    </a:lnT>
+                    <a:lnB w="6350" cap="flat" cmpd="sng" algn="ctr">
+                      <a:solidFill>
+                        <a:srgbClr val="D5DCE1"/>
+                      </a:solidFill>
+                      <a:prstDash val="solid"/>
+                      <a:round/>
+                      <a:headEnd type="none" w="med" len="med"/>
+                      <a:tailEnd type="none" w="med" len="med"/>
+                    </a:lnB>
+                  </a:tcPr>
+                </a:tc>
+              </a:tr>
+              <a:tr h="274320">
+                <a:tc>
+                  <a:txBody>
+                    <a:bodyPr/>
+                    <a:lstStyle/>
+                    <a:p>
+                      <a:pPr indent="0" marL="0">
+                        <a:buNone/>
+                      </a:pPr>
+                      <a:r>
+                        <a:rPr lang="en-US" sz="1000" b="1" dirty="0">
+                          <a:solidFill>
+                            <a:schemeClr val="tx1"/>
+                          </a:solidFill>
+                          <a:latin typeface="Calibri" pitchFamily="34" charset="0"/>
+                          <a:ea typeface="Calibri" pitchFamily="34" charset="-122"/>
+                          <a:cs typeface="Calibri" pitchFamily="34" charset="-120"/>
+                        </a:rPr>
+                        <a:t>forth-from-forth</a:t>
+                      </a:r>
+                      <a:endParaRPr lang="en-US" sz="1000" dirty="0">
+                        <a:latin typeface="Calibri" charset="0"/>
+                        <a:ea typeface="Calibri" charset="0"/>
+                        <a:cs typeface="Calibri" charset="0"/>
+                      </a:endParaRPr>
+                    </a:p>
+                  </a:txBody>
+                  <a:tcPr marL="45720" marR="45720" marT="45720" marB="45720" anchor="ctr">
+                    <a:lnL w="6350" cap="flat" cmpd="sng" algn="ctr">
+                      <a:solidFill>
+                        <a:srgbClr val="D5DCE1"/>
+                      </a:solidFill>
+                      <a:prstDash val="solid"/>
+                      <a:round/>
+                      <a:headEnd type="none" w="med" len="med"/>
+                      <a:tailEnd type="none" w="med" len="med"/>
+                    </a:lnL>
+                    <a:lnR w="6350" cap="flat" cmpd="sng" algn="ctr">
+                      <a:solidFill>
+                        <a:srgbClr val="D5DCE1"/>
+                      </a:solidFill>
+                      <a:prstDash val="solid"/>
+                      <a:round/>
+                      <a:headEnd type="none" w="med" len="med"/>
+                      <a:tailEnd type="none" w="med" len="med"/>
+                    </a:lnR>
+                    <a:lnT w="6350" cap="flat" cmpd="sng" algn="ctr">
+                      <a:solidFill>
+                        <a:srgbClr val="D5DCE1"/>
+                      </a:solidFill>
+                      <a:prstDash val="solid"/>
+                      <a:round/>
+                      <a:headEnd type="none" w="med" len="med"/>
+                      <a:tailEnd type="none" w="med" len="med"/>
+                    </a:lnT>
+                    <a:lnB w="6350" cap="flat" cmpd="sng" algn="ctr">
+                      <a:solidFill>
+                        <a:srgbClr val="D5DCE1"/>
+                      </a:solidFill>
+                      <a:prstDash val="solid"/>
+                      <a:round/>
+                      <a:headEnd type="none" w="med" len="med"/>
+                      <a:tailEnd type="none" w="med" len="med"/>
+                    </a:lnB>
+                  </a:tcPr>
+                </a:tc>
+                <a:tc>
+                  <a:txBody>
+                    <a:bodyPr/>
+                    <a:lstStyle/>
+                    <a:p>
+                      <a:pPr indent="0" marL="0">
+                        <a:buNone/>
+                      </a:pPr>
+                      <a:r>
+                        <a:rPr lang="en-US" sz="1000" dirty="0">
+                          <a:solidFill>
+                            <a:schemeClr val="tx1"/>
+                          </a:solidFill>
+                          <a:latin typeface="Calibri" pitchFamily="34" charset="0"/>
+                          <a:ea typeface="Calibri" pitchFamily="34" charset="-122"/>
+                          <a:cs typeface="Calibri" pitchFamily="34" charset="-120"/>
+                        </a:rPr>
+                        <a:t>0.71 M</a:t>
+                      </a:r>
+                      <a:endParaRPr lang="en-US" sz="1000" dirty="0">
+                        <a:latin typeface="Calibri" charset="0"/>
+                        <a:ea typeface="Calibri" charset="0"/>
+                        <a:cs typeface="Calibri" charset="0"/>
+                      </a:endParaRPr>
+                    </a:p>
+                  </a:txBody>
+                  <a:tcPr marL="45720" marR="45720" marT="45720" marB="45720" anchor="ctr">
+                    <a:lnL w="6350" cap="flat" cmpd="sng" algn="ctr">
+                      <a:solidFill>
+                        <a:srgbClr val="D5DCE1"/>
+                      </a:solidFill>
+                      <a:prstDash val="solid"/>
+                      <a:round/>
+                      <a:headEnd type="none" w="med" len="med"/>
+                      <a:tailEnd type="none" w="med" len="med"/>
+                    </a:lnL>
+                    <a:lnR w="6350" cap="flat" cmpd="sng" algn="ctr">
+                      <a:solidFill>
+                        <a:srgbClr val="D5DCE1"/>
+                      </a:solidFill>
+                      <a:prstDash val="solid"/>
+                      <a:round/>
+                      <a:headEnd type="none" w="med" len="med"/>
+                      <a:tailEnd type="none" w="med" len="med"/>
+                    </a:lnR>
+                    <a:lnT w="6350" cap="flat" cmpd="sng" algn="ctr">
+                      <a:solidFill>
+                        <a:srgbClr val="D5DCE1"/>
+                      </a:solidFill>
+                      <a:prstDash val="solid"/>
+                      <a:round/>
+                      <a:headEnd type="none" w="med" len="med"/>
+                      <a:tailEnd type="none" w="med" len="med"/>
+                    </a:lnT>
+                    <a:lnB w="6350" cap="flat" cmpd="sng" algn="ctr">
+                      <a:solidFill>
+                        <a:srgbClr val="D5DCE1"/>
+                      </a:solidFill>
+                      <a:prstDash val="solid"/>
+                      <a:round/>
+                      <a:headEnd type="none" w="med" len="med"/>
+                      <a:tailEnd type="none" w="med" len="med"/>
+                    </a:lnB>
+                  </a:tcPr>
+                </a:tc>
+                <a:tc>
+                  <a:txBody>
+                    <a:bodyPr/>
+                    <a:lstStyle/>
+                    <a:p>
+                      <a:pPr indent="0" marL="0">
+                        <a:buNone/>
+                      </a:pPr>
+                      <a:r>
+                        <a:rPr lang="en-US" sz="1000" dirty="0">
+                          <a:solidFill>
+                            <a:schemeClr val="tx1"/>
+                          </a:solidFill>
+                          <a:latin typeface="Calibri" pitchFamily="34" charset="0"/>
+                          <a:ea typeface="Calibri" pitchFamily="34" charset="-122"/>
+                          <a:cs typeface="Calibri" pitchFamily="34" charset="-120"/>
+                        </a:rPr>
+                        <a:t>compiled into the image</a:t>
                       </a:r>
                       <a:endParaRPr lang="en-US" sz="1000" dirty="0">
                         <a:latin typeface="Calibri" charset="0"/>
@@ -9199,7 +9450,7 @@
                           <a:ea typeface="Calibri" pitchFamily="34" charset="-122"/>
                           <a:cs typeface="Calibri" pitchFamily="34" charset="-120"/>
                         </a:rPr>
-                        <a:t>~120 M</a:t>
+                        <a:t>87 M</a:t>
                       </a:r>
                       <a:endParaRPr lang="en-US" sz="1000" dirty="0">
                         <a:latin typeface="Calibri" charset="0"/>
@@ -9264,7 +9515,7 @@
                           <a:ea typeface="Calibri" pitchFamily="34" charset="-122"/>
                           <a:cs typeface="Calibri" pitchFamily="34" charset="-120"/>
                         </a:rPr>
-                        <a:t>IF / UNTIL compile as threaded code</a:t>
+                        <a:t>4 tiers over the UART</a:t>
                       </a:r>
                       <a:endParaRPr lang="en-US" sz="1000" dirty="0">
                         <a:latin typeface="Calibri" charset="0"/>
@@ -9396,7 +9647,7 @@
                           <a:ea typeface="Calibri" pitchFamily="34" charset="-122"/>
                           <a:cs typeface="Calibri" pitchFamily="34" charset="-120"/>
                         </a:rPr>
-                        <a:t>~800 M budget</a:t>
+                        <a:t>150 M</a:t>
                       </a:r>
                       <a:endParaRPr lang="en-US" sz="1000" dirty="0">
                         <a:latin typeface="Calibri" charset="0"/>
@@ -9461,7 +9712,7 @@
                           <a:ea typeface="Calibri" pitchFamily="34" charset="-122"/>
                           <a:cs typeface="Calibri" pitchFamily="34" charset="-120"/>
                         </a:rPr>
-                        <a:t>WORD / FIND / NUMBER and stack ops in Forth</a:t>
+                        <a:t>5 tiers over the UART</a:t>
                       </a:r>
                       <a:endParaRPr lang="en-US" sz="1000" dirty="0">
                         <a:latin typeface="Calibri" charset="0"/>
@@ -9616,7 +9867,7 @@
                   <a:schemeClr val="tx1"/>
                 </a:solidFill>
               </a:rPr>
-              <a:t>Trade-offs between the three</a:t>
+              <a:t>Trade-offs between the four</a:t>
             </a:r>
             <a:endParaRPr lang="en-US" sz="2600" dirty="0"/>
           </a:p>
@@ -9624,7 +9875,7 @@
       </p:sp>
       <p:graphicFrame>
         <p:nvGraphicFramePr>
-          <p:cNvPr id="17" name="table 171"/>
+          <p:cNvPr id="17" name="table 183"/>
           <p:cNvGraphicFramePr>
             <a:graphicFrameLocks noGrp="1"/>
           </p:cNvGraphicFramePr>
@@ -9645,12 +9896,13 @@
             <a:tbl>
               <a:tblPr/>
               <a:tblGrid>
-                <a:gridCol w="1554480"/>
-                <a:gridCol w="2103120"/>
-                <a:gridCol w="2194560"/>
-                <a:gridCol w="2377440"/>
+                <a:gridCol w="1280160"/>
+                <a:gridCol w="1691640"/>
+                <a:gridCol w="1691640"/>
+                <a:gridCol w="1783080"/>
+                <a:gridCol w="1783080"/>
               </a:tblGrid>
-              <a:tr h="384048">
+              <a:tr h="457200">
                 <a:tc>
                   <a:txBody>
                     <a:bodyPr/>
@@ -9912,8 +10164,76 @@
                     </a:solidFill>
                   </a:tcPr>
                 </a:tc>
+                <a:tc>
+                  <a:txBody>
+                    <a:bodyPr/>
+                    <a:lstStyle/>
+                    <a:p>
+                      <a:pPr indent="0" marL="0">
+                        <a:buNone/>
+                      </a:pPr>
+                      <a:r>
+                        <a:rPr lang="en-US" sz="1000" b="1" dirty="0">
+                          <a:solidFill>
+                            <a:schemeClr val="bg1"/>
+                          </a:solidFill>
+                          <a:latin typeface="Calibri" pitchFamily="34" charset="0"/>
+                          <a:ea typeface="Calibri" pitchFamily="34" charset="-122"/>
+                          <a:cs typeface="Calibri" pitchFamily="34" charset="-120"/>
+                        </a:rPr>
+                        <a:t>forth-from-forth</a:t>
+                      </a:r>
+                      <a:endParaRPr lang="en-US" sz="1000" dirty="0">
+                        <a:latin typeface="Calibri" charset="0"/>
+                        <a:ea typeface="Calibri" charset="0"/>
+                        <a:cs typeface="Calibri" charset="0"/>
+                      </a:endParaRPr>
+                    </a:p>
+                  </a:txBody>
+                  <a:tcPr marL="45720" marR="45720" marT="45720" marB="45720" anchor="ctr">
+                    <a:lnL w="6350" cap="flat" cmpd="sng" algn="ctr">
+                      <a:solidFill>
+                        <a:srgbClr val="D5DCE1"/>
+                      </a:solidFill>
+                      <a:prstDash val="solid"/>
+                      <a:round/>
+                      <a:headEnd type="none" w="med" len="med"/>
+                      <a:tailEnd type="none" w="med" len="med"/>
+                    </a:lnL>
+                    <a:lnR w="6350" cap="flat" cmpd="sng" algn="ctr">
+                      <a:solidFill>
+                        <a:srgbClr val="D5DCE1"/>
+                      </a:solidFill>
+                      <a:prstDash val="solid"/>
+                      <a:round/>
+                      <a:headEnd type="none" w="med" len="med"/>
+                      <a:tailEnd type="none" w="med" len="med"/>
+                    </a:lnR>
+                    <a:lnT w="6350" cap="flat" cmpd="sng" algn="ctr">
+                      <a:solidFill>
+                        <a:srgbClr val="D5DCE1"/>
+                      </a:solidFill>
+                      <a:prstDash val="solid"/>
+                      <a:round/>
+                      <a:headEnd type="none" w="med" len="med"/>
+                      <a:tailEnd type="none" w="med" len="med"/>
+                    </a:lnT>
+                    <a:lnB w="6350" cap="flat" cmpd="sng" algn="ctr">
+                      <a:solidFill>
+                        <a:srgbClr val="D5DCE1"/>
+                      </a:solidFill>
+                      <a:prstDash val="solid"/>
+                      <a:round/>
+                      <a:headEnd type="none" w="med" len="med"/>
+                      <a:tailEnd type="none" w="med" len="med"/>
+                    </a:lnB>
+                    <a:solidFill>
+                      <a:schemeClr val="tx2"/>
+                    </a:solidFill>
+                  </a:tcPr>
+                </a:tc>
               </a:tr>
-              <a:tr h="384048">
+              <a:tr h="457200">
                 <a:tc>
                   <a:txBody>
                     <a:bodyPr/>
@@ -9996,7 +10316,7 @@
                           <a:ea typeface="Calibri" pitchFamily="34" charset="-122"/>
                           <a:cs typeface="Calibri" pitchFamily="34" charset="-120"/>
                         </a:rPr>
-                        <a:t>fastest; compile and run native</a:t>
+                        <a:t>fastest; native compile and run</a:t>
                       </a:r>
                       <a:endParaRPr lang="en-US" sz="1000" dirty="0">
                         <a:latin typeface="Calibri" charset="0"/>
@@ -10126,7 +10446,7 @@
                           <a:ea typeface="Calibri" pitchFamily="34" charset="-122"/>
                           <a:cs typeface="Calibri" pitchFamily="34" charset="-120"/>
                         </a:rPr>
-                        <a:t>everything through Forth; ~20× the budget</a:t>
+                        <a:t>everything through Forth</a:t>
                       </a:r>
                       <a:endParaRPr lang="en-US" sz="1000" dirty="0">
                         <a:latin typeface="Calibri" charset="0"/>
@@ -10174,8 +10494,73 @@
                     </a:lnB>
                   </a:tcPr>
                 </a:tc>
+                <a:tc>
+                  <a:txBody>
+                    <a:bodyPr/>
+                    <a:lstStyle/>
+                    <a:p>
+                      <a:pPr indent="0" marL="0">
+                        <a:buNone/>
+                      </a:pPr>
+                      <a:r>
+                        <a:rPr lang="en-US" sz="1000" dirty="0">
+                          <a:solidFill>
+                            <a:schemeClr val="tx1"/>
+                          </a:solidFill>
+                          <a:latin typeface="Calibri" pitchFamily="34" charset="0"/>
+                          <a:ea typeface="Calibri" pitchFamily="34" charset="-122"/>
+                          <a:cs typeface="Calibri" pitchFamily="34" charset="-120"/>
+                        </a:rPr>
+                        <a:t>as tab 3, but boot ~200× less work</a:t>
+                      </a:r>
+                      <a:endParaRPr lang="en-US" sz="1000" dirty="0">
+                        <a:latin typeface="Calibri" charset="0"/>
+                        <a:ea typeface="Calibri" charset="0"/>
+                        <a:cs typeface="Calibri" charset="0"/>
+                      </a:endParaRPr>
+                    </a:p>
+                  </a:txBody>
+                  <a:tcPr marL="45720" marR="45720" marT="45720" marB="45720" anchor="ctr">
+                    <a:lnL w="6350" cap="flat" cmpd="sng" algn="ctr">
+                      <a:solidFill>
+                        <a:srgbClr val="D5DCE1"/>
+                      </a:solidFill>
+                      <a:prstDash val="solid"/>
+                      <a:round/>
+                      <a:headEnd type="none" w="med" len="med"/>
+                      <a:tailEnd type="none" w="med" len="med"/>
+                    </a:lnL>
+                    <a:lnR w="6350" cap="flat" cmpd="sng" algn="ctr">
+                      <a:solidFill>
+                        <a:srgbClr val="D5DCE1"/>
+                      </a:solidFill>
+                      <a:prstDash val="solid"/>
+                      <a:round/>
+                      <a:headEnd type="none" w="med" len="med"/>
+                      <a:tailEnd type="none" w="med" len="med"/>
+                    </a:lnR>
+                    <a:lnT w="6350" cap="flat" cmpd="sng" algn="ctr">
+                      <a:solidFill>
+                        <a:srgbClr val="D5DCE1"/>
+                      </a:solidFill>
+                      <a:prstDash val="solid"/>
+                      <a:round/>
+                      <a:headEnd type="none" w="med" len="med"/>
+                      <a:tailEnd type="none" w="med" len="med"/>
+                    </a:lnT>
+                    <a:lnB w="6350" cap="flat" cmpd="sng" algn="ctr">
+                      <a:solidFill>
+                        <a:srgbClr val="D5DCE1"/>
+                      </a:solidFill>
+                      <a:prstDash val="solid"/>
+                      <a:round/>
+                      <a:headEnd type="none" w="med" len="med"/>
+                      <a:tailEnd type="none" w="med" len="med"/>
+                    </a:lnB>
+                  </a:tcPr>
+                </a:tc>
               </a:tr>
-              <a:tr h="384048">
+              <a:tr h="457200">
                 <a:tc>
                   <a:txBody>
                     <a:bodyPr/>
@@ -10388,7 +10773,7 @@
                           <a:ea typeface="Calibri" pitchFamily="34" charset="-122"/>
                           <a:cs typeface="Calibri" pitchFamily="34" charset="-120"/>
                         </a:rPr>
-                        <a:t>~2,650 lines, but only ~22 matter after boot</a:t>
+                        <a:t>~2,650 lines; ~22 matter after boot</a:t>
                       </a:r>
                       <a:endParaRPr lang="en-US" sz="1000" dirty="0">
                         <a:latin typeface="Calibri" charset="0"/>
@@ -10436,8 +10821,73 @@
                     </a:lnB>
                   </a:tcPr>
                 </a:tc>
+                <a:tc>
+                  <a:txBody>
+                    <a:bodyPr/>
+                    <a:lstStyle/>
+                    <a:p>
+                      <a:pPr indent="0" marL="0">
+                        <a:buNone/>
+                      </a:pPr>
+                      <a:r>
+                        <a:rPr lang="en-US" sz="1000" dirty="0">
+                          <a:solidFill>
+                            <a:schemeClr val="tx1"/>
+                          </a:solidFill>
+                          <a:latin typeface="Calibri" pitchFamily="34" charset="0"/>
+                          <a:ea typeface="Calibri" pitchFamily="34" charset="-122"/>
+                          <a:cs typeface="Calibri" pitchFamily="34" charset="-120"/>
+                        </a:rPr>
+                        <a:t>the primitives only; dictionary generated</a:t>
+                      </a:r>
+                      <a:endParaRPr lang="en-US" sz="1000" dirty="0">
+                        <a:latin typeface="Calibri" charset="0"/>
+                        <a:ea typeface="Calibri" charset="0"/>
+                        <a:cs typeface="Calibri" charset="0"/>
+                      </a:endParaRPr>
+                    </a:p>
+                  </a:txBody>
+                  <a:tcPr marL="45720" marR="45720" marT="45720" marB="45720" anchor="ctr">
+                    <a:lnL w="6350" cap="flat" cmpd="sng" algn="ctr">
+                      <a:solidFill>
+                        <a:srgbClr val="D5DCE1"/>
+                      </a:solidFill>
+                      <a:prstDash val="solid"/>
+                      <a:round/>
+                      <a:headEnd type="none" w="med" len="med"/>
+                      <a:tailEnd type="none" w="med" len="med"/>
+                    </a:lnL>
+                    <a:lnR w="6350" cap="flat" cmpd="sng" algn="ctr">
+                      <a:solidFill>
+                        <a:srgbClr val="D5DCE1"/>
+                      </a:solidFill>
+                      <a:prstDash val="solid"/>
+                      <a:round/>
+                      <a:headEnd type="none" w="med" len="med"/>
+                      <a:tailEnd type="none" w="med" len="med"/>
+                    </a:lnR>
+                    <a:lnT w="6350" cap="flat" cmpd="sng" algn="ctr">
+                      <a:solidFill>
+                        <a:srgbClr val="D5DCE1"/>
+                      </a:solidFill>
+                      <a:prstDash val="solid"/>
+                      <a:round/>
+                      <a:headEnd type="none" w="med" len="med"/>
+                      <a:tailEnd type="none" w="med" len="med"/>
+                    </a:lnT>
+                    <a:lnB w="6350" cap="flat" cmpd="sng" algn="ctr">
+                      <a:solidFill>
+                        <a:srgbClr val="D5DCE1"/>
+                      </a:solidFill>
+                      <a:prstDash val="solid"/>
+                      <a:round/>
+                      <a:headEnd type="none" w="med" len="med"/>
+                      <a:tailEnd type="none" w="med" len="med"/>
+                    </a:lnB>
+                  </a:tcPr>
+                </a:tc>
               </a:tr>
-              <a:tr h="384048">
+              <a:tr h="457200">
                 <a:tc>
                   <a:txBody>
                     <a:bodyPr/>
@@ -10698,8 +11148,73 @@
                     </a:lnB>
                   </a:tcPr>
                 </a:tc>
+                <a:tc>
+                  <a:txBody>
+                    <a:bodyPr/>
+                    <a:lstStyle/>
+                    <a:p>
+                      <a:pPr indent="0" marL="0">
+                        <a:buNone/>
+                      </a:pPr>
+                      <a:r>
+                        <a:rPr lang="en-US" sz="1000" dirty="0">
+                          <a:solidFill>
+                            <a:schemeClr val="tx1"/>
+                          </a:solidFill>
+                          <a:latin typeface="Calibri" pitchFamily="34" charset="0"/>
+                          <a:ea typeface="Calibri" pitchFamily="34" charset="-122"/>
+                          <a:cs typeface="Calibri" pitchFamily="34" charset="-120"/>
+                        </a:rPr>
+                        <a:t>same, all compiled ahead of time</a:t>
+                      </a:r>
+                      <a:endParaRPr lang="en-US" sz="1000" dirty="0">
+                        <a:latin typeface="Calibri" charset="0"/>
+                        <a:ea typeface="Calibri" charset="0"/>
+                        <a:cs typeface="Calibri" charset="0"/>
+                      </a:endParaRPr>
+                    </a:p>
+                  </a:txBody>
+                  <a:tcPr marL="45720" marR="45720" marT="45720" marB="45720" anchor="ctr">
+                    <a:lnL w="6350" cap="flat" cmpd="sng" algn="ctr">
+                      <a:solidFill>
+                        <a:srgbClr val="D5DCE1"/>
+                      </a:solidFill>
+                      <a:prstDash val="solid"/>
+                      <a:round/>
+                      <a:headEnd type="none" w="med" len="med"/>
+                      <a:tailEnd type="none" w="med" len="med"/>
+                    </a:lnL>
+                    <a:lnR w="6350" cap="flat" cmpd="sng" algn="ctr">
+                      <a:solidFill>
+                        <a:srgbClr val="D5DCE1"/>
+                      </a:solidFill>
+                      <a:prstDash val="solid"/>
+                      <a:round/>
+                      <a:headEnd type="none" w="med" len="med"/>
+                      <a:tailEnd type="none" w="med" len="med"/>
+                    </a:lnR>
+                    <a:lnT w="6350" cap="flat" cmpd="sng" algn="ctr">
+                      <a:solidFill>
+                        <a:srgbClr val="D5DCE1"/>
+                      </a:solidFill>
+                      <a:prstDash val="solid"/>
+                      <a:round/>
+                      <a:headEnd type="none" w="med" len="med"/>
+                      <a:tailEnd type="none" w="med" len="med"/>
+                    </a:lnT>
+                    <a:lnB w="6350" cap="flat" cmpd="sng" algn="ctr">
+                      <a:solidFill>
+                        <a:srgbClr val="D5DCE1"/>
+                      </a:solidFill>
+                      <a:prstDash val="solid"/>
+                      <a:round/>
+                      <a:headEnd type="none" w="med" len="med"/>
+                      <a:tailEnd type="none" w="med" len="med"/>
+                    </a:lnB>
+                  </a:tcPr>
+                </a:tc>
               </a:tr>
-              <a:tr h="384048">
+              <a:tr h="457200">
                 <a:tc>
                   <a:txBody>
                     <a:bodyPr/>
@@ -10847,7 +11362,7 @@
                           <a:ea typeface="Calibri" pitchFamily="34" charset="-122"/>
                           <a:cs typeface="Calibri" pitchFamily="34" charset="-120"/>
                         </a:rPr>
-                        <a:t>rewrite 50 primitives + bootstrap</a:t>
+                        <a:t>50 primitives + bootstrap</a:t>
                       </a:r>
                       <a:endParaRPr lang="en-US" sz="1000" dirty="0">
                         <a:latin typeface="Calibri" charset="0"/>
@@ -10912,74 +11427,7 @@
                           <a:ea typeface="Calibri" pitchFamily="34" charset="-122"/>
                           <a:cs typeface="Calibri" pitchFamily="34" charset="-120"/>
                         </a:rPr>
-                        <a:t>rewrite ~22 primitives + bootstrap; outer interpreter is portable Forth</a:t>
-                      </a:r>
-                      <a:endParaRPr lang="en-US" sz="1000" dirty="0">
-                        <a:latin typeface="Calibri" charset="0"/>
-                        <a:ea typeface="Calibri" charset="0"/>
-                        <a:cs typeface="Calibri" charset="0"/>
-                      </a:endParaRPr>
-                    </a:p>
-                  </a:txBody>
-                  <a:tcPr marL="45720" marR="45720" marT="45720" marB="45720" anchor="ctr">
-                    <a:lnL w="6350" cap="flat" cmpd="sng" algn="ctr">
-                      <a:solidFill>
-                        <a:srgbClr val="D5DCE1"/>
-                      </a:solidFill>
-                      <a:prstDash val="solid"/>
-                      <a:round/>
-                      <a:headEnd type="none" w="med" len="med"/>
-                      <a:tailEnd type="none" w="med" len="med"/>
-                    </a:lnL>
-                    <a:lnR w="6350" cap="flat" cmpd="sng" algn="ctr">
-                      <a:solidFill>
-                        <a:srgbClr val="D5DCE1"/>
-                      </a:solidFill>
-                      <a:prstDash val="solid"/>
-                      <a:round/>
-                      <a:headEnd type="none" w="med" len="med"/>
-                      <a:tailEnd type="none" w="med" len="med"/>
-                    </a:lnR>
-                    <a:lnT w="6350" cap="flat" cmpd="sng" algn="ctr">
-                      <a:solidFill>
-                        <a:srgbClr val="D5DCE1"/>
-                      </a:solidFill>
-                      <a:prstDash val="solid"/>
-                      <a:round/>
-                      <a:headEnd type="none" w="med" len="med"/>
-                      <a:tailEnd type="none" w="med" len="med"/>
-                    </a:lnT>
-                    <a:lnB w="6350" cap="flat" cmpd="sng" algn="ctr">
-                      <a:solidFill>
-                        <a:srgbClr val="D5DCE1"/>
-                      </a:solidFill>
-                      <a:prstDash val="solid"/>
-                      <a:round/>
-                      <a:headEnd type="none" w="med" len="med"/>
-                      <a:tailEnd type="none" w="med" len="med"/>
-                    </a:lnB>
-                  </a:tcPr>
-                </a:tc>
-              </a:tr>
-              <a:tr h="384048">
-                <a:tc>
-                  <a:txBody>
-                    <a:bodyPr/>
-                    <a:lstStyle/>
-                    <a:p>
-                      <a:pPr indent="0" marL="0">
-                        <a:buNone/>
-                      </a:pPr>
-                      <a:r>
-                        <a:rPr lang="en-US" sz="1000" b="1" dirty="0">
-                          <a:solidFill>
-                            <a:schemeClr val="tx1"/>
-                          </a:solidFill>
-                          <a:latin typeface="Calibri" pitchFamily="34" charset="0"/>
-                          <a:ea typeface="Calibri" pitchFamily="34" charset="-122"/>
-                          <a:cs typeface="Calibri" pitchFamily="34" charset="-120"/>
-                        </a:rPr>
-                        <a:t>Extra vocabulary</a:t>
+                        <a:t>~22 primitives + bootstrap</a:t>
                       </a:r>
                       <a:endParaRPr lang="en-US" sz="1000" dirty="0">
                         <a:latin typeface="Calibri" charset="0"/>
@@ -11044,7 +11492,7 @@
                           <a:ea typeface="Calibri" pitchFamily="34" charset="-122"/>
                           <a:cs typeface="Calibri" pitchFamily="34" charset="-120"/>
                         </a:rPr>
-                        <a:t>FORGET, :NONAME</a:t>
+                        <a:t>new asm emitter + ~22 primitives</a:t>
                       </a:r>
                       <a:endParaRPr lang="en-US" sz="1000" dirty="0">
                         <a:latin typeface="Calibri" charset="0"/>
@@ -11092,138 +11540,8 @@
                     </a:lnB>
                   </a:tcPr>
                 </a:tc>
-                <a:tc>
-                  <a:txBody>
-                    <a:bodyPr/>
-                    <a:lstStyle/>
-                    <a:p>
-                      <a:pPr indent="0" marL="0">
-                        <a:buNone/>
-                      </a:pPr>
-                      <a:r>
-                        <a:rPr lang="en-US" sz="1000" dirty="0">
-                          <a:solidFill>
-                            <a:schemeClr val="tx1"/>
-                          </a:solidFill>
-                          <a:latin typeface="Calibri" pitchFamily="34" charset="0"/>
-                          <a:ea typeface="Calibri" pitchFamily="34" charset="-122"/>
-                          <a:cs typeface="Calibri" pitchFamily="34" charset="-120"/>
-                        </a:rPr>
-                        <a:t>SEE, DUMP-ALL, PICK, ROT</a:t>
-                      </a:r>
-                      <a:endParaRPr lang="en-US" sz="1000" dirty="0">
-                        <a:latin typeface="Calibri" charset="0"/>
-                        <a:ea typeface="Calibri" charset="0"/>
-                        <a:cs typeface="Calibri" charset="0"/>
-                      </a:endParaRPr>
-                    </a:p>
-                  </a:txBody>
-                  <a:tcPr marL="45720" marR="45720" marT="45720" marB="45720" anchor="ctr">
-                    <a:lnL w="6350" cap="flat" cmpd="sng" algn="ctr">
-                      <a:solidFill>
-                        <a:srgbClr val="D5DCE1"/>
-                      </a:solidFill>
-                      <a:prstDash val="solid"/>
-                      <a:round/>
-                      <a:headEnd type="none" w="med" len="med"/>
-                      <a:tailEnd type="none" w="med" len="med"/>
-                    </a:lnL>
-                    <a:lnR w="6350" cap="flat" cmpd="sng" algn="ctr">
-                      <a:solidFill>
-                        <a:srgbClr val="D5DCE1"/>
-                      </a:solidFill>
-                      <a:prstDash val="solid"/>
-                      <a:round/>
-                      <a:headEnd type="none" w="med" len="med"/>
-                      <a:tailEnd type="none" w="med" len="med"/>
-                    </a:lnR>
-                    <a:lnT w="6350" cap="flat" cmpd="sng" algn="ctr">
-                      <a:solidFill>
-                        <a:srgbClr val="D5DCE1"/>
-                      </a:solidFill>
-                      <a:prstDash val="solid"/>
-                      <a:round/>
-                      <a:headEnd type="none" w="med" len="med"/>
-                      <a:tailEnd type="none" w="med" len="med"/>
-                    </a:lnT>
-                    <a:lnB w="6350" cap="flat" cmpd="sng" algn="ctr">
-                      <a:solidFill>
-                        <a:srgbClr val="D5DCE1"/>
-                      </a:solidFill>
-                      <a:prstDash val="solid"/>
-                      <a:round/>
-                      <a:headEnd type="none" w="med" len="med"/>
-                      <a:tailEnd type="none" w="med" len="med"/>
-                    </a:lnB>
-                  </a:tcPr>
-                </a:tc>
-                <a:tc>
-                  <a:txBody>
-                    <a:bodyPr/>
-                    <a:lstStyle/>
-                    <a:p>
-                      <a:pPr indent="0" marL="0">
-                        <a:buNone/>
-                      </a:pPr>
-                      <a:r>
-                        <a:rPr lang="en-US" sz="1000" dirty="0">
-                          <a:solidFill>
-                            <a:schemeClr val="tx1"/>
-                          </a:solidFill>
-                          <a:latin typeface="Calibri" pitchFamily="34" charset="0"/>
-                          <a:ea typeface="Calibri" pitchFamily="34" charset="-122"/>
-                          <a:cs typeface="Calibri" pitchFamily="34" charset="-120"/>
-                        </a:rPr>
-                        <a:t>NAND, SP!, RP@, RP!, WORD-BUFFER</a:t>
-                      </a:r>
-                      <a:endParaRPr lang="en-US" sz="1000" dirty="0">
-                        <a:latin typeface="Calibri" charset="0"/>
-                        <a:ea typeface="Calibri" charset="0"/>
-                        <a:cs typeface="Calibri" charset="0"/>
-                      </a:endParaRPr>
-                    </a:p>
-                  </a:txBody>
-                  <a:tcPr marL="45720" marR="45720" marT="45720" marB="45720" anchor="ctr">
-                    <a:lnL w="6350" cap="flat" cmpd="sng" algn="ctr">
-                      <a:solidFill>
-                        <a:srgbClr val="D5DCE1"/>
-                      </a:solidFill>
-                      <a:prstDash val="solid"/>
-                      <a:round/>
-                      <a:headEnd type="none" w="med" len="med"/>
-                      <a:tailEnd type="none" w="med" len="med"/>
-                    </a:lnL>
-                    <a:lnR w="6350" cap="flat" cmpd="sng" algn="ctr">
-                      <a:solidFill>
-                        <a:srgbClr val="D5DCE1"/>
-                      </a:solidFill>
-                      <a:prstDash val="solid"/>
-                      <a:round/>
-                      <a:headEnd type="none" w="med" len="med"/>
-                      <a:tailEnd type="none" w="med" len="med"/>
-                    </a:lnR>
-                    <a:lnT w="6350" cap="flat" cmpd="sng" algn="ctr">
-                      <a:solidFill>
-                        <a:srgbClr val="D5DCE1"/>
-                      </a:solidFill>
-                      <a:prstDash val="solid"/>
-                      <a:round/>
-                      <a:headEnd type="none" w="med" len="med"/>
-                      <a:tailEnd type="none" w="med" len="med"/>
-                    </a:lnT>
-                    <a:lnB w="6350" cap="flat" cmpd="sng" algn="ctr">
-                      <a:solidFill>
-                        <a:srgbClr val="D5DCE1"/>
-                      </a:solidFill>
-                      <a:prstDash val="solid"/>
-                      <a:round/>
-                      <a:headEnd type="none" w="med" len="med"/>
-                      <a:tailEnd type="none" w="med" len="med"/>
-                    </a:lnB>
-                  </a:tcPr>
-                </a:tc>
               </a:tr>
-              <a:tr h="384048">
+              <a:tr h="457200">
                 <a:tc>
                   <a:txBody>
                     <a:bodyPr/>
@@ -11436,7 +11754,7 @@
                           <a:ea typeface="Calibri" pitchFamily="34" charset="-122"/>
                           <a:cs typeface="Calibri" pitchFamily="34" charset="-120"/>
                         </a:rPr>
-                        <a:t>chicken-and-egg: asm loop must compile Forth : first</a:t>
+                        <a:t>asm loop must compile Forth : first</a:t>
                       </a:r>
                       <a:endParaRPr lang="en-US" sz="1000" dirty="0">
                         <a:latin typeface="Calibri" charset="0"/>
@@ -11484,8 +11802,73 @@
                     </a:lnB>
                   </a:tcPr>
                 </a:tc>
+                <a:tc>
+                  <a:txBody>
+                    <a:bodyPr/>
+                    <a:lstStyle/>
+                    <a:p>
+                      <a:pPr indent="0" marL="0">
+                        <a:buNone/>
+                      </a:pPr>
+                      <a:r>
+                        <a:rPr lang="en-US" sz="1000" dirty="0">
+                          <a:solidFill>
+                            <a:schemeClr val="tx1"/>
+                          </a:solidFill>
+                          <a:latin typeface="Calibri" pitchFamily="34" charset="0"/>
+                          <a:ea typeface="Calibri" pitchFamily="34" charset="-122"/>
+                          <a:cs typeface="Calibri" pitchFamily="34" charset="-120"/>
+                        </a:rPr>
+                        <a:t>none at run time; the compiler carries it</a:t>
+                      </a:r>
+                      <a:endParaRPr lang="en-US" sz="1000" dirty="0">
+                        <a:latin typeface="Calibri" charset="0"/>
+                        <a:ea typeface="Calibri" charset="0"/>
+                        <a:cs typeface="Calibri" charset="0"/>
+                      </a:endParaRPr>
+                    </a:p>
+                  </a:txBody>
+                  <a:tcPr marL="45720" marR="45720" marT="45720" marB="45720" anchor="ctr">
+                    <a:lnL w="6350" cap="flat" cmpd="sng" algn="ctr">
+                      <a:solidFill>
+                        <a:srgbClr val="D5DCE1"/>
+                      </a:solidFill>
+                      <a:prstDash val="solid"/>
+                      <a:round/>
+                      <a:headEnd type="none" w="med" len="med"/>
+                      <a:tailEnd type="none" w="med" len="med"/>
+                    </a:lnL>
+                    <a:lnR w="6350" cap="flat" cmpd="sng" algn="ctr">
+                      <a:solidFill>
+                        <a:srgbClr val="D5DCE1"/>
+                      </a:solidFill>
+                      <a:prstDash val="solid"/>
+                      <a:round/>
+                      <a:headEnd type="none" w="med" len="med"/>
+                      <a:tailEnd type="none" w="med" len="med"/>
+                    </a:lnR>
+                    <a:lnT w="6350" cap="flat" cmpd="sng" algn="ctr">
+                      <a:solidFill>
+                        <a:srgbClr val="D5DCE1"/>
+                      </a:solidFill>
+                      <a:prstDash val="solid"/>
+                      <a:round/>
+                      <a:headEnd type="none" w="med" len="med"/>
+                      <a:tailEnd type="none" w="med" len="med"/>
+                    </a:lnT>
+                    <a:lnB w="6350" cap="flat" cmpd="sng" algn="ctr">
+                      <a:solidFill>
+                        <a:srgbClr val="D5DCE1"/>
+                      </a:solidFill>
+                      <a:prstDash val="solid"/>
+                      <a:round/>
+                      <a:headEnd type="none" w="med" len="med"/>
+                      <a:tailEnd type="none" w="med" len="med"/>
+                    </a:lnB>
+                  </a:tcPr>
+                </a:tc>
               </a:tr>
-              <a:tr h="384048">
+              <a:tr h="457200">
                 <a:tc>
                   <a:txBody>
                     <a:bodyPr/>
@@ -11698,7 +12081,72 @@
                           <a:ea typeface="Calibri" pitchFamily="34" charset="-122"/>
                           <a:cs typeface="Calibri" pitchFamily="34" charset="-120"/>
                         </a:rPr>
-                        <a:t>porting; seeing the whole interpreter as Forth</a:t>
+                        <a:t>seeing the interpreter as Forth</a:t>
+                      </a:r>
+                      <a:endParaRPr lang="en-US" sz="1000" dirty="0">
+                        <a:latin typeface="Calibri" charset="0"/>
+                        <a:ea typeface="Calibri" charset="0"/>
+                        <a:cs typeface="Calibri" charset="0"/>
+                      </a:endParaRPr>
+                    </a:p>
+                  </a:txBody>
+                  <a:tcPr marL="45720" marR="45720" marT="45720" marB="45720" anchor="ctr">
+                    <a:lnL w="6350" cap="flat" cmpd="sng" algn="ctr">
+                      <a:solidFill>
+                        <a:srgbClr val="D5DCE1"/>
+                      </a:solidFill>
+                      <a:prstDash val="solid"/>
+                      <a:round/>
+                      <a:headEnd type="none" w="med" len="med"/>
+                      <a:tailEnd type="none" w="med" len="med"/>
+                    </a:lnL>
+                    <a:lnR w="6350" cap="flat" cmpd="sng" algn="ctr">
+                      <a:solidFill>
+                        <a:srgbClr val="D5DCE1"/>
+                      </a:solidFill>
+                      <a:prstDash val="solid"/>
+                      <a:round/>
+                      <a:headEnd type="none" w="med" len="med"/>
+                      <a:tailEnd type="none" w="med" len="med"/>
+                    </a:lnR>
+                    <a:lnT w="6350" cap="flat" cmpd="sng" algn="ctr">
+                      <a:solidFill>
+                        <a:srgbClr val="D5DCE1"/>
+                      </a:solidFill>
+                      <a:prstDash val="solid"/>
+                      <a:round/>
+                      <a:headEnd type="none" w="med" len="med"/>
+                      <a:tailEnd type="none" w="med" len="med"/>
+                    </a:lnT>
+                    <a:lnB w="6350" cap="flat" cmpd="sng" algn="ctr">
+                      <a:solidFill>
+                        <a:srgbClr val="D5DCE1"/>
+                      </a:solidFill>
+                      <a:prstDash val="solid"/>
+                      <a:round/>
+                      <a:headEnd type="none" w="med" len="med"/>
+                      <a:tailEnd type="none" w="med" len="med"/>
+                    </a:lnB>
+                  </a:tcPr>
+                </a:tc>
+                <a:tc>
+                  <a:txBody>
+                    <a:bodyPr/>
+                    <a:lstStyle/>
+                    <a:p>
+                      <a:pPr indent="0" marL="0">
+                        <a:buNone/>
+                      </a:pPr>
+                      <a:r>
+                        <a:rPr lang="en-US" sz="1000" dirty="0">
+                          <a:solidFill>
+                            <a:schemeClr val="tx1"/>
+                          </a:solidFill>
+                          <a:latin typeface="Calibri" pitchFamily="34" charset="0"/>
+                          <a:ea typeface="Calibri" pitchFamily="34" charset="-122"/>
+                          <a:cs typeface="Calibri" pitchFamily="34" charset="-120"/>
+                        </a:rPr>
+                        <a:t>fast start; the self-hosting story end to end</a:t>
                       </a:r>
                       <a:endParaRPr lang="en-US" sz="1000" dirty="0">
                         <a:latin typeface="Calibri" charset="0"/>
@@ -11962,7 +12410,7 @@
       </p:sp>
       <p:graphicFrame>
         <p:nvGraphicFramePr>
-          <p:cNvPr id="19" name="table 172"/>
+          <p:cNvPr id="19" name="table 184"/>
           <p:cNvGraphicFramePr>
             <a:graphicFrameLocks noGrp="1"/>
           </p:cNvGraphicFramePr>
@@ -12475,7 +12923,7 @@
                           <a:ea typeface="Calibri" pitchFamily="34" charset="-122"/>
                           <a:cs typeface="Calibri" pitchFamily="34" charset="-120"/>
                         </a:rPr>
-                        <a:t>1 2 3</a:t>
+                        <a:t>1 2 3 4</a:t>
                       </a:r>
                       <a:endParaRPr lang="en-US" sz="900" dirty="0">
                         <a:latin typeface="Calibri" charset="0"/>
@@ -12737,7 +13185,7 @@
                           <a:ea typeface="Calibri" pitchFamily="34" charset="-122"/>
                           <a:cs typeface="Calibri" pitchFamily="34" charset="-120"/>
                         </a:rPr>
-                        <a:t>1 2 3</a:t>
+                        <a:t>1 2 3 4</a:t>
                       </a:r>
                       <a:endParaRPr lang="en-US" sz="900" dirty="0">
                         <a:latin typeface="Calibri" charset="0"/>
@@ -12999,7 +13447,7 @@
                           <a:ea typeface="Calibri" pitchFamily="34" charset="-122"/>
                           <a:cs typeface="Calibri" pitchFamily="34" charset="-120"/>
                         </a:rPr>
-                        <a:t>1 2 3</a:t>
+                        <a:t>1 2 3 4</a:t>
                       </a:r>
                       <a:endParaRPr lang="en-US" sz="900" dirty="0">
                         <a:latin typeface="Calibri" charset="0"/>
@@ -13261,7 +13709,7 @@
                           <a:ea typeface="Calibri" pitchFamily="34" charset="-122"/>
                           <a:cs typeface="Calibri" pitchFamily="34" charset="-120"/>
                         </a:rPr>
-                        <a:t>1 2 3</a:t>
+                        <a:t>1 2 3 4</a:t>
                       </a:r>
                       <a:endParaRPr lang="en-US" sz="900" dirty="0">
                         <a:latin typeface="Calibri" charset="0"/>
@@ -13523,7 +13971,7 @@
                           <a:ea typeface="Calibri" pitchFamily="34" charset="-122"/>
                           <a:cs typeface="Calibri" pitchFamily="34" charset="-120"/>
                         </a:rPr>
-                        <a:t>1 2 3</a:t>
+                        <a:t>1 2 3 4</a:t>
                       </a:r>
                       <a:endParaRPr lang="en-US" sz="900" dirty="0">
                         <a:latin typeface="Calibri" charset="0"/>
@@ -13785,7 +14233,7 @@
                           <a:ea typeface="Calibri" pitchFamily="34" charset="-122"/>
                           <a:cs typeface="Calibri" pitchFamily="34" charset="-120"/>
                         </a:rPr>
-                        <a:t>1 2 3</a:t>
+                        <a:t>1 2 3 4</a:t>
                       </a:r>
                       <a:endParaRPr lang="en-US" sz="900" dirty="0">
                         <a:latin typeface="Calibri" charset="0"/>
@@ -14047,7 +14495,7 @@
                           <a:ea typeface="Calibri" pitchFamily="34" charset="-122"/>
                           <a:cs typeface="Calibri" pitchFamily="34" charset="-120"/>
                         </a:rPr>
-                        <a:t>1 2 3</a:t>
+                        <a:t>1 2 3 4</a:t>
                       </a:r>
                       <a:endParaRPr lang="en-US" sz="900" dirty="0">
                         <a:latin typeface="Calibri" charset="0"/>
@@ -14309,7 +14757,7 @@
                           <a:ea typeface="Calibri" pitchFamily="34" charset="-122"/>
                           <a:cs typeface="Calibri" pitchFamily="34" charset="-120"/>
                         </a:rPr>
-                        <a:t>1 2 3</a:t>
+                        <a:t>1 2 3 4</a:t>
                       </a:r>
                       <a:endParaRPr lang="en-US" sz="900" dirty="0">
                         <a:latin typeface="Calibri" charset="0"/>
@@ -14571,7 +15019,7 @@
                           <a:ea typeface="Calibri" pitchFamily="34" charset="-122"/>
                           <a:cs typeface="Calibri" pitchFamily="34" charset="-120"/>
                         </a:rPr>
-                        <a:t>1 2 3</a:t>
+                        <a:t>1 2 3 4</a:t>
                       </a:r>
                       <a:endParaRPr lang="en-US" sz="900" dirty="0">
                         <a:latin typeface="Calibri" charset="0"/>
@@ -14833,7 +15281,7 @@
                           <a:ea typeface="Calibri" pitchFamily="34" charset="-122"/>
                           <a:cs typeface="Calibri" pitchFamily="34" charset="-120"/>
                         </a:rPr>
-                        <a:t>1 2 3</a:t>
+                        <a:t>1 2 3 4</a:t>
                       </a:r>
                       <a:endParaRPr lang="en-US" sz="900" dirty="0">
                         <a:latin typeface="Calibri" charset="0"/>
@@ -15095,7 +15543,7 @@
                           <a:ea typeface="Calibri" pitchFamily="34" charset="-122"/>
                           <a:cs typeface="Calibri" pitchFamily="34" charset="-120"/>
                         </a:rPr>
-                        <a:t>2 3</a:t>
+                        <a:t>2 3 4</a:t>
                       </a:r>
                       <a:endParaRPr lang="en-US" sz="900" dirty="0">
                         <a:latin typeface="Calibri" charset="0"/>
@@ -15357,7 +15805,7 @@
                           <a:ea typeface="Calibri" pitchFamily="34" charset="-122"/>
                           <a:cs typeface="Calibri" pitchFamily="34" charset="-120"/>
                         </a:rPr>
-                        <a:t>2 3</a:t>
+                        <a:t>2 3 4</a:t>
                       </a:r>
                       <a:endParaRPr lang="en-US" sz="900" dirty="0">
                         <a:latin typeface="Calibri" charset="0"/>
@@ -15619,7 +16067,7 @@
                           <a:ea typeface="Calibri" pitchFamily="34" charset="-122"/>
                           <a:cs typeface="Calibri" pitchFamily="34" charset="-120"/>
                         </a:rPr>
-                        <a:t>2 3</a:t>
+                        <a:t>2 3 4</a:t>
                       </a:r>
                       <a:endParaRPr lang="en-US" sz="900" dirty="0">
                         <a:latin typeface="Calibri" charset="0"/>
@@ -15881,7 +16329,7 @@
                           <a:ea typeface="Calibri" pitchFamily="34" charset="-122"/>
                           <a:cs typeface="Calibri" pitchFamily="34" charset="-120"/>
                         </a:rPr>
-                        <a:t>2 3</a:t>
+                        <a:t>2 3 4</a:t>
                       </a:r>
                       <a:endParaRPr lang="en-US" sz="900" dirty="0">
                         <a:latin typeface="Calibri" charset="0"/>
@@ -16143,7 +16591,7 @@
                           <a:ea typeface="Calibri" pitchFamily="34" charset="-122"/>
                           <a:cs typeface="Calibri" pitchFamily="34" charset="-120"/>
                         </a:rPr>
-                        <a:t>1 2 3</a:t>
+                        <a:t>1 2 3 4</a:t>
                       </a:r>
                       <a:endParaRPr lang="en-US" sz="900" dirty="0">
                         <a:latin typeface="Calibri" charset="0"/>
@@ -16566,7 +17014,7 @@
       </p:sp>
       <p:sp>
         <p:nvSpPr>
-          <p:cNvPr id="9" name="card 173"/>
+          <p:cNvPr id="9" name="card 185"/>
           <p:cNvSpPr/>
           <p:nvPr/>
         </p:nvSpPr>
@@ -16593,7 +17041,7 @@
       </p:sp>
       <p:sp>
         <p:nvSpPr>
-          <p:cNvPr id="10" name="icon 174"/>
+          <p:cNvPr id="10" name="icon 186"/>
           <p:cNvSpPr/>
           <p:nvPr/>
         </p:nvSpPr>
@@ -16618,7 +17066,7 @@
       </p:sp>
       <p:sp>
         <p:nvSpPr>
-          <p:cNvPr id="11" name="glyph 175"/>
+          <p:cNvPr id="11" name="glyph 187"/>
           <p:cNvSpPr txBox="1"/>
           <p:nvPr/>
         </p:nvSpPr>
@@ -16654,7 +17102,7 @@
       </p:sp>
       <p:sp>
         <p:nvSpPr>
-          <p:cNvPr id="12" name="card head 176"/>
+          <p:cNvPr id="12" name="card head 188"/>
           <p:cNvSpPr txBox="1"/>
           <p:nvPr/>
         </p:nvSpPr>
@@ -16690,7 +17138,7 @@
       </p:sp>
       <p:sp>
         <p:nvSpPr>
-          <p:cNvPr id="13" name="card body 177"/>
+          <p:cNvPr id="13" name="card body 189"/>
           <p:cNvSpPr txBox="1"/>
           <p:nvPr/>
         </p:nvSpPr>
@@ -16740,7 +17188,7 @@
       </p:sp>
       <p:sp>
         <p:nvSpPr>
-          <p:cNvPr id="14" name="card 178"/>
+          <p:cNvPr id="14" name="card 190"/>
           <p:cNvSpPr/>
           <p:nvPr/>
         </p:nvSpPr>
@@ -16767,7 +17215,7 @@
       </p:sp>
       <p:sp>
         <p:nvSpPr>
-          <p:cNvPr id="15" name="icon 179"/>
+          <p:cNvPr id="15" name="icon 191"/>
           <p:cNvSpPr/>
           <p:nvPr/>
         </p:nvSpPr>
@@ -16792,7 +17240,7 @@
       </p:sp>
       <p:sp>
         <p:nvSpPr>
-          <p:cNvPr id="16" name="glyph 180"/>
+          <p:cNvPr id="16" name="glyph 192"/>
           <p:cNvSpPr txBox="1"/>
           <p:nvPr/>
         </p:nvSpPr>
@@ -16828,7 +17276,7 @@
       </p:sp>
       <p:sp>
         <p:nvSpPr>
-          <p:cNvPr id="17" name="card head 181"/>
+          <p:cNvPr id="17" name="card head 193"/>
           <p:cNvSpPr txBox="1"/>
           <p:nvPr/>
         </p:nvSpPr>
@@ -16864,7 +17312,7 @@
       </p:sp>
       <p:sp>
         <p:nvSpPr>
-          <p:cNvPr id="18" name="card body 182"/>
+          <p:cNvPr id="18" name="card body 194"/>
           <p:cNvSpPr txBox="1"/>
           <p:nvPr/>
         </p:nvSpPr>
@@ -16900,7 +17348,7 @@
       </p:sp>
       <p:sp>
         <p:nvSpPr>
-          <p:cNvPr id="19" name="card 183"/>
+          <p:cNvPr id="19" name="card 195"/>
           <p:cNvSpPr/>
           <p:nvPr/>
         </p:nvSpPr>
@@ -16927,7 +17375,7 @@
       </p:sp>
       <p:sp>
         <p:nvSpPr>
-          <p:cNvPr id="20" name="icon 184"/>
+          <p:cNvPr id="20" name="icon 196"/>
           <p:cNvSpPr/>
           <p:nvPr/>
         </p:nvSpPr>
@@ -16952,7 +17400,7 @@
       </p:sp>
       <p:sp>
         <p:nvSpPr>
-          <p:cNvPr id="21" name="glyph 185"/>
+          <p:cNvPr id="21" name="glyph 197"/>
           <p:cNvSpPr txBox="1"/>
           <p:nvPr/>
         </p:nvSpPr>
@@ -16988,7 +17436,7 @@
       </p:sp>
       <p:sp>
         <p:nvSpPr>
-          <p:cNvPr id="22" name="card head 186"/>
+          <p:cNvPr id="22" name="card head 198"/>
           <p:cNvSpPr txBox="1"/>
           <p:nvPr/>
         </p:nvSpPr>
@@ -17024,7 +17472,7 @@
       </p:sp>
       <p:sp>
         <p:nvSpPr>
-          <p:cNvPr id="23" name="card body 187"/>
+          <p:cNvPr id="23" name="card body 199"/>
           <p:cNvSpPr txBox="1"/>
           <p:nvPr/>
         </p:nvSpPr>
@@ -17096,7 +17544,7 @@
       </p:sp>
       <p:sp>
         <p:nvSpPr>
-          <p:cNvPr id="25" name="bullets 188"/>
+          <p:cNvPr id="25" name="bullets 200"/>
           <p:cNvSpPr txBox="1"/>
           <p:nvPr/>
         </p:nvSpPr>
@@ -17502,7 +17950,7 @@
                   <a:schemeClr val="tx1"/>
                 </a:solidFill>
               </a:rPr>
-              <a:t>Three implementations</a:t>
+              <a:t>Four implementations</a:t>
             </a:r>
             <a:endParaRPr lang="en-US" sz="1600" dirty="0"/>
           </a:p>
@@ -17538,7 +17986,7 @@
                   <a:schemeClr val="tx1"/>
                 </a:solidFill>
               </a:rPr>
-              <a:t>forth.s, forth-in-forth and forth-on-forthish: what each keeps in assembly and why. Plus forth.s hosted inside SWTOS.</a:t>
+              <a:t>forth.s, forth-in-forth, forth-on-forthish and forth-from-forth: what each keeps in assembly. Plus forth.s inside SWTOS.</a:t>
             </a:r>
             <a:endParaRPr lang="en-US" sz="1250" dirty="0"/>
           </a:p>
@@ -18116,7 +18564,7 @@
       </p:sp>
       <p:sp>
         <p:nvSpPr>
-          <p:cNvPr id="5" name="code background 189"/>
+          <p:cNvPr id="5" name="code background 201"/>
           <p:cNvSpPr/>
           <p:nvPr/>
         </p:nvSpPr>
@@ -18143,7 +18591,7 @@
       </p:sp>
       <p:sp>
         <p:nvSpPr>
-          <p:cNvPr id="6" name="code 190"/>
+          <p:cNvPr id="6" name="code 202"/>
           <p:cNvSpPr txBox="1"/>
           <p:nvPr/>
         </p:nvSpPr>
@@ -18298,7 +18746,7 @@
       </p:sp>
       <p:sp>
         <p:nvSpPr>
-          <p:cNvPr id="10" name="code background 191"/>
+          <p:cNvPr id="10" name="code background 203"/>
           <p:cNvSpPr/>
           <p:nvPr/>
         </p:nvSpPr>
@@ -18325,7 +18773,7 @@
       </p:sp>
       <p:sp>
         <p:nvSpPr>
-          <p:cNvPr id="11" name="code 192"/>
+          <p:cNvPr id="11" name="code 204"/>
           <p:cNvSpPr txBox="1"/>
           <p:nvPr/>
         </p:nvSpPr>
@@ -18480,7 +18928,7 @@
       </p:sp>
       <p:sp>
         <p:nvSpPr>
-          <p:cNvPr id="15" name="code background 193"/>
+          <p:cNvPr id="15" name="code background 205"/>
           <p:cNvSpPr/>
           <p:nvPr/>
         </p:nvSpPr>
@@ -18507,7 +18955,7 @@
       </p:sp>
       <p:sp>
         <p:nvSpPr>
-          <p:cNvPr id="16" name="code 194"/>
+          <p:cNvPr id="16" name="code 206"/>
           <p:cNvSpPr txBox="1"/>
           <p:nvPr/>
         </p:nvSpPr>
@@ -18696,7 +19144,7 @@
       </p:sp>
       <p:sp>
         <p:nvSpPr>
-          <p:cNvPr id="20" name="code background 195"/>
+          <p:cNvPr id="20" name="code background 207"/>
           <p:cNvSpPr/>
           <p:nvPr/>
         </p:nvSpPr>
@@ -18723,7 +19171,7 @@
       </p:sp>
       <p:sp>
         <p:nvSpPr>
-          <p:cNvPr id="21" name="code 196"/>
+          <p:cNvPr id="21" name="code 208"/>
           <p:cNvSpPr txBox="1"/>
           <p:nvPr/>
         </p:nvSpPr>
@@ -18974,7 +19422,7 @@
       </p:sp>
       <p:sp>
         <p:nvSpPr>
-          <p:cNvPr id="3" name="quirk icon 197"/>
+          <p:cNvPr id="3" name="quirk icon 209"/>
           <p:cNvSpPr/>
           <p:nvPr/>
         </p:nvSpPr>
@@ -18987,11 +19435,11 @@
             <a:avLst/>
           </a:prstGeom>
           <a:solidFill>
-            <a:schemeClr val="accent6"/>
+            <a:schemeClr val="accent3"/>
           </a:solidFill>
           <a:ln w="12700">
             <a:solidFill>
-              <a:schemeClr val="accent6"/>
+              <a:schemeClr val="accent3"/>
             </a:solidFill>
             <a:prstDash val="solid"/>
           </a:ln>
@@ -18999,7 +19447,7 @@
       </p:sp>
       <p:sp>
         <p:nvSpPr>
-          <p:cNvPr id="4" name="quirk glyph 198"/>
+          <p:cNvPr id="4" name="quirk glyph 210"/>
           <p:cNvSpPr txBox="1"/>
           <p:nvPr/>
         </p:nvSpPr>
@@ -19035,7 +19483,7 @@
       </p:sp>
       <p:sp>
         <p:nvSpPr>
-          <p:cNvPr id="5" name="quirk head 199"/>
+          <p:cNvPr id="5" name="quirk head 211"/>
           <p:cNvSpPr txBox="1"/>
           <p:nvPr/>
         </p:nvSpPr>
@@ -19063,7 +19511,7 @@
                   <a:schemeClr val="tx1"/>
                 </a:solidFill>
               </a:rPr>
-              <a:t>Fixed today: forth-on-forthish rejected negative literals</a:t>
+              <a:t>2SWAP and 2OVER are wrong on tabs 2 to 4</a:t>
             </a:r>
             <a:endParaRPr lang="en-US" sz="1400" dirty="0"/>
           </a:p>
@@ -19071,7 +19519,7 @@
       </p:sp>
       <p:sp>
         <p:nvSpPr>
-          <p:cNvPr id="6" name="quirk body 200"/>
+          <p:cNvPr id="6" name="quirk body 212"/>
           <p:cNvSpPr txBox="1"/>
           <p:nvPr/>
         </p:nvSpPr>
@@ -19099,7 +19547,7 @@
                   <a:schemeClr val="tx1"/>
                 </a:solidFill>
               </a:rPr>
-              <a:t>Its Forth NUMBER read the minus sign from the wrong stack cell, so -1 printed ? and left the stack short. Fixed 2026-10-23 in core/highlevel.fth; the tab 3 demos it broke (CONSTANT, DO LOOP, IF THEN, IF ELSE, Self Test) return with the next web build.</a:t>
+              <a:t>1 2 3 4 2SWAP leaves 2 1 4 3, not 3 4 1 2. Found while writing the cross-compiler, which avoids them; not fixed yet. Also: . prints -8388608 as -0.</a:t>
             </a:r>
             <a:endParaRPr lang="en-US" sz="1100" dirty="0"/>
           </a:p>
@@ -19107,7 +19555,7 @@
       </p:sp>
       <p:sp>
         <p:nvSpPr>
-          <p:cNvPr id="7" name="quirk icon 201"/>
+          <p:cNvPr id="7" name="quirk icon 213"/>
           <p:cNvSpPr/>
           <p:nvPr/>
         </p:nvSpPr>
@@ -19132,7 +19580,7 @@
       </p:sp>
       <p:sp>
         <p:nvSpPr>
-          <p:cNvPr id="8" name="quirk glyph 202"/>
+          <p:cNvPr id="8" name="quirk glyph 214"/>
           <p:cNvSpPr txBox="1"/>
           <p:nvPr/>
         </p:nvSpPr>
@@ -19168,7 +19616,7 @@
       </p:sp>
       <p:sp>
         <p:nvSpPr>
-          <p:cNvPr id="9" name="quirk head 203"/>
+          <p:cNvPr id="9" name="quirk head 215"/>
           <p:cNvSpPr txBox="1"/>
           <p:nvPr/>
         </p:nvSpPr>
@@ -19204,7 +19652,7 @@
       </p:sp>
       <p:sp>
         <p:nvSpPr>
-          <p:cNvPr id="10" name="quirk body 204"/>
+          <p:cNvPr id="10" name="quirk body 216"/>
           <p:cNvSpPr txBox="1"/>
           <p:nvPr/>
         </p:nvSpPr>
@@ -19240,7 +19688,7 @@
       </p:sp>
       <p:sp>
         <p:nvSpPr>
-          <p:cNvPr id="11" name="quirk icon 205"/>
+          <p:cNvPr id="11" name="quirk icon 217"/>
           <p:cNvSpPr/>
           <p:nvPr/>
         </p:nvSpPr>
@@ -19265,7 +19713,7 @@
       </p:sp>
       <p:sp>
         <p:nvSpPr>
-          <p:cNvPr id="12" name="quirk glyph 206"/>
+          <p:cNvPr id="12" name="quirk glyph 218"/>
           <p:cNvSpPr txBox="1"/>
           <p:nvPr/>
         </p:nvSpPr>
@@ -19301,7 +19749,7 @@
       </p:sp>
       <p:sp>
         <p:nvSpPr>
-          <p:cNvPr id="13" name="quirk head 207"/>
+          <p:cNvPr id="13" name="quirk head 219"/>
           <p:cNvSpPr txBox="1"/>
           <p:nvPr/>
         </p:nvSpPr>
@@ -19337,7 +19785,7 @@
       </p:sp>
       <p:sp>
         <p:nvSpPr>
-          <p:cNvPr id="14" name="quirk body 208"/>
+          <p:cNvPr id="14" name="quirk body 220"/>
           <p:cNvSpPr txBox="1"/>
           <p:nvPr/>
         </p:nvSpPr>
@@ -19365,7 +19813,7 @@
                   <a:schemeClr val="tx1"/>
                 </a:solidFill>
               </a:rPr>
-              <a:t>Tabs 2 and 3 redefine by shadowing; reclaiming dictionary space means Reset.</a:t>
+              <a:t>Tabs 2, 3 and 4 redefine by shadowing; reclaiming dictionary space means Reset.</a:t>
             </a:r>
             <a:endParaRPr lang="en-US" sz="1100" dirty="0"/>
           </a:p>
@@ -19373,7 +19821,7 @@
       </p:sp>
       <p:sp>
         <p:nvSpPr>
-          <p:cNvPr id="15" name="quirk icon 209"/>
+          <p:cNvPr id="15" name="quirk icon 221"/>
           <p:cNvSpPr/>
           <p:nvPr/>
         </p:nvSpPr>
@@ -19398,7 +19846,7 @@
       </p:sp>
       <p:sp>
         <p:nvSpPr>
-          <p:cNvPr id="16" name="quirk glyph 210"/>
+          <p:cNvPr id="16" name="quirk glyph 222"/>
           <p:cNvSpPr txBox="1"/>
           <p:nvPr/>
         </p:nvSpPr>
@@ -19426,7 +19874,7 @@
                   <a:schemeClr val="bg1"/>
                 </a:solidFill>
               </a:rPr>
-              <a:t>T</a:t>
+              <a:t>S</a:t>
             </a:r>
             <a:endParaRPr lang="en-US" sz="1400" dirty="0"/>
           </a:p>
@@ -19434,7 +19882,7 @@
       </p:sp>
       <p:sp>
         <p:nvSpPr>
-          <p:cNvPr id="17" name="quirk head 211"/>
+          <p:cNvPr id="17" name="quirk head 223"/>
           <p:cNvSpPr txBox="1"/>
           <p:nvPr/>
         </p:nvSpPr>
@@ -19462,7 +19910,7 @@
                   <a:schemeClr val="tx1"/>
                 </a:solidFill>
               </a:rPr>
-              <a:t>Test loose ends</a:t>
+              <a:t>Tab 3 starts with a stray stack cell</a:t>
             </a:r>
             <a:endParaRPr lang="en-US" sz="1400" dirty="0"/>
           </a:p>
@@ -19470,7 +19918,7 @@
       </p:sp>
       <p:sp>
         <p:nvSpPr>
-          <p:cNvPr id="18" name="quirk body 212"/>
+          <p:cNvPr id="18" name="quirk body 224"/>
           <p:cNvSpPr txBox="1"/>
           <p:nvPr/>
         </p:nvSpPr>
@@ -19498,7 +19946,7 @@
                   <a:schemeClr val="tx1"/>
                 </a:solidFill>
               </a:rPr>
-              <a:t>The 83-test reg-rs suite passes, but the 600 M-instruction stack-leak test can time out under --parallel and passes alone. The web help doc test lists 12 kernel words with no reference entry.</a:t>
+              <a:t>Its asm bootstrap prints ? ? ? while loading the core and leaves 3051 behind, so .S shows &lt;4&gt; for three items. Tab 4 has no bootstrap and starts clean.</a:t>
             </a:r>
             <a:endParaRPr lang="en-US" sz="1100" dirty="0"/>
           </a:p>
@@ -19644,7 +20092,7 @@
                   <a:schemeClr val="accent1"/>
                 </a:solidFill>
               </a:rPr>
-              <a:t>sw-embed.github.io/web-sw-cor24-forth (three kernels, press ? for the guide)  ·  swtos.softwarewrighter.com/forth/ (forth.s as an SWTOS pane: bg forth)</a:t>
+              <a:t>sw-embed.github.io/web-sw-cor24-forth (four kernels, tab 4 by default; ? for the guide)  ·  swtos.softwarewrighter.com/forth/ (forth.s as an SWTOS pane: bg forth)</a:t>
             </a:r>
             <a:endParaRPr lang="en-US" sz="1800" dirty="0"/>
           </a:p>
@@ -19688,7 +20136,7 @@
       </p:sp>
       <p:sp>
         <p:nvSpPr>
-          <p:cNvPr id="5" name="link label 213"/>
+          <p:cNvPr id="5" name="link label 225"/>
           <p:cNvSpPr txBox="1"/>
           <p:nvPr/>
         </p:nvSpPr>
@@ -19724,7 +20172,7 @@
       </p:sp>
       <p:sp>
         <p:nvSpPr>
-          <p:cNvPr id="6" name="link url 214"/>
+          <p:cNvPr id="6" name="link url 226"/>
           <p:cNvSpPr txBox="1"/>
           <p:nvPr/>
         </p:nvSpPr>
@@ -19763,7 +20211,7 @@
       </p:sp>
       <p:sp>
         <p:nvSpPr>
-          <p:cNvPr id="7" name="link label 215"/>
+          <p:cNvPr id="7" name="link label 227"/>
           <p:cNvSpPr txBox="1"/>
           <p:nvPr/>
         </p:nvSpPr>
@@ -19799,7 +20247,7 @@
       </p:sp>
       <p:sp>
         <p:nvSpPr>
-          <p:cNvPr id="8" name="link url 216"/>
+          <p:cNvPr id="8" name="link url 228"/>
           <p:cNvSpPr txBox="1"/>
           <p:nvPr/>
         </p:nvSpPr>
@@ -19838,7 +20286,7 @@
       </p:sp>
       <p:sp>
         <p:nvSpPr>
-          <p:cNvPr id="9" name="link label 217"/>
+          <p:cNvPr id="9" name="link label 229"/>
           <p:cNvSpPr txBox="1"/>
           <p:nvPr/>
         </p:nvSpPr>
@@ -19874,7 +20322,7 @@
       </p:sp>
       <p:sp>
         <p:nvSpPr>
-          <p:cNvPr id="10" name="link url 218"/>
+          <p:cNvPr id="10" name="link url 230"/>
           <p:cNvSpPr txBox="1"/>
           <p:nvPr/>
         </p:nvSpPr>
@@ -19913,7 +20361,7 @@
       </p:sp>
       <p:sp>
         <p:nvSpPr>
-          <p:cNvPr id="11" name="link label 219"/>
+          <p:cNvPr id="11" name="link label 231"/>
           <p:cNvSpPr txBox="1"/>
           <p:nvPr/>
         </p:nvSpPr>
@@ -19949,7 +20397,7 @@
       </p:sp>
       <p:sp>
         <p:nvSpPr>
-          <p:cNvPr id="12" name="link url 220"/>
+          <p:cNvPr id="12" name="link url 232"/>
           <p:cNvSpPr txBox="1"/>
           <p:nvPr/>
         </p:nvSpPr>
@@ -19988,7 +20436,7 @@
       </p:sp>
       <p:sp>
         <p:nvSpPr>
-          <p:cNvPr id="13" name="link label 221"/>
+          <p:cNvPr id="13" name="link label 233"/>
           <p:cNvSpPr txBox="1"/>
           <p:nvPr/>
         </p:nvSpPr>
@@ -20024,7 +20472,7 @@
       </p:sp>
       <p:sp>
         <p:nvSpPr>
-          <p:cNvPr id="14" name="link url 222"/>
+          <p:cNvPr id="14" name="link url 234"/>
           <p:cNvSpPr txBox="1"/>
           <p:nvPr/>
         </p:nvSpPr>
@@ -20063,7 +20511,7 @@
       </p:sp>
       <p:sp>
         <p:nvSpPr>
-          <p:cNvPr id="15" name="link label 223"/>
+          <p:cNvPr id="15" name="link label 235"/>
           <p:cNvSpPr txBox="1"/>
           <p:nvPr/>
         </p:nvSpPr>
@@ -20099,7 +20547,7 @@
       </p:sp>
       <p:sp>
         <p:nvSpPr>
-          <p:cNvPr id="16" name="link url 224"/>
+          <p:cNvPr id="16" name="link url 236"/>
           <p:cNvSpPr txBox="1"/>
           <p:nvPr/>
         </p:nvSpPr>
@@ -23342,7 +23790,7 @@
                   <a:schemeClr val="tx1"/>
                 </a:solidFill>
               </a:rPr>
-              <a:t>Design shared by all three kernels</a:t>
+              <a:t>Design shared by all four kernels</a:t>
             </a:r>
             <a:endParaRPr lang="en-US" sz="2600" dirty="0"/>
           </a:p>
@@ -24982,7 +25430,7 @@
                           <a:ea typeface="Calibri" pitchFamily="34" charset="-122"/>
                           <a:cs typeface="Calibri" pitchFamily="34" charset="-120"/>
                         </a:rPr>
-                        <a:t>asm, down to ~22 prims + Forth</a:t>
+                        <a:t>asm prims + Forth; tab 4 compiled by Forth</a:t>
                       </a:r>
                       <a:endParaRPr lang="en-US" sz="1000" dirty="0">
                         <a:latin typeface="Calibri" charset="0"/>
@@ -27330,7 +27778,7 @@
                   <a:schemeClr val="bg1"/>
                 </a:solidFill>
               </a:rPr>
-              <a:t>Three implementations</a:t>
+              <a:t>Four implementations</a:t>
             </a:r>
             <a:endParaRPr lang="en-US" sz="3600" dirty="0"/>
           </a:p>
@@ -27431,7 +27879,7 @@
                   <a:schemeClr val="tx1"/>
                 </a:solidFill>
               </a:rPr>
-              <a:t>One language, three kernels (and a fourth under way)</a:t>
+              <a:t>One language, four kernels</a:t>
             </a:r>
             <a:endParaRPr lang="en-US" sz="2600" dirty="0"/>
           </a:p>
@@ -27446,11 +27894,11 @@
         <p:spPr>
           <a:xfrm>
             <a:off x="457200" y="914400"/>
-            <a:ext cx="2651760" cy="3246120"/>
+            <a:ext cx="1975104" cy="3383280"/>
           </a:xfrm>
           <a:prstGeom prst="roundRect">
             <a:avLst>
-              <a:gd name="adj" fmla="val 3448"/>
+              <a:gd name="adj" fmla="val 4630"/>
             </a:avLst>
           </a:prstGeom>
           <a:solidFill>
@@ -27472,8 +27920,8 @@
         </p:nvSpPr>
         <p:spPr>
           <a:xfrm>
-            <a:off x="603504" y="1042416"/>
-            <a:ext cx="365760" cy="365760"/>
+            <a:off x="585216" y="1024128"/>
+            <a:ext cx="329184" cy="329184"/>
           </a:xfrm>
           <a:prstGeom prst="ellipse">
             <a:avLst/>
@@ -27497,8 +27945,8 @@
         </p:nvSpPr>
         <p:spPr>
           <a:xfrm>
-            <a:off x="603504" y="1042416"/>
-            <a:ext cx="365760" cy="365760"/>
+            <a:off x="585216" y="1024128"/>
+            <a:ext cx="329184" cy="329184"/>
           </a:xfrm>
           <a:prstGeom prst="rect">
             <a:avLst/>
@@ -27514,14 +27962,14 @@
               <a:buNone/>
             </a:pPr>
             <a:r>
-              <a:rPr lang="en-US" sz="1400" b="1" dirty="0">
+              <a:rPr lang="en-US" sz="1300" b="1" dirty="0">
                 <a:solidFill>
                   <a:schemeClr val="bg1"/>
                 </a:solidFill>
               </a:rPr>
               <a:t>1</a:t>
             </a:r>
-            <a:endParaRPr lang="en-US" sz="1400" dirty="0"/>
+            <a:endParaRPr lang="en-US" sz="1300" dirty="0"/>
           </a:p>
         </p:txBody>
       </p:sp>
@@ -27533,8 +27981,8 @@
         </p:nvSpPr>
         <p:spPr>
           <a:xfrm>
-            <a:off x="1060704" y="1005840"/>
-            <a:ext cx="1920240" cy="274320"/>
+            <a:off x="987552" y="1005840"/>
+            <a:ext cx="1371600" cy="365760"/>
           </a:xfrm>
           <a:prstGeom prst="rect">
             <a:avLst/>
@@ -27550,17 +27998,14 @@
               <a:buNone/>
             </a:pPr>
             <a:r>
-              <a:rPr lang="en-US" sz="1400" b="1" dirty="0">
+              <a:rPr lang="en-US" sz="1250" b="1" dirty="0">
                 <a:solidFill>
                   <a:schemeClr val="tx1"/>
                 </a:solidFill>
-                <a:latin typeface="Courier New" pitchFamily="34" charset="0"/>
-                <a:ea typeface="Courier New" pitchFamily="34" charset="-122"/>
-                <a:cs typeface="Courier New" pitchFamily="34" charset="-120"/>
               </a:rPr>
               <a:t>forth.s</a:t>
             </a:r>
-            <a:endParaRPr lang="en-US" sz="1400" dirty="0"/>
+            <a:endParaRPr lang="en-US" sz="1250" dirty="0"/>
           </a:p>
         </p:txBody>
       </p:sp>
@@ -27572,8 +28017,8 @@
         </p:nvSpPr>
         <p:spPr>
           <a:xfrm>
-            <a:off x="1060704" y="1261872"/>
-            <a:ext cx="1920240" cy="274320"/>
+            <a:off x="585216" y="1417320"/>
+            <a:ext cx="1719072" cy="274320"/>
           </a:xfrm>
           <a:prstGeom prst="rect">
             <a:avLst/>
@@ -27589,14 +28034,14 @@
               <a:buNone/>
             </a:pPr>
             <a:r>
-              <a:rPr lang="en-US" sz="1050" i="1" dirty="0">
+              <a:rPr lang="en-US" sz="1000" i="1" dirty="0">
                 <a:solidFill>
                   <a:schemeClr val="tx1"/>
                 </a:solidFill>
               </a:rPr>
               <a:t>All-assembly kernel</a:t>
             </a:r>
-            <a:endParaRPr lang="en-US" sz="1050" dirty="0"/>
+            <a:endParaRPr lang="en-US" sz="1000" dirty="0"/>
           </a:p>
         </p:txBody>
       </p:sp>
@@ -27608,8 +28053,8 @@
         </p:nvSpPr>
         <p:spPr>
           <a:xfrm>
-            <a:off x="603504" y="1645920"/>
-            <a:ext cx="1005840" cy="457200"/>
+            <a:off x="585216" y="1783080"/>
+            <a:ext cx="1719072" cy="274320"/>
           </a:xfrm>
           <a:prstGeom prst="rect">
             <a:avLst/>
@@ -27625,14 +28070,14 @@
               <a:buNone/>
             </a:pPr>
             <a:r>
-              <a:rPr lang="en-US" sz="2000" b="1" dirty="0">
+              <a:rPr lang="en-US" sz="1700" b="1" dirty="0">
                 <a:solidFill>
                   <a:schemeClr val="accent1"/>
                 </a:solidFill>
               </a:rPr>
               <a:t>3,498</a:t>
             </a:r>
-            <a:endParaRPr lang="en-US" sz="2000" dirty="0"/>
+            <a:endParaRPr lang="en-US" sz="1700" dirty="0"/>
           </a:p>
         </p:txBody>
       </p:sp>
@@ -27644,8 +28089,44 @@
         </p:nvSpPr>
         <p:spPr>
           <a:xfrm>
-            <a:off x="1627632" y="1645920"/>
-            <a:ext cx="1335024" cy="457200"/>
+            <a:off x="585216" y="2057400"/>
+            <a:ext cx="1719072" cy="274320"/>
+          </a:xfrm>
+          <a:prstGeom prst="rect">
+            <a:avLst/>
+          </a:prstGeom>
+          <a:noFill/>
+          <a:ln/>
+        </p:spPr>
+        <p:txBody>
+          <a:bodyPr wrap="square" lIns="0" tIns="0" rIns="0" bIns="0" rtlCol="0" anchor="t"/>
+          <a:lstStyle/>
+          <a:p>
+            <a:pPr indent="0" marL="0">
+              <a:buNone/>
+            </a:pPr>
+            <a:r>
+              <a:rPr lang="en-US" sz="1000" dirty="0">
+                <a:solidFill>
+                  <a:schemeClr val="tx1"/>
+                </a:solidFill>
+              </a:rPr>
+              <a:t>lines of asm</a:t>
+            </a:r>
+            <a:endParaRPr lang="en-US" sz="1000" dirty="0"/>
+          </a:p>
+        </p:txBody>
+      </p:sp>
+      <p:sp>
+        <p:nvSpPr>
+          <p:cNvPr id="10" name="kernel stat 74"/>
+          <p:cNvSpPr txBox="1"/>
+          <p:nvPr/>
+        </p:nvSpPr>
+        <p:spPr>
+          <a:xfrm>
+            <a:off x="585216" y="2350008"/>
+            <a:ext cx="1719072" cy="274320"/>
           </a:xfrm>
           <a:prstGeom prst="rect">
             <a:avLst/>
@@ -27661,27 +28142,63 @@
               <a:buNone/>
             </a:pPr>
             <a:r>
-              <a:rPr lang="en-US" sz="1050" dirty="0">
-                <a:solidFill>
-                  <a:schemeClr val="tx1"/>
-                </a:solidFill>
-              </a:rPr>
-              <a:t>lines of asm</a:t>
-            </a:r>
-            <a:endParaRPr lang="en-US" sz="1050" dirty="0"/>
+              <a:rPr lang="en-US" sz="1700" b="1" dirty="0">
+                <a:solidFill>
+                  <a:schemeClr val="accent1"/>
+                </a:solidFill>
+              </a:rPr>
+              <a:t>0</a:t>
+            </a:r>
+            <a:endParaRPr lang="en-US" sz="1700" dirty="0"/>
           </a:p>
         </p:txBody>
       </p:sp>
       <p:sp>
         <p:nvSpPr>
-          <p:cNvPr id="10" name="kernel stat 74"/>
+          <p:cNvPr id="11" name="kernel stat label 75"/>
           <p:cNvSpPr txBox="1"/>
           <p:nvPr/>
         </p:nvSpPr>
         <p:spPr>
           <a:xfrm>
-            <a:off x="603504" y="2212848"/>
-            <a:ext cx="1005840" cy="457200"/>
+            <a:off x="585216" y="2624328"/>
+            <a:ext cx="1719072" cy="274320"/>
+          </a:xfrm>
+          <a:prstGeom prst="rect">
+            <a:avLst/>
+          </a:prstGeom>
+          <a:noFill/>
+          <a:ln/>
+        </p:spPr>
+        <p:txBody>
+          <a:bodyPr wrap="square" lIns="0" tIns="0" rIns="0" bIns="0" rtlCol="0" anchor="t"/>
+          <a:lstStyle/>
+          <a:p>
+            <a:pPr indent="0" marL="0">
+              <a:buNone/>
+            </a:pPr>
+            <a:r>
+              <a:rPr lang="en-US" sz="1000" dirty="0">
+                <a:solidFill>
+                  <a:schemeClr val="tx1"/>
+                </a:solidFill>
+              </a:rPr>
+              <a:t>lines of Forth core</a:t>
+            </a:r>
+            <a:endParaRPr lang="en-US" sz="1000" dirty="0"/>
+          </a:p>
+        </p:txBody>
+      </p:sp>
+      <p:sp>
+        <p:nvSpPr>
+          <p:cNvPr id="12" name="kernel stat 76"/>
+          <p:cNvSpPr txBox="1"/>
+          <p:nvPr/>
+        </p:nvSpPr>
+        <p:spPr>
+          <a:xfrm>
+            <a:off x="585216" y="2916936"/>
+            <a:ext cx="1719072" cy="274320"/>
           </a:xfrm>
           <a:prstGeom prst="rect">
             <a:avLst/>
@@ -27697,86 +28214,14 @@
               <a:buNone/>
             </a:pPr>
             <a:r>
-              <a:rPr lang="en-US" sz="2000" b="1" dirty="0">
+              <a:rPr lang="en-US" sz="1700" b="1" dirty="0">
                 <a:solidFill>
                   <a:schemeClr val="accent1"/>
                 </a:solidFill>
               </a:rPr>
-              <a:t>0</a:t>
-            </a:r>
-            <a:endParaRPr lang="en-US" sz="2000" dirty="0"/>
-          </a:p>
-        </p:txBody>
-      </p:sp>
-      <p:sp>
-        <p:nvSpPr>
-          <p:cNvPr id="11" name="kernel stat label 75"/>
-          <p:cNvSpPr txBox="1"/>
-          <p:nvPr/>
-        </p:nvSpPr>
-        <p:spPr>
-          <a:xfrm>
-            <a:off x="1627632" y="2212848"/>
-            <a:ext cx="1335024" cy="457200"/>
-          </a:xfrm>
-          <a:prstGeom prst="rect">
-            <a:avLst/>
-          </a:prstGeom>
-          <a:noFill/>
-          <a:ln/>
-        </p:spPr>
-        <p:txBody>
-          <a:bodyPr wrap="square" lIns="0" tIns="0" rIns="0" bIns="0" rtlCol="0" anchor="ctr"/>
-          <a:lstStyle/>
-          <a:p>
-            <a:pPr indent="0" marL="0">
-              <a:buNone/>
-            </a:pPr>
-            <a:r>
-              <a:rPr lang="en-US" sz="1050" dirty="0">
-                <a:solidFill>
-                  <a:schemeClr val="tx1"/>
-                </a:solidFill>
-              </a:rPr>
-              <a:t>lines of Forth core</a:t>
-            </a:r>
-            <a:endParaRPr lang="en-US" sz="1050" dirty="0"/>
-          </a:p>
-        </p:txBody>
-      </p:sp>
-      <p:sp>
-        <p:nvSpPr>
-          <p:cNvPr id="12" name="kernel stat 76"/>
-          <p:cNvSpPr txBox="1"/>
-          <p:nvPr/>
-        </p:nvSpPr>
-        <p:spPr>
-          <a:xfrm>
-            <a:off x="603504" y="2779776"/>
-            <a:ext cx="1005840" cy="457200"/>
-          </a:xfrm>
-          <a:prstGeom prst="rect">
-            <a:avLst/>
-          </a:prstGeom>
-          <a:noFill/>
-          <a:ln/>
-        </p:spPr>
-        <p:txBody>
-          <a:bodyPr wrap="square" lIns="0" tIns="0" rIns="0" bIns="0" rtlCol="0" anchor="ctr"/>
-          <a:lstStyle/>
-          <a:p>
-            <a:pPr indent="0" marL="0">
-              <a:buNone/>
-            </a:pPr>
-            <a:r>
-              <a:rPr lang="en-US" sz="2000" b="1" dirty="0">
-                <a:solidFill>
-                  <a:schemeClr val="accent1"/>
-                </a:solidFill>
-              </a:rPr>
               <a:t>~65</a:t>
             </a:r>
-            <a:endParaRPr lang="en-US" sz="2000" dirty="0"/>
+            <a:endParaRPr lang="en-US" sz="1700" dirty="0"/>
           </a:p>
         </p:txBody>
       </p:sp>
@@ -27788,8 +28233,8 @@
         </p:nvSpPr>
         <p:spPr>
           <a:xfrm>
-            <a:off x="1627632" y="2779776"/>
-            <a:ext cx="1335024" cy="457200"/>
+            <a:off x="585216" y="3191256"/>
+            <a:ext cx="1719072" cy="274320"/>
           </a:xfrm>
           <a:prstGeom prst="rect">
             <a:avLst/>
@@ -27798,21 +28243,21 @@
           <a:ln/>
         </p:spPr>
         <p:txBody>
-          <a:bodyPr wrap="square" lIns="0" tIns="0" rIns="0" bIns="0" rtlCol="0" anchor="ctr"/>
+          <a:bodyPr wrap="square" lIns="0" tIns="0" rIns="0" bIns="0" rtlCol="0" anchor="t"/>
           <a:lstStyle/>
           <a:p>
             <a:pPr indent="0" marL="0">
               <a:buNone/>
             </a:pPr>
             <a:r>
-              <a:rPr lang="en-US" sz="1050" dirty="0">
+              <a:rPr lang="en-US" sz="1000" dirty="0">
                 <a:solidFill>
                   <a:schemeClr val="tx1"/>
                 </a:solidFill>
               </a:rPr>
-              <a:t>primitives</a:t>
-            </a:r>
-            <a:endParaRPr lang="en-US" sz="1050" dirty="0"/>
+              <a:t>asm primitives</a:t>
+            </a:r>
+            <a:endParaRPr lang="en-US" sz="1000" dirty="0"/>
           </a:p>
         </p:txBody>
       </p:sp>
@@ -27824,8 +28269,8 @@
         </p:nvSpPr>
         <p:spPr>
           <a:xfrm>
-            <a:off x="603504" y="3383280"/>
-            <a:ext cx="2359152" cy="713232"/>
+            <a:off x="585216" y="3520440"/>
+            <a:ext cx="1719072" cy="685800"/>
           </a:xfrm>
           <a:prstGeom prst="rect">
             <a:avLst/>
@@ -27841,14 +28286,14 @@
               <a:buNone/>
             </a:pPr>
             <a:r>
-              <a:rPr lang="en-US" sz="1050" dirty="0">
+              <a:rPr lang="en-US" sz="1000" dirty="0">
                 <a:solidFill>
                   <a:schemeClr val="tx1"/>
                 </a:solidFill>
               </a:rPr>
-              <a:t>Tab 1: the debugger. Canonical kernel for the FPGA board and the reg-rs golden tests.</a:t>
-            </a:r>
-            <a:endParaRPr lang="en-US" sz="1050" dirty="0"/>
+              <a:t>Tab 1: the debugger. Runs on the FPGA board; reg-rs golden tests.</a:t>
+            </a:r>
+            <a:endParaRPr lang="en-US" sz="1000" dirty="0"/>
           </a:p>
         </p:txBody>
       </p:sp>
@@ -27860,12 +28305,12 @@
         </p:nvSpPr>
         <p:spPr>
           <a:xfrm>
-            <a:off x="3246120" y="914400"/>
-            <a:ext cx="2651760" cy="3246120"/>
+            <a:off x="2542032" y="914400"/>
+            <a:ext cx="1975104" cy="3383280"/>
           </a:xfrm>
           <a:prstGeom prst="roundRect">
             <a:avLst>
-              <a:gd name="adj" fmla="val 3448"/>
+              <a:gd name="adj" fmla="val 4630"/>
             </a:avLst>
           </a:prstGeom>
           <a:solidFill>
@@ -27887,8 +28332,8 @@
         </p:nvSpPr>
         <p:spPr>
           <a:xfrm>
-            <a:off x="3392424" y="1042416"/>
-            <a:ext cx="365760" cy="365760"/>
+            <a:off x="2670048" y="1024128"/>
+            <a:ext cx="329184" cy="329184"/>
           </a:xfrm>
           <a:prstGeom prst="ellipse">
             <a:avLst/>
@@ -27912,8 +28357,8 @@
         </p:nvSpPr>
         <p:spPr>
           <a:xfrm>
-            <a:off x="3392424" y="1042416"/>
-            <a:ext cx="365760" cy="365760"/>
+            <a:off x="2670048" y="1024128"/>
+            <a:ext cx="329184" cy="329184"/>
           </a:xfrm>
           <a:prstGeom prst="rect">
             <a:avLst/>
@@ -27929,14 +28374,14 @@
               <a:buNone/>
             </a:pPr>
             <a:r>
-              <a:rPr lang="en-US" sz="1400" b="1" dirty="0">
+              <a:rPr lang="en-US" sz="1300" b="1" dirty="0">
                 <a:solidFill>
                   <a:schemeClr val="bg1"/>
                 </a:solidFill>
               </a:rPr>
               <a:t>2</a:t>
             </a:r>
-            <a:endParaRPr lang="en-US" sz="1400" dirty="0"/>
+            <a:endParaRPr lang="en-US" sz="1300" dirty="0"/>
           </a:p>
         </p:txBody>
       </p:sp>
@@ -27948,8 +28393,8 @@
         </p:nvSpPr>
         <p:spPr>
           <a:xfrm>
-            <a:off x="3849624" y="1005840"/>
-            <a:ext cx="1920240" cy="274320"/>
+            <a:off x="3072384" y="1005840"/>
+            <a:ext cx="1371600" cy="365760"/>
           </a:xfrm>
           <a:prstGeom prst="rect">
             <a:avLst/>
@@ -27965,17 +28410,14 @@
               <a:buNone/>
             </a:pPr>
             <a:r>
-              <a:rPr lang="en-US" sz="1400" b="1" dirty="0">
+              <a:rPr lang="en-US" sz="1250" b="1" dirty="0">
                 <a:solidFill>
                   <a:schemeClr val="tx1"/>
                 </a:solidFill>
-                <a:latin typeface="Courier New" pitchFamily="34" charset="0"/>
-                <a:ea typeface="Courier New" pitchFamily="34" charset="-122"/>
-                <a:cs typeface="Courier New" pitchFamily="34" charset="-120"/>
               </a:rPr>
               <a:t>forth-in-forth</a:t>
             </a:r>
-            <a:endParaRPr lang="en-US" sz="1400" dirty="0"/>
+            <a:endParaRPr lang="en-US" sz="1250" dirty="0"/>
           </a:p>
         </p:txBody>
       </p:sp>
@@ -27987,8 +28429,8 @@
         </p:nvSpPr>
         <p:spPr>
           <a:xfrm>
-            <a:off x="3849624" y="1261872"/>
-            <a:ext cx="1920240" cy="274320"/>
+            <a:off x="2670048" y="1417320"/>
+            <a:ext cx="1719072" cy="274320"/>
           </a:xfrm>
           <a:prstGeom prst="rect">
             <a:avLst/>
@@ -28004,14 +28446,14 @@
               <a:buNone/>
             </a:pPr>
             <a:r>
-              <a:rPr lang="en-US" sz="1050" i="1" dirty="0">
+              <a:rPr lang="en-US" sz="1000" i="1" dirty="0">
                 <a:solidFill>
                   <a:schemeClr val="tx1"/>
                 </a:solidFill>
               </a:rPr>
-              <a:t>Forth runs in a slimmed asm host</a:t>
-            </a:r>
-            <a:endParaRPr lang="en-US" sz="1050" dirty="0"/>
+              <a:t>Forth in a slimmed asm host</a:t>
+            </a:r>
+            <a:endParaRPr lang="en-US" sz="1000" dirty="0"/>
           </a:p>
         </p:txBody>
       </p:sp>
@@ -28023,8 +28465,8 @@
         </p:nvSpPr>
         <p:spPr>
           <a:xfrm>
-            <a:off x="3392424" y="1645920"/>
-            <a:ext cx="1005840" cy="457200"/>
+            <a:off x="2670048" y="1783080"/>
+            <a:ext cx="1719072" cy="274320"/>
           </a:xfrm>
           <a:prstGeom prst="rect">
             <a:avLst/>
@@ -28040,14 +28482,14 @@
               <a:buNone/>
             </a:pPr>
             <a:r>
-              <a:rPr lang="en-US" sz="2000" b="1" dirty="0">
+              <a:rPr lang="en-US" sz="1700" b="1" dirty="0">
                 <a:solidFill>
                   <a:schemeClr val="accent2"/>
                 </a:solidFill>
               </a:rPr>
               <a:t>2,720</a:t>
             </a:r>
-            <a:endParaRPr lang="en-US" sz="2000" dirty="0"/>
+            <a:endParaRPr lang="en-US" sz="1700" dirty="0"/>
           </a:p>
         </p:txBody>
       </p:sp>
@@ -28059,8 +28501,44 @@
         </p:nvSpPr>
         <p:spPr>
           <a:xfrm>
-            <a:off x="4416552" y="1645920"/>
-            <a:ext cx="1335024" cy="457200"/>
+            <a:off x="2670048" y="2057400"/>
+            <a:ext cx="1719072" cy="274320"/>
+          </a:xfrm>
+          <a:prstGeom prst="rect">
+            <a:avLst/>
+          </a:prstGeom>
+          <a:noFill/>
+          <a:ln/>
+        </p:spPr>
+        <p:txBody>
+          <a:bodyPr wrap="square" lIns="0" tIns="0" rIns="0" bIns="0" rtlCol="0" anchor="t"/>
+          <a:lstStyle/>
+          <a:p>
+            <a:pPr indent="0" marL="0">
+              <a:buNone/>
+            </a:pPr>
+            <a:r>
+              <a:rPr lang="en-US" sz="1000" dirty="0">
+                <a:solidFill>
+                  <a:schemeClr val="tx1"/>
+                </a:solidFill>
+              </a:rPr>
+              <a:t>lines of asm</a:t>
+            </a:r>
+            <a:endParaRPr lang="en-US" sz="1000" dirty="0"/>
+          </a:p>
+        </p:txBody>
+      </p:sp>
+      <p:sp>
+        <p:nvSpPr>
+          <p:cNvPr id="22" name="kernel stat 86"/>
+          <p:cNvSpPr txBox="1"/>
+          <p:nvPr/>
+        </p:nvSpPr>
+        <p:spPr>
+          <a:xfrm>
+            <a:off x="2670048" y="2350008"/>
+            <a:ext cx="1719072" cy="274320"/>
           </a:xfrm>
           <a:prstGeom prst="rect">
             <a:avLst/>
@@ -28076,27 +28554,63 @@
               <a:buNone/>
             </a:pPr>
             <a:r>
-              <a:rPr lang="en-US" sz="1050" dirty="0">
-                <a:solidFill>
-                  <a:schemeClr val="tx1"/>
-                </a:solidFill>
-              </a:rPr>
-              <a:t>lines of asm</a:t>
-            </a:r>
-            <a:endParaRPr lang="en-US" sz="1050" dirty="0"/>
+              <a:rPr lang="en-US" sz="1700" b="1" dirty="0">
+                <a:solidFill>
+                  <a:schemeClr val="accent2"/>
+                </a:solidFill>
+              </a:rPr>
+              <a:t>276</a:t>
+            </a:r>
+            <a:endParaRPr lang="en-US" sz="1700" dirty="0"/>
           </a:p>
         </p:txBody>
       </p:sp>
       <p:sp>
         <p:nvSpPr>
-          <p:cNvPr id="22" name="kernel stat 86"/>
+          <p:cNvPr id="23" name="kernel stat label 87"/>
           <p:cNvSpPr txBox="1"/>
           <p:nvPr/>
         </p:nvSpPr>
         <p:spPr>
           <a:xfrm>
-            <a:off x="3392424" y="2212848"/>
-            <a:ext cx="1005840" cy="457200"/>
+            <a:off x="2670048" y="2624328"/>
+            <a:ext cx="1719072" cy="274320"/>
+          </a:xfrm>
+          <a:prstGeom prst="rect">
+            <a:avLst/>
+          </a:prstGeom>
+          <a:noFill/>
+          <a:ln/>
+        </p:spPr>
+        <p:txBody>
+          <a:bodyPr wrap="square" lIns="0" tIns="0" rIns="0" bIns="0" rtlCol="0" anchor="t"/>
+          <a:lstStyle/>
+          <a:p>
+            <a:pPr indent="0" marL="0">
+              <a:buNone/>
+            </a:pPr>
+            <a:r>
+              <a:rPr lang="en-US" sz="1000" dirty="0">
+                <a:solidFill>
+                  <a:schemeClr val="tx1"/>
+                </a:solidFill>
+              </a:rPr>
+              <a:t>lines in 4 core tiers</a:t>
+            </a:r>
+            <a:endParaRPr lang="en-US" sz="1000" dirty="0"/>
+          </a:p>
+        </p:txBody>
+      </p:sp>
+      <p:sp>
+        <p:nvSpPr>
+          <p:cNvPr id="24" name="kernel stat 88"/>
+          <p:cNvSpPr txBox="1"/>
+          <p:nvPr/>
+        </p:nvSpPr>
+        <p:spPr>
+          <a:xfrm>
+            <a:off x="2670048" y="2916936"/>
+            <a:ext cx="1719072" cy="274320"/>
           </a:xfrm>
           <a:prstGeom prst="rect">
             <a:avLst/>
@@ -28112,86 +28626,14 @@
               <a:buNone/>
             </a:pPr>
             <a:r>
-              <a:rPr lang="en-US" sz="2000" b="1" dirty="0">
+              <a:rPr lang="en-US" sz="1700" b="1" dirty="0">
                 <a:solidFill>
                   <a:schemeClr val="accent2"/>
                 </a:solidFill>
               </a:rPr>
-              <a:t>276</a:t>
-            </a:r>
-            <a:endParaRPr lang="en-US" sz="2000" dirty="0"/>
-          </a:p>
-        </p:txBody>
-      </p:sp>
-      <p:sp>
-        <p:nvSpPr>
-          <p:cNvPr id="23" name="kernel stat label 87"/>
-          <p:cNvSpPr txBox="1"/>
-          <p:nvPr/>
-        </p:nvSpPr>
-        <p:spPr>
-          <a:xfrm>
-            <a:off x="4416552" y="2212848"/>
-            <a:ext cx="1335024" cy="457200"/>
-          </a:xfrm>
-          <a:prstGeom prst="rect">
-            <a:avLst/>
-          </a:prstGeom>
-          <a:noFill/>
-          <a:ln/>
-        </p:spPr>
-        <p:txBody>
-          <a:bodyPr wrap="square" lIns="0" tIns="0" rIns="0" bIns="0" rtlCol="0" anchor="ctr"/>
-          <a:lstStyle/>
-          <a:p>
-            <a:pPr indent="0" marL="0">
-              <a:buNone/>
-            </a:pPr>
-            <a:r>
-              <a:rPr lang="en-US" sz="1050" dirty="0">
-                <a:solidFill>
-                  <a:schemeClr val="tx1"/>
-                </a:solidFill>
-              </a:rPr>
-              <a:t>lines in 4 core tiers</a:t>
-            </a:r>
-            <a:endParaRPr lang="en-US" sz="1050" dirty="0"/>
-          </a:p>
-        </p:txBody>
-      </p:sp>
-      <p:sp>
-        <p:nvSpPr>
-          <p:cNvPr id="24" name="kernel stat 88"/>
-          <p:cNvSpPr txBox="1"/>
-          <p:nvPr/>
-        </p:nvSpPr>
-        <p:spPr>
-          <a:xfrm>
-            <a:off x="3392424" y="2779776"/>
-            <a:ext cx="1005840" cy="457200"/>
-          </a:xfrm>
-          <a:prstGeom prst="rect">
-            <a:avLst/>
-          </a:prstGeom>
-          <a:noFill/>
-          <a:ln/>
-        </p:spPr>
-        <p:txBody>
-          <a:bodyPr wrap="square" lIns="0" tIns="0" rIns="0" bIns="0" rtlCol="0" anchor="ctr"/>
-          <a:lstStyle/>
-          <a:p>
-            <a:pPr indent="0" marL="0">
-              <a:buNone/>
-            </a:pPr>
-            <a:r>
-              <a:rPr lang="en-US" sz="2000" b="1" dirty="0">
-                <a:solidFill>
-                  <a:schemeClr val="accent2"/>
-                </a:solidFill>
-              </a:rPr>
               <a:t>50</a:t>
             </a:r>
-            <a:endParaRPr lang="en-US" sz="2000" dirty="0"/>
+            <a:endParaRPr lang="en-US" sz="1700" dirty="0"/>
           </a:p>
         </p:txBody>
       </p:sp>
@@ -28203,8 +28645,8 @@
         </p:nvSpPr>
         <p:spPr>
           <a:xfrm>
-            <a:off x="4416552" y="2779776"/>
-            <a:ext cx="1335024" cy="457200"/>
+            <a:off x="2670048" y="3191256"/>
+            <a:ext cx="1719072" cy="274320"/>
           </a:xfrm>
           <a:prstGeom prst="rect">
             <a:avLst/>
@@ -28213,21 +28655,21 @@
           <a:ln/>
         </p:spPr>
         <p:txBody>
-          <a:bodyPr wrap="square" lIns="0" tIns="0" rIns="0" bIns="0" rtlCol="0" anchor="ctr"/>
+          <a:bodyPr wrap="square" lIns="0" tIns="0" rIns="0" bIns="0" rtlCol="0" anchor="t"/>
           <a:lstStyle/>
           <a:p>
             <a:pPr indent="0" marL="0">
               <a:buNone/>
             </a:pPr>
             <a:r>
-              <a:rPr lang="en-US" sz="1050" dirty="0">
+              <a:rPr lang="en-US" sz="1000" dirty="0">
                 <a:solidFill>
                   <a:schemeClr val="tx1"/>
                 </a:solidFill>
               </a:rPr>
-              <a:t>primitives, 61 colon words</a:t>
-            </a:r>
-            <a:endParaRPr lang="en-US" sz="1050" dirty="0"/>
+              <a:t>asm primitives</a:t>
+            </a:r>
+            <a:endParaRPr lang="en-US" sz="1000" dirty="0"/>
           </a:p>
         </p:txBody>
       </p:sp>
@@ -28239,8 +28681,8 @@
         </p:nvSpPr>
         <p:spPr>
           <a:xfrm>
-            <a:off x="3392424" y="3383280"/>
-            <a:ext cx="2359152" cy="713232"/>
+            <a:off x="2670048" y="3520440"/>
+            <a:ext cx="1719072" cy="685800"/>
           </a:xfrm>
           <a:prstGeom prst="rect">
             <a:avLst/>
@@ -28256,14 +28698,14 @@
               <a:buNone/>
             </a:pPr>
             <a:r>
-              <a:rPr lang="en-US" sz="1050" dirty="0">
+              <a:rPr lang="en-US" sz="1000" dirty="0">
                 <a:solidFill>
                   <a:schemeClr val="tx1"/>
                 </a:solidFill>
               </a:rPr>
-              <a:t>Tab 2: self-hosting REPL. IF, ., WORDS, SEE are Forth.</a:t>
-            </a:r>
-            <a:endParaRPr lang="en-US" sz="1050" dirty="0"/>
+              <a:t>Tab 2: IF, ., WORDS and SEE are Forth, loaded at boot.</a:t>
+            </a:r>
+            <a:endParaRPr lang="en-US" sz="1000" dirty="0"/>
           </a:p>
         </p:txBody>
       </p:sp>
@@ -28275,12 +28717,12 @@
         </p:nvSpPr>
         <p:spPr>
           <a:xfrm>
-            <a:off x="6035040" y="914400"/>
-            <a:ext cx="2651760" cy="3246120"/>
+            <a:off x="4626864" y="914400"/>
+            <a:ext cx="1975104" cy="3383280"/>
           </a:xfrm>
           <a:prstGeom prst="roundRect">
             <a:avLst>
-              <a:gd name="adj" fmla="val 3448"/>
+              <a:gd name="adj" fmla="val 4630"/>
             </a:avLst>
           </a:prstGeom>
           <a:solidFill>
@@ -28302,8 +28744,8 @@
         </p:nvSpPr>
         <p:spPr>
           <a:xfrm>
-            <a:off x="6181344" y="1042416"/>
-            <a:ext cx="365760" cy="365760"/>
+            <a:off x="4754880" y="1024128"/>
+            <a:ext cx="329184" cy="329184"/>
           </a:xfrm>
           <a:prstGeom prst="ellipse">
             <a:avLst/>
@@ -28327,8 +28769,8 @@
         </p:nvSpPr>
         <p:spPr>
           <a:xfrm>
-            <a:off x="6181344" y="1042416"/>
-            <a:ext cx="365760" cy="365760"/>
+            <a:off x="4754880" y="1024128"/>
+            <a:ext cx="329184" cy="329184"/>
           </a:xfrm>
           <a:prstGeom prst="rect">
             <a:avLst/>
@@ -28344,14 +28786,14 @@
               <a:buNone/>
             </a:pPr>
             <a:r>
-              <a:rPr lang="en-US" sz="1400" b="1" dirty="0">
+              <a:rPr lang="en-US" sz="1300" b="1" dirty="0">
                 <a:solidFill>
                   <a:schemeClr val="bg1"/>
                 </a:solidFill>
               </a:rPr>
               <a:t>3</a:t>
             </a:r>
-            <a:endParaRPr lang="en-US" sz="1400" dirty="0"/>
+            <a:endParaRPr lang="en-US" sz="1300" dirty="0"/>
           </a:p>
         </p:txBody>
       </p:sp>
@@ -28363,8 +28805,8 @@
         </p:nvSpPr>
         <p:spPr>
           <a:xfrm>
-            <a:off x="6638544" y="1005840"/>
-            <a:ext cx="1920240" cy="274320"/>
+            <a:off x="5157216" y="1005840"/>
+            <a:ext cx="1371600" cy="365760"/>
           </a:xfrm>
           <a:prstGeom prst="rect">
             <a:avLst/>
@@ -28380,17 +28822,14 @@
               <a:buNone/>
             </a:pPr>
             <a:r>
-              <a:rPr lang="en-US" sz="1400" b="1" dirty="0">
+              <a:rPr lang="en-US" sz="1250" b="1" dirty="0">
                 <a:solidFill>
                   <a:schemeClr val="tx1"/>
                 </a:solidFill>
-                <a:latin typeface="Courier New" pitchFamily="34" charset="0"/>
-                <a:ea typeface="Courier New" pitchFamily="34" charset="-122"/>
-                <a:cs typeface="Courier New" pitchFamily="34" charset="-120"/>
               </a:rPr>
               <a:t>forth-on-forthish</a:t>
             </a:r>
-            <a:endParaRPr lang="en-US" sz="1400" dirty="0"/>
+            <a:endParaRPr lang="en-US" sz="1250" dirty="0"/>
           </a:p>
         </p:txBody>
       </p:sp>
@@ -28402,8 +28841,8 @@
         </p:nvSpPr>
         <p:spPr>
           <a:xfrm>
-            <a:off x="6638544" y="1261872"/>
-            <a:ext cx="1920240" cy="274320"/>
+            <a:off x="4754880" y="1417320"/>
+            <a:ext cx="1719072" cy="274320"/>
           </a:xfrm>
           <a:prstGeom prst="rect">
             <a:avLst/>
@@ -28419,14 +28858,14 @@
               <a:buNone/>
             </a:pPr>
             <a:r>
-              <a:rPr lang="en-US" sz="1050" i="1" dirty="0">
+              <a:rPr lang="en-US" sz="1000" i="1" dirty="0">
                 <a:solidFill>
                   <a:schemeClr val="tx1"/>
                 </a:solidFill>
               </a:rPr>
               <a:t>Forth on a Forth-ish substrate</a:t>
             </a:r>
-            <a:endParaRPr lang="en-US" sz="1050" dirty="0"/>
+            <a:endParaRPr lang="en-US" sz="1000" dirty="0"/>
           </a:p>
         </p:txBody>
       </p:sp>
@@ -28438,8 +28877,8 @@
         </p:nvSpPr>
         <p:spPr>
           <a:xfrm>
-            <a:off x="6181344" y="1645920"/>
-            <a:ext cx="1005840" cy="457200"/>
+            <a:off x="4754880" y="1783080"/>
+            <a:ext cx="1719072" cy="274320"/>
           </a:xfrm>
           <a:prstGeom prst="rect">
             <a:avLst/>
@@ -28455,14 +28894,14 @@
               <a:buNone/>
             </a:pPr>
             <a:r>
-              <a:rPr lang="en-US" sz="2000" b="1" dirty="0">
+              <a:rPr lang="en-US" sz="1700" b="1" dirty="0">
                 <a:solidFill>
                   <a:schemeClr val="accent3"/>
                 </a:solidFill>
               </a:rPr>
               <a:t>2,659</a:t>
             </a:r>
-            <a:endParaRPr lang="en-US" sz="2000" dirty="0"/>
+            <a:endParaRPr lang="en-US" sz="1700" dirty="0"/>
           </a:p>
         </p:txBody>
       </p:sp>
@@ -28474,8 +28913,44 @@
         </p:nvSpPr>
         <p:spPr>
           <a:xfrm>
-            <a:off x="7205472" y="1645920"/>
-            <a:ext cx="1335024" cy="457200"/>
+            <a:off x="4754880" y="2057400"/>
+            <a:ext cx="1719072" cy="274320"/>
+          </a:xfrm>
+          <a:prstGeom prst="rect">
+            <a:avLst/>
+          </a:prstGeom>
+          <a:noFill/>
+          <a:ln/>
+        </p:spPr>
+        <p:txBody>
+          <a:bodyPr wrap="square" lIns="0" tIns="0" rIns="0" bIns="0" rtlCol="0" anchor="t"/>
+          <a:lstStyle/>
+          <a:p>
+            <a:pPr indent="0" marL="0">
+              <a:buNone/>
+            </a:pPr>
+            <a:r>
+              <a:rPr lang="en-US" sz="1000" dirty="0">
+                <a:solidFill>
+                  <a:schemeClr val="tx1"/>
+                </a:solidFill>
+              </a:rPr>
+              <a:t>lines of asm</a:t>
+            </a:r>
+            <a:endParaRPr lang="en-US" sz="1000" dirty="0"/>
+          </a:p>
+        </p:txBody>
+      </p:sp>
+      <p:sp>
+        <p:nvSpPr>
+          <p:cNvPr id="34" name="kernel stat 98"/>
+          <p:cNvSpPr txBox="1"/>
+          <p:nvPr/>
+        </p:nvSpPr>
+        <p:spPr>
+          <a:xfrm>
+            <a:off x="4754880" y="2350008"/>
+            <a:ext cx="1719072" cy="274320"/>
           </a:xfrm>
           <a:prstGeom prst="rect">
             <a:avLst/>
@@ -28491,27 +28966,63 @@
               <a:buNone/>
             </a:pPr>
             <a:r>
-              <a:rPr lang="en-US" sz="1050" dirty="0">
-                <a:solidFill>
-                  <a:schemeClr val="tx1"/>
-                </a:solidFill>
-              </a:rPr>
-              <a:t>lines of asm (see note)</a:t>
-            </a:r>
-            <a:endParaRPr lang="en-US" sz="1050" dirty="0"/>
+              <a:rPr lang="en-US" sz="1700" b="1" dirty="0">
+                <a:solidFill>
+                  <a:schemeClr val="accent3"/>
+                </a:solidFill>
+              </a:rPr>
+              <a:t>497</a:t>
+            </a:r>
+            <a:endParaRPr lang="en-US" sz="1700" dirty="0"/>
           </a:p>
         </p:txBody>
       </p:sp>
       <p:sp>
         <p:nvSpPr>
-          <p:cNvPr id="34" name="kernel stat 98"/>
+          <p:cNvPr id="35" name="kernel stat label 99"/>
           <p:cNvSpPr txBox="1"/>
           <p:nvPr/>
         </p:nvSpPr>
         <p:spPr>
           <a:xfrm>
-            <a:off x="6181344" y="2212848"/>
-            <a:ext cx="1005840" cy="457200"/>
+            <a:off x="4754880" y="2624328"/>
+            <a:ext cx="1719072" cy="274320"/>
+          </a:xfrm>
+          <a:prstGeom prst="rect">
+            <a:avLst/>
+          </a:prstGeom>
+          <a:noFill/>
+          <a:ln/>
+        </p:spPr>
+        <p:txBody>
+          <a:bodyPr wrap="square" lIns="0" tIns="0" rIns="0" bIns="0" rtlCol="0" anchor="t"/>
+          <a:lstStyle/>
+          <a:p>
+            <a:pPr indent="0" marL="0">
+              <a:buNone/>
+            </a:pPr>
+            <a:r>
+              <a:rPr lang="en-US" sz="1000" dirty="0">
+                <a:solidFill>
+                  <a:schemeClr val="tx1"/>
+                </a:solidFill>
+              </a:rPr>
+              <a:t>lines in 5 core tiers</a:t>
+            </a:r>
+            <a:endParaRPr lang="en-US" sz="1000" dirty="0"/>
+          </a:p>
+        </p:txBody>
+      </p:sp>
+      <p:sp>
+        <p:nvSpPr>
+          <p:cNvPr id="36" name="kernel stat 100"/>
+          <p:cNvSpPr txBox="1"/>
+          <p:nvPr/>
+        </p:nvSpPr>
+        <p:spPr>
+          <a:xfrm>
+            <a:off x="4754880" y="2916936"/>
+            <a:ext cx="1719072" cy="274320"/>
           </a:xfrm>
           <a:prstGeom prst="rect">
             <a:avLst/>
@@ -28527,27 +29038,151 @@
               <a:buNone/>
             </a:pPr>
             <a:r>
-              <a:rPr lang="en-US" sz="2000" b="1" dirty="0">
+              <a:rPr lang="en-US" sz="1700" b="1" dirty="0">
                 <a:solidFill>
                   <a:schemeClr val="accent3"/>
                 </a:solidFill>
               </a:rPr>
-              <a:t>497</a:t>
-            </a:r>
-            <a:endParaRPr lang="en-US" sz="2000" dirty="0"/>
+              <a:t>~22</a:t>
+            </a:r>
+            <a:endParaRPr lang="en-US" sz="1700" dirty="0"/>
           </a:p>
         </p:txBody>
       </p:sp>
       <p:sp>
         <p:nvSpPr>
-          <p:cNvPr id="35" name="kernel stat label 99"/>
+          <p:cNvPr id="37" name="kernel stat label 101"/>
           <p:cNvSpPr txBox="1"/>
           <p:nvPr/>
         </p:nvSpPr>
         <p:spPr>
           <a:xfrm>
-            <a:off x="7205472" y="2212848"/>
-            <a:ext cx="1335024" cy="457200"/>
+            <a:off x="4754880" y="3191256"/>
+            <a:ext cx="1719072" cy="274320"/>
+          </a:xfrm>
+          <a:prstGeom prst="rect">
+            <a:avLst/>
+          </a:prstGeom>
+          <a:noFill/>
+          <a:ln/>
+        </p:spPr>
+        <p:txBody>
+          <a:bodyPr wrap="square" lIns="0" tIns="0" rIns="0" bIns="0" rtlCol="0" anchor="t"/>
+          <a:lstStyle/>
+          <a:p>
+            <a:pPr indent="0" marL="0">
+              <a:buNone/>
+            </a:pPr>
+            <a:r>
+              <a:rPr lang="en-US" sz="1000" dirty="0">
+                <a:solidFill>
+                  <a:schemeClr val="tx1"/>
+                </a:solidFill>
+              </a:rPr>
+              <a:t>irreducible primitives</a:t>
+            </a:r>
+            <a:endParaRPr lang="en-US" sz="1000" dirty="0"/>
+          </a:p>
+        </p:txBody>
+      </p:sp>
+      <p:sp>
+        <p:nvSpPr>
+          <p:cNvPr id="38" name="kernel blurb 102"/>
+          <p:cNvSpPr txBox="1"/>
+          <p:nvPr/>
+        </p:nvSpPr>
+        <p:spPr>
+          <a:xfrm>
+            <a:off x="4754880" y="3520440"/>
+            <a:ext cx="1719072" cy="685800"/>
+          </a:xfrm>
+          <a:prstGeom prst="rect">
+            <a:avLst/>
+          </a:prstGeom>
+          <a:noFill/>
+          <a:ln/>
+        </p:spPr>
+        <p:txBody>
+          <a:bodyPr wrap="square" lIns="0" tIns="0" rIns="0" bIns="0" rtlCol="0" anchor="t"/>
+          <a:lstStyle/>
+          <a:p>
+            <a:pPr indent="0" marL="0">
+              <a:buNone/>
+            </a:pPr>
+            <a:r>
+              <a:rPr lang="en-US" sz="1000" dirty="0">
+                <a:solidFill>
+                  <a:schemeClr val="tx1"/>
+                </a:solidFill>
+              </a:rPr>
+              <a:t>Tab 3: :, WORD, FIND, NUMBER, INTERPRET, QUIT are Forth.</a:t>
+            </a:r>
+            <a:endParaRPr lang="en-US" sz="1000" dirty="0"/>
+          </a:p>
+        </p:txBody>
+      </p:sp>
+      <p:sp>
+        <p:nvSpPr>
+          <p:cNvPr id="39" name="kernel card 103"/>
+          <p:cNvSpPr/>
+          <p:nvPr/>
+        </p:nvSpPr>
+        <p:spPr>
+          <a:xfrm>
+            <a:off x="6711696" y="914400"/>
+            <a:ext cx="1975104" cy="3383280"/>
+          </a:xfrm>
+          <a:prstGeom prst="roundRect">
+            <a:avLst>
+              <a:gd name="adj" fmla="val 4630"/>
+            </a:avLst>
+          </a:prstGeom>
+          <a:solidFill>
+            <a:schemeClr val="bg2"/>
+          </a:solidFill>
+          <a:ln w="12700">
+            <a:solidFill>
+              <a:schemeClr val="bg2"/>
+            </a:solidFill>
+            <a:prstDash val="solid"/>
+          </a:ln>
+        </p:spPr>
+      </p:sp>
+      <p:sp>
+        <p:nvSpPr>
+          <p:cNvPr id="40" name="kernel icon 104"/>
+          <p:cNvSpPr/>
+          <p:nvPr/>
+        </p:nvSpPr>
+        <p:spPr>
+          <a:xfrm>
+            <a:off x="6839712" y="1024128"/>
+            <a:ext cx="329184" cy="329184"/>
+          </a:xfrm>
+          <a:prstGeom prst="ellipse">
+            <a:avLst/>
+          </a:prstGeom>
+          <a:solidFill>
+            <a:schemeClr val="accent6"/>
+          </a:solidFill>
+          <a:ln w="12700">
+            <a:solidFill>
+              <a:schemeClr val="accent6"/>
+            </a:solidFill>
+            <a:prstDash val="solid"/>
+          </a:ln>
+        </p:spPr>
+      </p:sp>
+      <p:sp>
+        <p:nvSpPr>
+          <p:cNvPr id="41" name="kernel num 105"/>
+          <p:cNvSpPr txBox="1"/>
+          <p:nvPr/>
+        </p:nvSpPr>
+        <p:spPr>
+          <a:xfrm>
+            <a:off x="6839712" y="1024128"/>
+            <a:ext cx="329184" cy="329184"/>
           </a:xfrm>
           <a:prstGeom prst="rect">
             <a:avLst/>
@@ -28559,31 +29194,31 @@
           <a:bodyPr wrap="square" lIns="0" tIns="0" rIns="0" bIns="0" rtlCol="0" anchor="ctr"/>
           <a:lstStyle/>
           <a:p>
-            <a:pPr indent="0" marL="0">
+            <a:pPr algn="ctr" indent="0" marL="0">
               <a:buNone/>
             </a:pPr>
             <a:r>
-              <a:rPr lang="en-US" sz="1050" dirty="0">
-                <a:solidFill>
-                  <a:schemeClr val="tx1"/>
-                </a:solidFill>
-              </a:rPr>
-              <a:t>lines in 5 core tiers</a:t>
-            </a:r>
-            <a:endParaRPr lang="en-US" sz="1050" dirty="0"/>
+              <a:rPr lang="en-US" sz="1300" b="1" dirty="0">
+                <a:solidFill>
+                  <a:schemeClr val="bg1"/>
+                </a:solidFill>
+              </a:rPr>
+              <a:t>4</a:t>
+            </a:r>
+            <a:endParaRPr lang="en-US" sz="1300" dirty="0"/>
           </a:p>
         </p:txBody>
       </p:sp>
       <p:sp>
         <p:nvSpPr>
-          <p:cNvPr id="36" name="kernel stat 100"/>
+          <p:cNvPr id="42" name="kernel name 106"/>
           <p:cNvSpPr txBox="1"/>
           <p:nvPr/>
         </p:nvSpPr>
         <p:spPr>
           <a:xfrm>
-            <a:off x="6181344" y="2779776"/>
-            <a:ext cx="1005840" cy="457200"/>
+            <a:off x="7242048" y="1005840"/>
+            <a:ext cx="1371600" cy="365760"/>
           </a:xfrm>
           <a:prstGeom prst="rect">
             <a:avLst/>
@@ -28599,27 +29234,27 @@
               <a:buNone/>
             </a:pPr>
             <a:r>
-              <a:rPr lang="en-US" sz="2000" b="1" dirty="0">
-                <a:solidFill>
-                  <a:schemeClr val="accent3"/>
-                </a:solidFill>
-              </a:rPr>
-              <a:t>~22</a:t>
-            </a:r>
-            <a:endParaRPr lang="en-US" sz="2000" dirty="0"/>
+              <a:rPr lang="en-US" sz="1250" b="1" dirty="0">
+                <a:solidFill>
+                  <a:schemeClr val="tx1"/>
+                </a:solidFill>
+              </a:rPr>
+              <a:t>forth-from-forth</a:t>
+            </a:r>
+            <a:endParaRPr lang="en-US" sz="1250" dirty="0"/>
           </a:p>
         </p:txBody>
       </p:sp>
       <p:sp>
         <p:nvSpPr>
-          <p:cNvPr id="37" name="kernel stat label 101"/>
+          <p:cNvPr id="43" name="kernel tag 107"/>
           <p:cNvSpPr txBox="1"/>
           <p:nvPr/>
         </p:nvSpPr>
         <p:spPr>
           <a:xfrm>
-            <a:off x="7205472" y="2779776"/>
-            <a:ext cx="1335024" cy="457200"/>
+            <a:off x="6839712" y="1417320"/>
+            <a:ext cx="1719072" cy="274320"/>
           </a:xfrm>
           <a:prstGeom prst="rect">
             <a:avLst/>
@@ -28635,27 +29270,63 @@
               <a:buNone/>
             </a:pPr>
             <a:r>
-              <a:rPr lang="en-US" sz="1050" dirty="0">
+              <a:rPr lang="en-US" sz="1000" i="1" dirty="0">
                 <a:solidFill>
                   <a:schemeClr val="tx1"/>
                 </a:solidFill>
               </a:rPr>
-              <a:t>irreducible primitives, 82 colon words</a:t>
-            </a:r>
-            <a:endParaRPr lang="en-US" sz="1050" dirty="0"/>
+              <a:t>Dictionary compiled by Forth</a:t>
+            </a:r>
+            <a:endParaRPr lang="en-US" sz="1000" dirty="0"/>
           </a:p>
         </p:txBody>
       </p:sp>
       <p:sp>
         <p:nvSpPr>
-          <p:cNvPr id="38" name="kernel blurb 102"/>
+          <p:cNvPr id="44" name="kernel stat 108"/>
           <p:cNvSpPr txBox="1"/>
           <p:nvPr/>
         </p:nvSpPr>
         <p:spPr>
           <a:xfrm>
-            <a:off x="6181344" y="3383280"/>
-            <a:ext cx="2359152" cy="713232"/>
+            <a:off x="6839712" y="1783080"/>
+            <a:ext cx="1719072" cy="274320"/>
+          </a:xfrm>
+          <a:prstGeom prst="rect">
+            <a:avLst/>
+          </a:prstGeom>
+          <a:noFill/>
+          <a:ln/>
+        </p:spPr>
+        <p:txBody>
+          <a:bodyPr wrap="square" lIns="0" tIns="0" rIns="0" bIns="0" rtlCol="0" anchor="ctr"/>
+          <a:lstStyle/>
+          <a:p>
+            <a:pPr indent="0" marL="0">
+              <a:buNone/>
+            </a:pPr>
+            <a:r>
+              <a:rPr lang="en-US" sz="1700" b="1" dirty="0">
+                <a:solidFill>
+                  <a:schemeClr val="accent6"/>
+                </a:solidFill>
+              </a:rPr>
+              <a:t>83</a:t>
+            </a:r>
+            <a:endParaRPr lang="en-US" sz="1700" dirty="0"/>
+          </a:p>
+        </p:txBody>
+      </p:sp>
+      <p:sp>
+        <p:nvSpPr>
+          <p:cNvPr id="45" name="kernel stat label 109"/>
+          <p:cNvSpPr txBox="1"/>
+          <p:nvPr/>
+        </p:nvSpPr>
+        <p:spPr>
+          <a:xfrm>
+            <a:off x="6839712" y="2057400"/>
+            <a:ext cx="1719072" cy="274320"/>
           </a:xfrm>
           <a:prstGeom prst="rect">
             <a:avLst/>
@@ -28671,27 +29342,27 @@
               <a:buNone/>
             </a:pPr>
             <a:r>
-              <a:rPr lang="en-US" sz="1050" dirty="0">
+              <a:rPr lang="en-US" sz="1000" dirty="0">
                 <a:solidFill>
                   <a:schemeClr val="tx1"/>
                 </a:solidFill>
               </a:rPr>
-              <a:t>Tab 3 (default): :, WORD, FIND, NUMBER, INTERPRET, QUIT are Forth.</a:t>
-            </a:r>
-            <a:endParaRPr lang="en-US" sz="1050" dirty="0"/>
+              <a:t>definitions cross-compiled</a:t>
+            </a:r>
+            <a:endParaRPr lang="en-US" sz="1000" dirty="0"/>
           </a:p>
         </p:txBody>
       </p:sp>
       <p:sp>
         <p:nvSpPr>
-          <p:cNvPr id="39" name="phase 4 note"/>
+          <p:cNvPr id="46" name="kernel stat 110"/>
           <p:cNvSpPr txBox="1"/>
           <p:nvPr/>
         </p:nvSpPr>
         <p:spPr>
           <a:xfrm>
-            <a:off x="457200" y="4297680"/>
-            <a:ext cx="8229600" cy="411480"/>
+            <a:off x="6839712" y="2350008"/>
+            <a:ext cx="1719072" cy="274320"/>
           </a:xfrm>
           <a:prstGeom prst="rect">
             <a:avLst/>
@@ -28707,14 +29378,194 @@
               <a:buNone/>
             </a:pPr>
             <a:r>
-              <a:rPr lang="en-US" sz="1100" dirty="0">
+              <a:rPr lang="en-US" sz="1700" b="1" dirty="0">
+                <a:solidFill>
+                  <a:schemeClr val="accent6"/>
+                </a:solidFill>
+              </a:rPr>
+              <a:t>4,060</a:t>
+            </a:r>
+            <a:endParaRPr lang="en-US" sz="1700" dirty="0"/>
+          </a:p>
+        </p:txBody>
+      </p:sp>
+      <p:sp>
+        <p:nvSpPr>
+          <p:cNvPr id="47" name="kernel stat label 111"/>
+          <p:cNvSpPr txBox="1"/>
+          <p:nvPr/>
+        </p:nvSpPr>
+        <p:spPr>
+          <a:xfrm>
+            <a:off x="6839712" y="2624328"/>
+            <a:ext cx="1719072" cy="274320"/>
+          </a:xfrm>
+          <a:prstGeom prst="rect">
+            <a:avLst/>
+          </a:prstGeom>
+          <a:noFill/>
+          <a:ln/>
+        </p:spPr>
+        <p:txBody>
+          <a:bodyPr wrap="square" lIns="0" tIns="0" rIns="0" bIns="0" rtlCol="0" anchor="t"/>
+          <a:lstStyle/>
+          <a:p>
+            <a:pPr indent="0" marL="0">
+              <a:buNone/>
+            </a:pPr>
+            <a:r>
+              <a:rPr lang="en-US" sz="1000" dirty="0">
+                <a:solidFill>
+                  <a:schemeClr val="tx1"/>
+                </a:solidFill>
+              </a:rPr>
+              <a:t>lines of generated kernel.s</a:t>
+            </a:r>
+            <a:endParaRPr lang="en-US" sz="1000" dirty="0"/>
+          </a:p>
+        </p:txBody>
+      </p:sp>
+      <p:sp>
+        <p:nvSpPr>
+          <p:cNvPr id="48" name="kernel stat 112"/>
+          <p:cNvSpPr txBox="1"/>
+          <p:nvPr/>
+        </p:nvSpPr>
+        <p:spPr>
+          <a:xfrm>
+            <a:off x="6839712" y="2916936"/>
+            <a:ext cx="1719072" cy="274320"/>
+          </a:xfrm>
+          <a:prstGeom prst="rect">
+            <a:avLst/>
+          </a:prstGeom>
+          <a:noFill/>
+          <a:ln/>
+        </p:spPr>
+        <p:txBody>
+          <a:bodyPr wrap="square" lIns="0" tIns="0" rIns="0" bIns="0" rtlCol="0" anchor="ctr"/>
+          <a:lstStyle/>
+          <a:p>
+            <a:pPr indent="0" marL="0">
+              <a:buNone/>
+            </a:pPr>
+            <a:r>
+              <a:rPr lang="en-US" sz="1700" b="1" dirty="0">
+                <a:solidFill>
+                  <a:schemeClr val="accent6"/>
+                </a:solidFill>
+              </a:rPr>
+              <a:t>0.7 M</a:t>
+            </a:r>
+            <a:endParaRPr lang="en-US" sz="1700" dirty="0"/>
+          </a:p>
+        </p:txBody>
+      </p:sp>
+      <p:sp>
+        <p:nvSpPr>
+          <p:cNvPr id="49" name="kernel stat label 113"/>
+          <p:cNvSpPr txBox="1"/>
+          <p:nvPr/>
+        </p:nvSpPr>
+        <p:spPr>
+          <a:xfrm>
+            <a:off x="6839712" y="3191256"/>
+            <a:ext cx="1719072" cy="274320"/>
+          </a:xfrm>
+          <a:prstGeom prst="rect">
+            <a:avLst/>
+          </a:prstGeom>
+          <a:noFill/>
+          <a:ln/>
+        </p:spPr>
+        <p:txBody>
+          <a:bodyPr wrap="square" lIns="0" tIns="0" rIns="0" bIns="0" rtlCol="0" anchor="t"/>
+          <a:lstStyle/>
+          <a:p>
+            <a:pPr indent="0" marL="0">
+              <a:buNone/>
+            </a:pPr>
+            <a:r>
+              <a:rPr lang="en-US" sz="1000" dirty="0">
+                <a:solidFill>
+                  <a:schemeClr val="tx1"/>
+                </a:solidFill>
+              </a:rPr>
+              <a:t>instructions to first output</a:t>
+            </a:r>
+            <a:endParaRPr lang="en-US" sz="1000" dirty="0"/>
+          </a:p>
+        </p:txBody>
+      </p:sp>
+      <p:sp>
+        <p:nvSpPr>
+          <p:cNvPr id="50" name="kernel blurb 114"/>
+          <p:cNvSpPr txBox="1"/>
+          <p:nvPr/>
+        </p:nvSpPr>
+        <p:spPr>
+          <a:xfrm>
+            <a:off x="6839712" y="3520440"/>
+            <a:ext cx="1719072" cy="685800"/>
+          </a:xfrm>
+          <a:prstGeom prst="rect">
+            <a:avLst/>
+          </a:prstGeom>
+          <a:noFill/>
+          <a:ln/>
+        </p:spPr>
+        <p:txBody>
+          <a:bodyPr wrap="square" lIns="0" tIns="0" rIns="0" bIns="0" rtlCol="0" anchor="t"/>
+          <a:lstStyle/>
+          <a:p>
+            <a:pPr indent="0" marL="0">
+              <a:buNone/>
+            </a:pPr>
+            <a:r>
+              <a:rPr lang="en-US" sz="1000" dirty="0">
+                <a:solidFill>
+                  <a:schemeClr val="tx1"/>
+                </a:solidFill>
+              </a:rPr>
+              <a:t>Tab 4 (default): nothing streams at boot; tab 3 needs 150 M.</a:t>
+            </a:r>
+            <a:endParaRPr lang="en-US" sz="1000" dirty="0"/>
+          </a:p>
+        </p:txBody>
+      </p:sp>
+      <p:sp>
+        <p:nvSpPr>
+          <p:cNvPr id="51" name="phase 4 note"/>
+          <p:cNvSpPr txBox="1"/>
+          <p:nvPr/>
+        </p:nvSpPr>
+        <p:spPr>
+          <a:xfrm>
+            <a:off x="457200" y="4389120"/>
+            <a:ext cx="8229600" cy="365760"/>
+          </a:xfrm>
+          <a:prstGeom prst="rect">
+            <a:avLst/>
+          </a:prstGeom>
+          <a:noFill/>
+          <a:ln/>
+        </p:spPr>
+        <p:txBody>
+          <a:bodyPr wrap="square" lIns="0" tIns="0" rIns="0" bIns="0" rtlCol="0" anchor="ctr"/>
+          <a:lstStyle/>
+          <a:p>
+            <a:pPr indent="0" marL="0">
+              <a:buNone/>
+            </a:pPr>
+            <a:r>
+              <a:rPr lang="en-US" sz="1050" dirty="0">
                 <a:solidFill>
                   <a:schemeClr val="accent2"/>
                 </a:solidFill>
               </a:rPr>
-              <a:t>4  forth-from-forth (phase 4, work in progress, two slides on): a cross-compiler written in Forth emits the kernel .s, so no hand-written assembly remains. Retargeting becomes a new asm-emit module.</a:t>
-            </a:r>
-            <a:endParaRPr lang="en-US" sz="1100" dirty="0"/>
+              <a:t>Tab 4's primitives still come from tab 3's hand-written assembly; the dictionary on top of them is generated. Emitting the primitives from Forth too is the next step.</a:t>
+            </a:r>
+            <a:endParaRPr lang="en-US" sz="1050" dirty="0"/>
           </a:p>
         </p:txBody>
       </p:sp>

</xml_diff>

<commit_message>
feat: tab 4 help says the kernel is all Forth and a fixed point; deck updated
Co-Authored-By: Claude Opus 5.5 <noreply@anthropic.com>
</commit_message>
<xml_diff>
--- a/docs/forth-on-cor24.pptx
+++ b/docs/forth-on-cor24.pptx
@@ -128,13 +128,13 @@
   <p:extLst>
     <p:ext uri="{521415D9-36F7-43E2-AB2F-B90AF26B5E84}">
       <p14:sectionLst xmlns:p14="http://schemas.microsoft.com/office/powerpoint/2010/main">
-        <p14:section name="Intro" id="{a39012f4-56b8-3259-85e7-51be84849491}">
+        <p14:section name="Intro" id="{cf4b88e5-80cf-d8a8-730c-0ff2bd0d2fa1}">
           <p14:sldIdLst>
             <p14:sldId id="256"/>
             <p14:sldId id="257"/>
           </p14:sldIdLst>
         </p14:section>
-        <p14:section name="The target" id="{5ddff025-cd3c-07ba-88f2-8e4ef95314d9}">
+        <p14:section name="The target" id="{46c9adf6-44b8-3462-f982-5751b71683ef}">
           <p14:sldIdLst>
             <p14:sldId id="258"/>
             <p14:sldId id="259"/>
@@ -143,7 +143,7 @@
             <p14:sldId id="262"/>
           </p14:sldIdLst>
         </p14:section>
-        <p14:section name="Implementations" id="{daccbc34-c375-50d5-d73e-86c4fd1de0bc}">
+        <p14:section name="Implementations" id="{983ef46c-4e90-5f9d-2271-04f4e9671643}">
           <p14:sldIdLst>
             <p14:sldId id="263"/>
             <p14:sldId id="264"/>
@@ -156,14 +156,14 @@
             <p14:sldId id="271"/>
           </p14:sldIdLst>
         </p14:section>
-        <p14:section name="Demos" id="{1d37f474-3b8a-4177-7c89-3688c8f68361}">
+        <p14:section name="Demos" id="{892b03e9-5c6c-06a0-1f64-3421a81a7b94}">
           <p14:sldIdLst>
             <p14:sldId id="272"/>
             <p14:sldId id="273"/>
             <p14:sldId id="274"/>
           </p14:sldIdLst>
         </p14:section>
-        <p14:section name="Working with words" id="{11650ce8-1349-ad9c-3b82-47ccefd78af7}">
+        <p14:section name="Working with words" id="{f74b8d75-cec8-09b8-3466-b30f577d58e7}">
           <p14:sldIdLst>
             <p14:sldId id="275"/>
             <p14:sldId id="276"/>
@@ -7236,7 +7236,7 @@
                   <a:schemeClr val="bg1"/>
                 </a:solidFill>
               </a:rPr>
-              <a:t>xcomp.fth + prims.fth</a:t>
+              <a:t>xcomp.fth + prims-asm.fth</a:t>
             </a:r>
             <a:endParaRPr lang="en-US" sz="1000" dirty="0"/>
           </a:p>
@@ -7250,7 +7250,7 @@
                   <a:schemeClr val="bg1"/>
                 </a:solidFill>
               </a:rPr>
-              <a:t>(the compiler, in Forth)</a:t>
+              <a:t>(compiler + primitives, Forth)</a:t>
             </a:r>
             <a:endParaRPr lang="en-US" sz="1000" dirty="0"/>
           </a:p>
@@ -7440,7 +7440,7 @@
                   <a:schemeClr val="bg1"/>
                 </a:solidFill>
               </a:rPr>
-              <a:t>runs on tab 3's kernel,</a:t>
+              <a:t>runs on tab 3's kernel or</a:t>
             </a:r>
             <a:endParaRPr lang="en-US" sz="1000" dirty="0"/>
           </a:p>
@@ -7454,7 +7454,7 @@
                   <a:schemeClr val="bg1"/>
                 </a:solidFill>
               </a:rPr>
-              <a:t>asm text out the UART</a:t>
+              <a:t>tab 4's own; asm text out</a:t>
             </a:r>
             <a:endParaRPr lang="en-US" sz="1000" dirty="0"/>
           </a:p>
@@ -7961,7 +7961,7 @@
                   <a:schemeClr val="tx1"/>
                 </a:solidFill>
               </a:rPr>
-              <a:t>Next: the primitives themselves from core/prims.fth.</a:t>
+              <a:t>Since 10-24 the primitives are Forth too (an assembler vocabulary), and the kernel rebuilds itself to the same bytes: a fixed point.</a:t>
             </a:r>
             <a:endParaRPr lang="en-US" sz="1000" dirty="0"/>
           </a:p>
@@ -10838,7 +10838,7 @@
                           <a:ea typeface="Calibri" pitchFamily="34" charset="-122"/>
                           <a:cs typeface="Calibri" pitchFamily="34" charset="-120"/>
                         </a:rPr>
-                        <a:t>the primitives only; dictionary generated</a:t>
+                        <a:t>none as .s: primitives in a Forth assembler vocabulary</a:t>
                       </a:r>
                       <a:endParaRPr lang="en-US" sz="1000" dirty="0">
                         <a:latin typeface="Calibri" charset="0"/>
@@ -29275,7 +29275,7 @@
                   <a:schemeClr val="tx1"/>
                 </a:solidFill>
               </a:rPr>
-              <a:t>Dictionary compiled by Forth</a:t>
+              <a:t>Kernel compiled by Forth</a:t>
             </a:r>
             <a:endParaRPr lang="en-US" sz="1000" dirty="0"/>
           </a:p>
@@ -29383,7 +29383,7 @@
                   <a:schemeClr val="accent6"/>
                 </a:solidFill>
               </a:rPr>
-              <a:t>4,060</a:t>
+              <a:t>3,917</a:t>
             </a:r>
             <a:endParaRPr lang="en-US" sz="1700" dirty="0"/>
           </a:p>
@@ -29419,7 +29419,7 @@
                   <a:schemeClr val="tx1"/>
                 </a:solidFill>
               </a:rPr>
-              <a:t>lines of generated kernel.s</a:t>
+              <a:t>lines of kernel.s, all from Forth</a:t>
             </a:r>
             <a:endParaRPr lang="en-US" sz="1000" dirty="0"/>
           </a:p>
@@ -29563,7 +29563,7 @@
                   <a:schemeClr val="accent2"/>
                 </a:solidFill>
               </a:rPr>
-              <a:t>Tab 4's primitives still come from tab 3's hand-written assembly; the dictionary on top of them is generated. Emitting the primitives from Forth too is the next step.</a:t>
+              <a:t>Tab 4's kernel.s is generated entirely from Forth, primitives included, and reproduces itself: run on tab 4's own kernel, the compiler emits the same kernel.s byte for byte.</a:t>
             </a:r>
             <a:endParaRPr lang="en-US" sz="1050" dirty="0"/>
           </a:p>

</xml_diff>

<commit_message>
feat: tab 4 Rebuild kernel button; kernel without the FIND hash
- src/rebuild.rs (no Yew): the rebuild input (xcomp.fth, prims.fth,
  prims-asm.fth and the core tiers from sw-cor24-forth/forth-from-forth),
  extraction of the printed kernel.s, and the comparison with the running
  kernel, text and bytes.
- Tab 4's toolbar gets Rebuild kernel: the input is queued to the running
  kernel, the pump runs in turbo (boot-sized budget), the ~4,000 lines of
  assembly go to a buffer, the status line shows progress, and the verdict
  is printed with time and instruction count.
- tests: tab4_rebuilds_its_own_kernel runs the same path headlessly and
  requires an identical kernel; boot_cost.rs (ignored) measures real
  per-kernel work.
- Tab 4 help: boot ~100 instructions (tab 3 ~10 M), 7,098 bytes, no hash.

Co-Authored-By: Claude Opus 5.5 <noreply@anthropic.com>
</commit_message>
<xml_diff>
--- a/docs/forth-on-cor24.pptx
+++ b/docs/forth-on-cor24.pptx
@@ -128,13 +128,13 @@
   <p:extLst>
     <p:ext uri="{521415D9-36F7-43E2-AB2F-B90AF26B5E84}">
       <p14:sectionLst xmlns:p14="http://schemas.microsoft.com/office/powerpoint/2010/main">
-        <p14:section name="Intro" id="{cf4b88e5-80cf-d8a8-730c-0ff2bd0d2fa1}">
+        <p14:section name="Intro" id="{e294a457-eed2-c760-1c83-ceaa97ae7d9a}">
           <p14:sldIdLst>
             <p14:sldId id="256"/>
             <p14:sldId id="257"/>
           </p14:sldIdLst>
         </p14:section>
-        <p14:section name="The target" id="{46c9adf6-44b8-3462-f982-5751b71683ef}">
+        <p14:section name="The target" id="{140a37a3-7095-7b63-4e58-554932034a82}">
           <p14:sldIdLst>
             <p14:sldId id="258"/>
             <p14:sldId id="259"/>
@@ -143,7 +143,7 @@
             <p14:sldId id="262"/>
           </p14:sldIdLst>
         </p14:section>
-        <p14:section name="Implementations" id="{983ef46c-4e90-5f9d-2271-04f4e9671643}">
+        <p14:section name="Implementations" id="{fb68603a-a34e-9465-f5ad-b50f48563d7f}">
           <p14:sldIdLst>
             <p14:sldId id="263"/>
             <p14:sldId id="264"/>
@@ -156,14 +156,14 @@
             <p14:sldId id="271"/>
           </p14:sldIdLst>
         </p14:section>
-        <p14:section name="Demos" id="{892b03e9-5c6c-06a0-1f64-3421a81a7b94}">
+        <p14:section name="Demos" id="{e2dafcd4-e674-982b-61ce-47891599a23d}">
           <p14:sldIdLst>
             <p14:sldId id="272"/>
             <p14:sldId id="273"/>
             <p14:sldId id="274"/>
           </p14:sldIdLst>
         </p14:section>
-        <p14:section name="Working with words" id="{f74b8d75-cec8-09b8-3466-b30f577d58e7}">
+        <p14:section name="Working with words" id="{576baf3b-0fff-0aa1-1d7e-6bab169968e2}">
           <p14:sldIdLst>
             <p14:sldId id="275"/>
             <p14:sldId id="276"/>
@@ -7907,7 +7907,7 @@
                   <a:schemeClr val="tx1"/>
                 </a:solidFill>
               </a:rPr>
-              <a:t>Boot: first output after 0.71 M instructions against 149.56 M for tab 3, which streams and compiles its core first.</a:t>
+              <a:t>Boot to the prompt: about 100 instructions, against 10.2 M for tab 3, which compiles its core from text first.</a:t>
             </a:r>
             <a:endParaRPr lang="en-US" sz="1000" dirty="0"/>
           </a:p>
@@ -7925,7 +7925,7 @@
                   <a:schemeClr val="tx1"/>
                 </a:solidFill>
               </a:rPr>
-              <a:t>A reachability pass removes the asm bootstrap (INTERPRET, QUIT, NUMBER, WORD, FIND, : ; [']): 9,450 → 8,168 bytes.</a:t>
+              <a:t>Gone: the asm bootstrap (INTERPRET, QUIT, NUMBER, WORD, FIND, : ; [']) and the FIND hash table: 9,450 → 7,098 bytes.</a:t>
             </a:r>
             <a:endParaRPr lang="en-US" sz="1000" dirty="0"/>
           </a:p>
@@ -7961,7 +7961,7 @@
                   <a:schemeClr val="tx1"/>
                 </a:solidFill>
               </a:rPr>
-              <a:t>Since 10-24 the primitives are Forth too (an assembler vocabulary), and the kernel rebuilds itself to the same bytes: a fixed point.</a:t>
+              <a:t>The primitives are Forth too, and the kernel rebuilds itself to the same bytes, a fixed point; tab 4's Rebuild kernel button does it in the browser.</a:t>
             </a:r>
             <a:endParaRPr lang="en-US" sz="1000" dirty="0"/>
           </a:p>
@@ -8853,7 +8853,7 @@
                           <a:ea typeface="Calibri" pitchFamily="34" charset="-122"/>
                           <a:cs typeface="Calibri" pitchFamily="34" charset="-120"/>
                         </a:rPr>
-                        <a:t>First output at</a:t>
+                        <a:t>Boot: real work</a:t>
                       </a:r>
                       <a:endParaRPr lang="en-US" sz="1000" dirty="0">
                         <a:latin typeface="Calibri" charset="0"/>
@@ -9056,7 +9056,7 @@
                           <a:ea typeface="Calibri" pitchFamily="34" charset="-122"/>
                           <a:cs typeface="Calibri" pitchFamily="34" charset="-120"/>
                         </a:rPr>
-                        <a:t>80 k</a:t>
+                        <a:t>~100</a:t>
                       </a:r>
                       <a:endParaRPr lang="en-US" sz="1000" dirty="0">
                         <a:latin typeface="Calibri" charset="0"/>
@@ -9253,7 +9253,7 @@
                           <a:ea typeface="Calibri" pitchFamily="34" charset="-122"/>
                           <a:cs typeface="Calibri" pitchFamily="34" charset="-120"/>
                         </a:rPr>
-                        <a:t>0.71 M</a:t>
+                        <a:t>~100</a:t>
                       </a:r>
                       <a:endParaRPr lang="en-US" sz="1000" dirty="0">
                         <a:latin typeface="Calibri" charset="0"/>
@@ -9450,7 +9450,7 @@
                           <a:ea typeface="Calibri" pitchFamily="34" charset="-122"/>
                           <a:cs typeface="Calibri" pitchFamily="34" charset="-120"/>
                         </a:rPr>
-                        <a:t>87 M</a:t>
+                        <a:t>1.74 M</a:t>
                       </a:r>
                       <a:endParaRPr lang="en-US" sz="1000" dirty="0">
                         <a:latin typeface="Calibri" charset="0"/>
@@ -9647,7 +9647,7 @@
                           <a:ea typeface="Calibri" pitchFamily="34" charset="-122"/>
                           <a:cs typeface="Calibri" pitchFamily="34" charset="-120"/>
                         </a:rPr>
-                        <a:t>150 M</a:t>
+                        <a:t>10.2 M</a:t>
                       </a:r>
                       <a:endParaRPr lang="en-US" sz="1000" dirty="0">
                         <a:latin typeface="Calibri" charset="0"/>
@@ -10511,7 +10511,7 @@
                           <a:ea typeface="Calibri" pitchFamily="34" charset="-122"/>
                           <a:cs typeface="Calibri" pitchFamily="34" charset="-120"/>
                         </a:rPr>
-                        <a:t>as tab 3, but boot ~200× less work</a:t>
+                        <a:t>as tab 3 per line; boot ~100 instructions</a:t>
                       </a:r>
                       <a:endParaRPr lang="en-US" sz="1000" dirty="0">
                         <a:latin typeface="Calibri" charset="0"/>
@@ -29383,7 +29383,7 @@
                   <a:schemeClr val="accent6"/>
                 </a:solidFill>
               </a:rPr>
-              <a:t>3,917</a:t>
+              <a:t>3,508</a:t>
             </a:r>
             <a:endParaRPr lang="en-US" sz="1700" dirty="0"/>
           </a:p>
@@ -29455,7 +29455,7 @@
                   <a:schemeClr val="accent6"/>
                 </a:solidFill>
               </a:rPr>
-              <a:t>0.7 M</a:t>
+              <a:t>~100</a:t>
             </a:r>
             <a:endParaRPr lang="en-US" sz="1700" dirty="0"/>
           </a:p>
@@ -29491,7 +29491,7 @@
                   <a:schemeClr val="tx1"/>
                 </a:solidFill>
               </a:rPr>
-              <a:t>instructions to first output</a:t>
+              <a:t>instructions to boot</a:t>
             </a:r>
             <a:endParaRPr lang="en-US" sz="1000" dirty="0"/>
           </a:p>
@@ -29527,7 +29527,7 @@
                   <a:schemeClr val="tx1"/>
                 </a:solidFill>
               </a:rPr>
-              <a:t>Tab 4 (default): nothing streams at boot; tab 3 needs 150 M.</a:t>
+              <a:t>Tab 4 (default): nothing to compile at boot; tab 3 needs 10 M.</a:t>
             </a:r>
             <a:endParaRPr lang="en-US" sz="1000" dirty="0"/>
           </a:p>

</xml_diff>